<commit_message>
Complete verified step visuals and guides for Lab 04
</commit_message>
<xml_diff>
--- a/slides/LAB04_Docker_Lifecycle_Praktikum.pptx
+++ b/slides/LAB04_Docker_Lifecycle_Praktikum.pptx
@@ -41,6 +41,7 @@
     <p:sldId xmlns:r="http://schemas.openxmlformats.org/officeDocument/2006/relationships" id="286" r:id="R8ae602b867de42e4"/>
     <p:sldId xmlns:r="http://schemas.openxmlformats.org/officeDocument/2006/relationships" id="287" r:id="R7c6814009c124fc2"/>
     <p:sldId xmlns:r="http://schemas.openxmlformats.org/officeDocument/2006/relationships" id="288" r:id="R1ab69cdde7bc4592"/>
+    <p:sldId xmlns:ns0="http://schemas.openxmlformats.org/officeDocument/2006/relationships" id="289" ns0:id="rId39"/>
   </p:sldIdLst>
   <p:sldSz cx="12192000" cy="6858000"/>
   <p:notesSz cx="6858000" cy="9144000"/>
@@ -15662,6 +15663,420 @@
 </p:sld>
 </file>
 
+<file path=ppt/slides/slide34.xml><?xml version="1.0" encoding="utf-8"?>
+<p:sld xmlns:a="http://schemas.openxmlformats.org/drawingml/2006/main" xmlns:p="http://schemas.openxmlformats.org/presentationml/2006/main" xmlns:r="http://schemas.openxmlformats.org/officeDocument/2006/relationships">
+  <p:cSld>
+    <p:spTree>
+      <p:nvGrpSpPr>
+        <p:cNvPr id="1" name=""/>
+        <p:cNvGrpSpPr/>
+        <p:nvPr/>
+      </p:nvGrpSpPr>
+      <p:grpSpPr/>
+      <p:sp>
+        <p:nvSpPr>
+          <p:cNvPr id="7" name="section">
+            <a:extLst>
+              <a:ext uri="{FF2B5EF4-FFF2-40B4-BE49-F238E27FC236}">
+                <a16:creationId xmlns:a16="http://schemas.microsoft.com/office/drawing/2014/main" id="{8AB038A4-485E-4E1A-8EA7-A13497461296}"/>
+              </a:ext>
+            </a:extLst>
+          </p:cNvPr>
+          <p:cNvSpPr>
+            <a:spLocks noGrp="1"/>
+          </p:cNvSpPr>
+          <p:nvPr/>
+        </p:nvSpPr>
+        <p:spPr>
+          <a:xfrm>
+            <a:off x="685800" y="295275"/>
+            <a:ext cx="7620000" cy="228600"/>
+          </a:xfrm>
+          <a:prstGeom prst="rect">
+            <a:avLst/>
+          </a:prstGeom>
+          <a:noFill/>
+          <a:ln w="0">
+            <a:noFill/>
+          </a:ln>
+        </p:spPr>
+        <p:txBody>
+          <a:bodyPr wrap="square" lIns="0" tIns="0" rIns="0" bIns="0" anchor="t">
+            <a:normAutofit fontScale="100000"/>
+          </a:bodyPr>
+          <a:lstStyle/>
+          <a:p>
+            <a:pPr>
+              <a:defRPr sz="1350" b="1">
+                <a:solidFill>
+                  <a:srgbClr val="F37021"/>
+                </a:solidFill>
+                <a:latin typeface="Calibri"/>
+                <a:ea typeface="Calibri"/>
+                <a:cs typeface="Calibri"/>
+              </a:defRPr>
+            </a:pPr>
+            <a:r>
+              <a:rPr sz="1350" b="1">
+                <a:solidFill>
+                  <a:srgbClr val="F37021"/>
+                </a:solidFill>
+                <a:latin typeface="Calibri"/>
+                <a:ea typeface="Calibri"/>
+                <a:cs typeface="Calibri"/>
+              </a:rPr>
+              <a:t>PRAKTIKUM 04</a:t>
+            </a:r>
+          </a:p>
+        </p:txBody>
+      </p:sp>
+      <p:sp>
+        <p:nvSpPr>
+          <p:cNvPr id="2" name="title">
+            <a:extLst>
+              <a:ext uri="{FF2B5EF4-FFF2-40B4-BE49-F238E27FC236}">
+                <a16:creationId xmlns:a16="http://schemas.microsoft.com/office/drawing/2014/main" id="{91FF576F-51DB-4D3D-BA37-0B58A7B6CC93}"/>
+              </a:ext>
+            </a:extLst>
+          </p:cNvPr>
+          <p:cNvSpPr>
+            <a:spLocks noGrp="1"/>
+          </p:cNvSpPr>
+          <p:nvPr/>
+        </p:nvSpPr>
+        <p:spPr>
+          <a:xfrm>
+            <a:off x="685800" y="619125"/>
+            <a:ext cx="10820400" cy="742950"/>
+          </a:xfrm>
+          <a:prstGeom prst="rect">
+            <a:avLst/>
+          </a:prstGeom>
+          <a:noFill/>
+          <a:ln w="0">
+            <a:noFill/>
+          </a:ln>
+        </p:spPr>
+        <p:txBody>
+          <a:bodyPr wrap="square" lIns="0" tIns="0" rIns="0" bIns="0" anchor="t">
+            <a:normAutofit fontScale="100000"/>
+          </a:bodyPr>
+          <a:lstStyle/>
+          <a:p>
+            <a:pPr>
+              <a:defRPr sz="3150" b="1">
+                <a:solidFill>
+                  <a:srgbClr val="002677"/>
+                </a:solidFill>
+                <a:latin typeface="Calibri"/>
+                <a:ea typeface="Calibri"/>
+                <a:cs typeface="Calibri"/>
+              </a:defRPr>
+            </a:pPr>
+            <a:r>
+              <a:rPr sz="3150" b="1">
+                <a:solidFill>
+                  <a:srgbClr val="002677"/>
+                </a:solidFill>
+                <a:latin typeface="Calibri"/>
+                <a:ea typeface="Calibri"/>
+                <a:cs typeface="Calibri"/>
+              </a:rPr>
+              <a:t>Bukti Git: commit dan modul tersedia</a:t>
+            </a:r>
+          </a:p>
+        </p:txBody>
+      </p:sp>
+      <p:sp>
+        <p:nvSpPr>
+          <p:cNvPr id="3" name="subtitle">
+            <a:extLst>
+              <a:ext uri="{FF2B5EF4-FFF2-40B4-BE49-F238E27FC236}">
+                <a16:creationId xmlns:a16="http://schemas.microsoft.com/office/drawing/2014/main" id="{EFA20D18-3AFC-49C5-BDA1-9BC7214D00B4}"/>
+              </a:ext>
+            </a:extLst>
+          </p:cNvPr>
+          <p:cNvSpPr>
+            <a:spLocks noGrp="1"/>
+          </p:cNvSpPr>
+          <p:nvPr/>
+        </p:nvSpPr>
+        <p:spPr>
+          <a:xfrm>
+            <a:off x="685800" y="1362075"/>
+            <a:ext cx="10820400" cy="438150"/>
+          </a:xfrm>
+          <a:prstGeom prst="rect">
+            <a:avLst/>
+          </a:prstGeom>
+          <a:noFill/>
+          <a:ln w="0">
+            <a:noFill/>
+          </a:ln>
+        </p:spPr>
+        <p:txBody>
+          <a:bodyPr wrap="square" lIns="0" tIns="0" rIns="0" bIns="0" anchor="t">
+            <a:normAutofit fontScale="100000"/>
+          </a:bodyPr>
+          <a:lstStyle/>
+          <a:p>
+            <a:pPr>
+              <a:defRPr sz="1725" b="0">
+                <a:solidFill>
+                  <a:srgbClr val="475569"/>
+                </a:solidFill>
+                <a:latin typeface="Calibri"/>
+                <a:ea typeface="Calibri"/>
+                <a:cs typeface="Calibri"/>
+              </a:defRPr>
+            </a:pPr>
+            <a:r>
+              <a:rPr sz="1725" b="0">
+                <a:solidFill>
+                  <a:srgbClr val="475569"/>
+                </a:solidFill>
+                <a:latin typeface="Calibri"/>
+                <a:ea typeface="Calibri"/>
+                <a:cs typeface="Calibri"/>
+              </a:rPr>
+              <a:t>Setelah git push, buka repo pribadi dan periksa commit pada branch main.</a:t>
+            </a:r>
+          </a:p>
+        </p:txBody>
+      </p:sp>
+      <p:sp>
+        <p:nvSpPr>
+          <p:cNvPr id="4" name="page">
+            <a:extLst>
+              <a:ext uri="{FF2B5EF4-FFF2-40B4-BE49-F238E27FC236}">
+                <a16:creationId xmlns:a16="http://schemas.microsoft.com/office/drawing/2014/main" id="{46C0AC1E-CE3B-48DA-BD1F-EB4120B24A2C}"/>
+              </a:ext>
+            </a:extLst>
+          </p:cNvPr>
+          <p:cNvSpPr>
+            <a:spLocks noGrp="1"/>
+          </p:cNvSpPr>
+          <p:nvPr/>
+        </p:nvSpPr>
+        <p:spPr>
+          <a:xfrm>
+            <a:off x="11153775" y="6353175"/>
+            <a:ext cx="361950" cy="209550"/>
+          </a:xfrm>
+          <a:prstGeom prst="rect">
+            <a:avLst/>
+          </a:prstGeom>
+          <a:noFill/>
+          <a:ln w="0">
+            <a:noFill/>
+          </a:ln>
+        </p:spPr>
+        <p:txBody>
+          <a:bodyPr wrap="square" lIns="0" tIns="0" rIns="0" bIns="0" anchor="t">
+            <a:normAutofit fontScale="100000"/>
+          </a:bodyPr>
+          <a:lstStyle/>
+          <a:p>
+            <a:pPr algn="r">
+              <a:defRPr sz="1125" b="0">
+                <a:solidFill>
+                  <a:srgbClr val="475569"/>
+                </a:solidFill>
+                <a:latin typeface="Consolas"/>
+                <a:ea typeface="Consolas"/>
+                <a:cs typeface="Consolas"/>
+              </a:defRPr>
+            </a:pPr>
+            <a:r>
+              <a:rPr sz="1125" b="0">
+                <a:solidFill>
+                  <a:srgbClr val="475569"/>
+                </a:solidFill>
+                <a:latin typeface="Consolas"/>
+                <a:ea typeface="Consolas"/>
+                <a:cs typeface="Consolas"/>
+              </a:rPr>
+              <a:t>34</a:t>
+            </a:r>
+          </a:p>
+        </p:txBody>
+      </p:sp>
+      <p:sp>
+        <p:nvSpPr>
+          <p:cNvPr id="6" name="evidence-final-test-bottom-caption">
+            <a:extLst>
+              <a:ext uri="{FF2B5EF4-FFF2-40B4-BE49-F238E27FC236}">
+                <a16:creationId xmlns:a16="http://schemas.microsoft.com/office/drawing/2014/main" id="{D4371BEE-53D1-466B-AF5C-123D697F8CAB}"/>
+              </a:ext>
+            </a:extLst>
+          </p:cNvPr>
+          <p:cNvSpPr>
+            <a:spLocks noGrp="1"/>
+          </p:cNvSpPr>
+          <p:nvPr/>
+        </p:nvSpPr>
+        <p:spPr>
+          <a:xfrm>
+            <a:off x="685800" y="5705475"/>
+            <a:ext cx="10572750" cy="447675"/>
+          </a:xfrm>
+          <a:prstGeom prst="rect">
+            <a:avLst/>
+          </a:prstGeom>
+          <a:noFill/>
+          <a:ln w="0">
+            <a:noFill/>
+          </a:ln>
+        </p:spPr>
+        <p:txBody>
+          <a:bodyPr wrap="square" lIns="0" tIns="0" rIns="0" bIns="0" anchor="t">
+            <a:normAutofit fontScale="100000"/>
+          </a:bodyPr>
+          <a:lstStyle/>
+          <a:p>
+            <a:pPr>
+              <a:defRPr sz="1500" b="0">
+                <a:solidFill>
+                  <a:srgbClr val="475569"/>
+                </a:solidFill>
+                <a:latin typeface="Calibri"/>
+                <a:ea typeface="Calibri"/>
+                <a:cs typeface="Calibri"/>
+              </a:defRPr>
+            </a:pPr>
+            <a:r>
+              <a:rPr sz="1500" b="0">
+                <a:solidFill>
+                  <a:srgbClr val="475569"/>
+                </a:solidFill>
+                <a:latin typeface="Calibri"/>
+                <a:ea typeface="Calibri"/>
+                <a:cs typeface="Calibri"/>
+              </a:rPr>
+              <a:t>Buka halaman repo, lihat branch main dan commit terbaru. Template dosen hanya contoh lokasi pemeriksaan.</a:t>
+            </a:r>
+          </a:p>
+        </p:txBody>
+      </p:sp>
+      <p:pic>
+        <p:nvPicPr>
+          <p:cNvPr id="8" name="Picture 7" descr="11_github_published.jpg"/>
+          <p:cNvPicPr>
+            <a:picLocks noChangeAspect="1"/>
+          </p:cNvPicPr>
+          <p:nvPr/>
+        </p:nvPicPr>
+        <p:blipFill>
+          <a:blip r:embed="rId2"/>
+          <a:stretch>
+            <a:fillRect/>
+          </a:stretch>
+        </p:blipFill>
+        <p:spPr>
+          <a:xfrm>
+            <a:off x="731520" y="2011680"/>
+            <a:ext cx="7498079" cy="3624958"/>
+          </a:xfrm>
+          <a:prstGeom prst="rect">
+            <a:avLst/>
+          </a:prstGeom>
+        </p:spPr>
+      </p:pic>
+      <p:sp>
+        <p:nvSpPr>
+          <p:cNvPr id="9" name="TextBox 8"/>
+          <p:cNvSpPr txBox="1"/>
+          <p:nvPr/>
+        </p:nvSpPr>
+        <p:spPr>
+          <a:xfrm>
+            <a:off x="8412480" y="2057400"/>
+            <a:ext cx="3063240" cy="3383280"/>
+          </a:xfrm>
+          <a:prstGeom prst="rect">
+            <a:avLst/>
+          </a:prstGeom>
+          <a:noFill/>
+        </p:spPr>
+        <p:txBody>
+          <a:bodyPr wrap="square">
+            <a:spAutoFit/>
+          </a:bodyPr>
+          <a:lstStyle/>
+          <a:p>
+            <a:pPr>
+              <a:spcAft>
+                <a:spcPts val="1000"/>
+              </a:spcAft>
+              <a:defRPr sz="1700" b="1">
+                <a:solidFill>
+                  <a:srgbClr val="002677"/>
+                </a:solidFill>
+                <a:latin typeface="Calibri"/>
+              </a:defRPr>
+            </a:pPr>
+            <a:r>
+              <a:t>Perintah: git push</a:t>
+            </a:r>
+          </a:p>
+          <a:p>
+            <a:pPr>
+              <a:spcAft>
+                <a:spcPts val="1000"/>
+              </a:spcAft>
+              <a:defRPr sz="1500" b="0">
+                <a:solidFill>
+                  <a:srgbClr val="475569"/>
+                </a:solidFill>
+                <a:latin typeface="Calibri"/>
+              </a:defRPr>
+            </a:pPr>
+            <a:r>
+              <a:t>Fungsi: mengirim commit dan laporan ke origin.</a:t>
+            </a:r>
+          </a:p>
+          <a:p>
+            <a:pPr>
+              <a:spcAft>
+                <a:spcPts val="1000"/>
+              </a:spcAft>
+              <a:defRPr sz="1500" b="0">
+                <a:solidFill>
+                  <a:srgbClr val="475569"/>
+                </a:solidFill>
+                <a:latin typeface="Calibri"/>
+              </a:defRPr>
+            </a:pPr>
+            <a:r>
+              <a:t>Cara kerja: Git memperbarui branch main di GitHub.</a:t>
+            </a:r>
+          </a:p>
+          <a:p>
+            <a:pPr>
+              <a:spcAft>
+                <a:spcPts val="1000"/>
+              </a:spcAft>
+              <a:defRPr sz="1500" b="0">
+                <a:solidFill>
+                  <a:srgbClr val="475569"/>
+                </a:solidFill>
+                <a:latin typeface="Calibri"/>
+              </a:defRPr>
+            </a:pPr>
+            <a:r>
+              <a:t>Baca hasil: pesan commit, modul, dan file hasil muncul.</a:t>
+            </a:r>
+          </a:p>
+        </p:txBody>
+      </p:sp>
+    </p:spTree>
+  </p:cSld>
+  <p:clrMapOvr>
+    <a:masterClrMapping/>
+  </p:clrMapOvr>
+</p:sld>
+</file>
+
 <file path=ppt/slides/slide4.xml><?xml version="1.0" encoding="utf-8"?>
 <p:sld xmlns:p="http://schemas.openxmlformats.org/presentationml/2006/main">
   <p:cSld>

</xml_diff>

<commit_message>
Explain Docker operations on Lab 04 evidence slides
</commit_message>
<xml_diff>
--- a/slides/LAB04_Docker_Lifecycle_Praktikum.pptx
+++ b/slides/LAB04_Docker_Lifecycle_Praktikum.pptx
@@ -2,46 +2,46 @@
 <file path=ppt/presentation.xml><?xml version="1.0" encoding="utf-8"?>
 <p:presentation xmlns:p="http://schemas.openxmlformats.org/presentationml/2006/main">
   <p:sldMasterIdLst>
-    <p:sldMasterId xmlns:r="http://schemas.openxmlformats.org/officeDocument/2006/relationships" id="2147483648" r:id="R8f6a71d53e0c498e"/>
+    <p:sldMasterId xmlns:r="http://schemas.openxmlformats.org/officeDocument/2006/relationships" id="2147483648" r:id="Rf314c5979c064308"/>
   </p:sldMasterIdLst>
   <p:notesMasterIdLst>
-    <p:notesMasterId xmlns:r="http://schemas.openxmlformats.org/officeDocument/2006/relationships" r:id="R4b3abdc2cc744109"/>
+    <p:notesMasterId xmlns:r="http://schemas.openxmlformats.org/officeDocument/2006/relationships" r:id="Rbbc75658ca1d419e"/>
   </p:notesMasterIdLst>
   <p:sldIdLst>
-    <p:sldId xmlns:r="http://schemas.openxmlformats.org/officeDocument/2006/relationships" id="256" r:id="R3d23349ee364451e"/>
-    <p:sldId xmlns:r="http://schemas.openxmlformats.org/officeDocument/2006/relationships" id="257" r:id="Rd6ad3d1b4580457c"/>
-    <p:sldId xmlns:r="http://schemas.openxmlformats.org/officeDocument/2006/relationships" id="258" r:id="R8b6b66f412a24d63"/>
-    <p:sldId xmlns:r="http://schemas.openxmlformats.org/officeDocument/2006/relationships" id="259" r:id="R4ef1ff7f1238413b"/>
-    <p:sldId xmlns:r="http://schemas.openxmlformats.org/officeDocument/2006/relationships" id="260" r:id="Rc54e4fd267da4fcd"/>
-    <p:sldId xmlns:r="http://schemas.openxmlformats.org/officeDocument/2006/relationships" id="261" r:id="R9f6d6c8e80e9431c"/>
-    <p:sldId xmlns:r="http://schemas.openxmlformats.org/officeDocument/2006/relationships" id="262" r:id="R35e13cb1e6e7460a"/>
-    <p:sldId xmlns:r="http://schemas.openxmlformats.org/officeDocument/2006/relationships" id="263" r:id="R6c436b8b0e544aae"/>
-    <p:sldId xmlns:r="http://schemas.openxmlformats.org/officeDocument/2006/relationships" id="264" r:id="R51a432350fe1470c"/>
-    <p:sldId xmlns:r="http://schemas.openxmlformats.org/officeDocument/2006/relationships" id="265" r:id="Rc20bcc304a864c4b"/>
-    <p:sldId xmlns:r="http://schemas.openxmlformats.org/officeDocument/2006/relationships" id="266" r:id="Rd2052dbc17954704"/>
-    <p:sldId xmlns:r="http://schemas.openxmlformats.org/officeDocument/2006/relationships" id="267" r:id="R6be549598fec45ad"/>
-    <p:sldId xmlns:r="http://schemas.openxmlformats.org/officeDocument/2006/relationships" id="268" r:id="Ra99ba30a29a247a4"/>
-    <p:sldId xmlns:r="http://schemas.openxmlformats.org/officeDocument/2006/relationships" id="269" r:id="R8a819b570d7a42ef"/>
-    <p:sldId xmlns:r="http://schemas.openxmlformats.org/officeDocument/2006/relationships" id="270" r:id="R9ce6710a233a4b1a"/>
-    <p:sldId xmlns:r="http://schemas.openxmlformats.org/officeDocument/2006/relationships" id="271" r:id="R07520ce5879e4a6c"/>
-    <p:sldId xmlns:r="http://schemas.openxmlformats.org/officeDocument/2006/relationships" id="272" r:id="R2d4f3bd391784582"/>
-    <p:sldId xmlns:r="http://schemas.openxmlformats.org/officeDocument/2006/relationships" id="273" r:id="R72741698c591407c"/>
-    <p:sldId xmlns:r="http://schemas.openxmlformats.org/officeDocument/2006/relationships" id="274" r:id="R1815b04bc07a4c3b"/>
-    <p:sldId xmlns:r="http://schemas.openxmlformats.org/officeDocument/2006/relationships" id="275" r:id="Rf55b39f8652d486e"/>
-    <p:sldId xmlns:r="http://schemas.openxmlformats.org/officeDocument/2006/relationships" id="276" r:id="R5e157b6145d14d77"/>
-    <p:sldId xmlns:r="http://schemas.openxmlformats.org/officeDocument/2006/relationships" id="277" r:id="Rf87ea02882b64146"/>
-    <p:sldId xmlns:r="http://schemas.openxmlformats.org/officeDocument/2006/relationships" id="278" r:id="R62cd0e1f329a4029"/>
-    <p:sldId xmlns:r="http://schemas.openxmlformats.org/officeDocument/2006/relationships" id="279" r:id="R476d944d9c2346f1"/>
-    <p:sldId xmlns:r="http://schemas.openxmlformats.org/officeDocument/2006/relationships" id="280" r:id="Rf65d532e8b444741"/>
-    <p:sldId xmlns:r="http://schemas.openxmlformats.org/officeDocument/2006/relationships" id="281" r:id="R8af055ff4f404f02"/>
-    <p:sldId xmlns:r="http://schemas.openxmlformats.org/officeDocument/2006/relationships" id="282" r:id="R10d6183de4c24700"/>
-    <p:sldId xmlns:r="http://schemas.openxmlformats.org/officeDocument/2006/relationships" id="283" r:id="Ra90c80d0d8cb4ec3"/>
-    <p:sldId xmlns:r="http://schemas.openxmlformats.org/officeDocument/2006/relationships" id="284" r:id="Rfc0fa667ef0e4b88"/>
-    <p:sldId xmlns:r="http://schemas.openxmlformats.org/officeDocument/2006/relationships" id="285" r:id="Re932dd0891434378"/>
-    <p:sldId xmlns:r="http://schemas.openxmlformats.org/officeDocument/2006/relationships" id="286" r:id="R8ae602b867de42e4"/>
-    <p:sldId xmlns:r="http://schemas.openxmlformats.org/officeDocument/2006/relationships" id="287" r:id="R7c6814009c124fc2"/>
-    <p:sldId xmlns:r="http://schemas.openxmlformats.org/officeDocument/2006/relationships" id="288" r:id="R1ab69cdde7bc4592"/>
-    <p:sldId xmlns:ns0="http://schemas.openxmlformats.org/officeDocument/2006/relationships" id="289" ns0:id="rId39"/>
+    <p:sldId xmlns:r="http://schemas.openxmlformats.org/officeDocument/2006/relationships" id="256" r:id="R3fb846f785a148e1"/>
+    <p:sldId xmlns:r="http://schemas.openxmlformats.org/officeDocument/2006/relationships" id="257" r:id="R1a2b4ebcbc734cc7"/>
+    <p:sldId xmlns:r="http://schemas.openxmlformats.org/officeDocument/2006/relationships" id="258" r:id="R1ad9c074f4a24647"/>
+    <p:sldId xmlns:r="http://schemas.openxmlformats.org/officeDocument/2006/relationships" id="259" r:id="Rc985e02931c740fb"/>
+    <p:sldId xmlns:r="http://schemas.openxmlformats.org/officeDocument/2006/relationships" id="260" r:id="R5df025e6d6454125"/>
+    <p:sldId xmlns:r="http://schemas.openxmlformats.org/officeDocument/2006/relationships" id="261" r:id="R909754d3f35b4617"/>
+    <p:sldId xmlns:r="http://schemas.openxmlformats.org/officeDocument/2006/relationships" id="262" r:id="R559ef0478bb34492"/>
+    <p:sldId xmlns:r="http://schemas.openxmlformats.org/officeDocument/2006/relationships" id="263" r:id="R00624a3160ac4e1d"/>
+    <p:sldId xmlns:r="http://schemas.openxmlformats.org/officeDocument/2006/relationships" id="264" r:id="R57462168942048cb"/>
+    <p:sldId xmlns:r="http://schemas.openxmlformats.org/officeDocument/2006/relationships" id="265" r:id="Rca9c461151894729"/>
+    <p:sldId xmlns:r="http://schemas.openxmlformats.org/officeDocument/2006/relationships" id="266" r:id="R8d328a364e28476f"/>
+    <p:sldId xmlns:r="http://schemas.openxmlformats.org/officeDocument/2006/relationships" id="267" r:id="R4c25f59e0c6e4587"/>
+    <p:sldId xmlns:r="http://schemas.openxmlformats.org/officeDocument/2006/relationships" id="268" r:id="Rd68fb666b8f8439d"/>
+    <p:sldId xmlns:r="http://schemas.openxmlformats.org/officeDocument/2006/relationships" id="269" r:id="Rf68d9bbcc3cf472e"/>
+    <p:sldId xmlns:r="http://schemas.openxmlformats.org/officeDocument/2006/relationships" id="270" r:id="R623787710025415a"/>
+    <p:sldId xmlns:r="http://schemas.openxmlformats.org/officeDocument/2006/relationships" id="271" r:id="R876f2431d34440fc"/>
+    <p:sldId xmlns:r="http://schemas.openxmlformats.org/officeDocument/2006/relationships" id="272" r:id="Re1802c7a32f4404d"/>
+    <p:sldId xmlns:r="http://schemas.openxmlformats.org/officeDocument/2006/relationships" id="273" r:id="R2ea8e52fbc2e4138"/>
+    <p:sldId xmlns:r="http://schemas.openxmlformats.org/officeDocument/2006/relationships" id="274" r:id="R4f94c47063b04440"/>
+    <p:sldId xmlns:r="http://schemas.openxmlformats.org/officeDocument/2006/relationships" id="275" r:id="Rd5e3614a2e244fee"/>
+    <p:sldId xmlns:r="http://schemas.openxmlformats.org/officeDocument/2006/relationships" id="276" r:id="R359cf016ff2442e3"/>
+    <p:sldId xmlns:r="http://schemas.openxmlformats.org/officeDocument/2006/relationships" id="277" r:id="R0f50644261004833"/>
+    <p:sldId xmlns:r="http://schemas.openxmlformats.org/officeDocument/2006/relationships" id="278" r:id="Rcf51cddfb8c24e73"/>
+    <p:sldId xmlns:r="http://schemas.openxmlformats.org/officeDocument/2006/relationships" id="279" r:id="Rd8b584e59b62456f"/>
+    <p:sldId xmlns:r="http://schemas.openxmlformats.org/officeDocument/2006/relationships" id="280" r:id="R2cd6fe28d52a4f67"/>
+    <p:sldId xmlns:r="http://schemas.openxmlformats.org/officeDocument/2006/relationships" id="281" r:id="R47acbfcf326842c0"/>
+    <p:sldId xmlns:r="http://schemas.openxmlformats.org/officeDocument/2006/relationships" id="282" r:id="R4003b5934bce4cd0"/>
+    <p:sldId xmlns:r="http://schemas.openxmlformats.org/officeDocument/2006/relationships" id="283" r:id="Re2ef04826fb14d79"/>
+    <p:sldId xmlns:r="http://schemas.openxmlformats.org/officeDocument/2006/relationships" id="284" r:id="R28c37ebf75104058"/>
+    <p:sldId xmlns:r="http://schemas.openxmlformats.org/officeDocument/2006/relationships" id="285" r:id="R6c4a3fadd50146f1"/>
+    <p:sldId xmlns:r="http://schemas.openxmlformats.org/officeDocument/2006/relationships" id="286" r:id="Rbf4b33aa13034791"/>
+    <p:sldId xmlns:r="http://schemas.openxmlformats.org/officeDocument/2006/relationships" id="287" r:id="R6cd661a292344977"/>
+    <p:sldId xmlns:r="http://schemas.openxmlformats.org/officeDocument/2006/relationships" id="288" r:id="Rf816190ed03c4876"/>
+    <p:sldId xmlns:r="http://schemas.openxmlformats.org/officeDocument/2006/relationships" id="289" r:id="Rf8bc6818702b40e9"/>
   </p:sldIdLst>
   <p:sldSz cx="12192000" cy="6858000"/>
   <p:notesSz cx="6858000" cy="9144000"/>
@@ -2325,6 +2325,72 @@
 </p:notes>
 </file>
 
+<file path=ppt/notesSlides/notesSlide34.xml><?xml version="1.0" encoding="utf-8"?>
+<p:notes xmlns:p="http://schemas.openxmlformats.org/presentationml/2006/main">
+  <p:cSld>
+    <p:spTree>
+      <p:nvGrpSpPr>
+        <p:cNvPr id="1" name=""/>
+        <p:cNvGrpSpPr/>
+        <p:nvPr/>
+      </p:nvGrpSpPr>
+      <p:grpSpPr>
+        <a:xfrm xmlns:a="http://schemas.openxmlformats.org/drawingml/2006/main"/>
+      </p:grpSpPr>
+      <p:sp>
+        <p:nvSpPr>
+          <p:cNvPr id="2" name="Slide Image Placeholder 1"/>
+          <p:cNvSpPr>
+            <a:spLocks xmlns:a="http://schemas.openxmlformats.org/drawingml/2006/main" noGrp="1"/>
+          </p:cNvSpPr>
+          <p:nvPr>
+            <p:ph type="sldImg" idx="0"/>
+          </p:nvPr>
+        </p:nvSpPr>
+        <p:spPr/>
+      </p:sp>
+      <p:sp>
+        <p:nvSpPr>
+          <p:cNvPr id="3" name="Notes Placeholder 2"/>
+          <p:cNvSpPr>
+            <a:spLocks xmlns:a="http://schemas.openxmlformats.org/drawingml/2006/main" noGrp="1"/>
+          </p:cNvSpPr>
+          <p:nvPr>
+            <p:ph type="body" idx="1"/>
+          </p:nvPr>
+        </p:nvSpPr>
+        <p:spPr/>
+        <p:txBody>
+          <a:bodyPr xmlns:a="http://schemas.openxmlformats.org/drawingml/2006/main"/>
+          <a:lstStyle xmlns:a="http://schemas.openxmlformats.org/drawingml/2006/main"/>
+          <a:p xmlns:a="http://schemas.openxmlformats.org/drawingml/2006/main"/>
+        </p:txBody>
+      </p:sp>
+      <p:sp>
+        <p:nvSpPr>
+          <p:cNvPr id="4" name="Slide Number Placeholder 3"/>
+          <p:cNvSpPr>
+            <a:spLocks xmlns:a="http://schemas.openxmlformats.org/drawingml/2006/main" noGrp="1"/>
+          </p:cNvSpPr>
+          <p:nvPr>
+            <p:ph type="sldNum" idx="5"/>
+          </p:nvPr>
+        </p:nvSpPr>
+        <p:spPr/>
+        <p:txBody>
+          <a:bodyPr xmlns:a="http://schemas.openxmlformats.org/drawingml/2006/main"/>
+          <a:lstStyle xmlns:a="http://schemas.openxmlformats.org/drawingml/2006/main"/>
+          <a:p xmlns:a="http://schemas.openxmlformats.org/drawingml/2006/main"/>
+        </p:txBody>
+      </p:sp>
+    </p:spTree>
+  </p:cSld>
+  <p:clrMapOvr>
+    <a:masterClrMapping xmlns:a="http://schemas.openxmlformats.org/drawingml/2006/main"/>
+  </p:clrMapOvr>
+</p:notes>
+</file>
+
 <file path=ppt/notesSlides/notesSlide4.xml><?xml version="1.0" encoding="utf-8"?>
 <p:notes xmlns:p="http://schemas.openxmlformats.org/presentationml/2006/main">
   <p:cSld>
@@ -2783,7 +2849,7 @@
   </p:cSld>
   <p:clrMap bg1="lt1" tx1="dk1" bg2="lt2" tx2="dk2" accent1="accent1" accent2="accent2" accent3="accent3" accent4="accent4" accent5="accent5" accent6="accent6" hlink="hlink" folHlink="folHlink"/>
   <p:sldLayoutIdLst>
-    <p:sldLayoutId xmlns:r="http://schemas.openxmlformats.org/officeDocument/2006/relationships" id="2147483649" r:id="R44ea1c4c45894b26"/>
+    <p:sldLayoutId xmlns:r="http://schemas.openxmlformats.org/officeDocument/2006/relationships" id="2147483649" r:id="R9127e58684434d47"/>
   </p:sldLayoutIdLst>
   <p:txStyles>
     <p:titleStyle>
@@ -3363,6 +3429,7 @@
           <a:lstStyle xmlns:a="http://schemas.openxmlformats.org/drawingml/2006/main"/>
           <a:p xmlns:a="http://schemas.openxmlformats.org/drawingml/2006/main">
             <a:pPr>
+              <a:buNone/>
               <a:defRPr sz="2100" b="1">
                 <a:solidFill>
                   <a:srgbClr val="F37021"/>
@@ -3420,6 +3487,7 @@
           <a:lstStyle xmlns:a="http://schemas.openxmlformats.org/drawingml/2006/main"/>
           <a:p xmlns:a="http://schemas.openxmlformats.org/drawingml/2006/main">
             <a:pPr>
+              <a:buNone/>
               <a:defRPr sz="4800" b="1">
                 <a:solidFill>
                   <a:srgbClr val="FFFFFF"/>
@@ -3477,6 +3545,7 @@
           <a:lstStyle xmlns:a="http://schemas.openxmlformats.org/drawingml/2006/main"/>
           <a:p xmlns:a="http://schemas.openxmlformats.org/drawingml/2006/main">
             <a:pPr>
+              <a:buNone/>
               <a:defRPr sz="2175" b="0">
                 <a:solidFill>
                   <a:srgbClr val="FFFFFF"/>
@@ -3534,6 +3603,7 @@
           <a:lstStyle xmlns:a="http://schemas.openxmlformats.org/drawingml/2006/main"/>
           <a:p xmlns:a="http://schemas.openxmlformats.org/drawingml/2006/main">
             <a:pPr>
+              <a:buNone/>
               <a:defRPr sz="1500" b="0">
                 <a:solidFill>
                   <a:srgbClr val="FFFFFF"/>
@@ -3620,6 +3690,7 @@
           <a:lstStyle xmlns:a="http://schemas.openxmlformats.org/drawingml/2006/main"/>
           <a:p xmlns:a="http://schemas.openxmlformats.org/drawingml/2006/main">
             <a:pPr>
+              <a:buNone/>
               <a:defRPr sz="1350" b="1">
                 <a:solidFill>
                   <a:srgbClr val="F37021"/>
@@ -3677,6 +3748,7 @@
           <a:lstStyle xmlns:a="http://schemas.openxmlformats.org/drawingml/2006/main"/>
           <a:p xmlns:a="http://schemas.openxmlformats.org/drawingml/2006/main">
             <a:pPr>
+              <a:buNone/>
               <a:defRPr sz="3150" b="1">
                 <a:solidFill>
                   <a:srgbClr val="002677"/>
@@ -3734,6 +3806,7 @@
           <a:lstStyle xmlns:a="http://schemas.openxmlformats.org/drawingml/2006/main"/>
           <a:p xmlns:a="http://schemas.openxmlformats.org/drawingml/2006/main">
             <a:pPr>
+              <a:buNone/>
               <a:defRPr sz="1725" b="0">
                 <a:solidFill>
                   <a:srgbClr val="475569"/>
@@ -3791,6 +3864,7 @@
           <a:lstStyle xmlns:a="http://schemas.openxmlformats.org/drawingml/2006/main"/>
           <a:p xmlns:a="http://schemas.openxmlformats.org/drawingml/2006/main">
             <a:pPr algn="r">
+              <a:buNone/>
               <a:defRPr sz="1125" b="0">
                 <a:solidFill>
                   <a:srgbClr val="475569"/>
@@ -3878,6 +3952,7 @@
           <a:lstStyle xmlns:a="http://schemas.openxmlformats.org/drawingml/2006/main"/>
           <a:p xmlns:a="http://schemas.openxmlformats.org/drawingml/2006/main">
             <a:pPr>
+              <a:buNone/>
               <a:defRPr sz="1500" b="0">
                 <a:solidFill>
                   <a:srgbClr val="E6F3FF"/>
@@ -3901,6 +3976,7 @@
           </a:p>
           <a:p xmlns:a="http://schemas.openxmlformats.org/drawingml/2006/main">
             <a:pPr>
+              <a:buNone/>
               <a:defRPr sz="1500" b="0">
                 <a:solidFill>
                   <a:srgbClr val="E6F3FF"/>
@@ -3924,6 +4000,7 @@
           </a:p>
           <a:p xmlns:a="http://schemas.openxmlformats.org/drawingml/2006/main">
             <a:pPr>
+              <a:buNone/>
               <a:defRPr sz="1500" b="0">
                 <a:solidFill>
                   <a:srgbClr val="E6F3FF"/>
@@ -3947,6 +4024,7 @@
           </a:p>
           <a:p xmlns:a="http://schemas.openxmlformats.org/drawingml/2006/main">
             <a:pPr>
+              <a:buNone/>
               <a:defRPr sz="1500" b="0">
                 <a:solidFill>
                   <a:srgbClr val="E6F3FF"/>
@@ -3970,6 +4048,7 @@
           </a:p>
           <a:p xmlns:a="http://schemas.openxmlformats.org/drawingml/2006/main">
             <a:pPr>
+              <a:buNone/>
               <a:defRPr sz="1500" b="0">
                 <a:solidFill>
                   <a:srgbClr val="E6F3FF"/>
@@ -4027,6 +4106,7 @@
           <a:lstStyle xmlns:a="http://schemas.openxmlformats.org/drawingml/2006/main"/>
           <a:p xmlns:a="http://schemas.openxmlformats.org/drawingml/2006/main">
             <a:pPr>
+              <a:buNone/>
               <a:defRPr sz="1425" b="1">
                 <a:solidFill>
                   <a:srgbClr val="F37021"/>
@@ -4084,6 +4164,7 @@
           <a:lstStyle xmlns:a="http://schemas.openxmlformats.org/drawingml/2006/main"/>
           <a:p xmlns:a="http://schemas.openxmlformats.org/drawingml/2006/main">
             <a:pPr>
+              <a:buNone/>
               <a:defRPr sz="1725" b="0">
                 <a:solidFill>
                   <a:srgbClr val="0F172A"/>
@@ -4170,6 +4251,7 @@
           <a:lstStyle xmlns:a="http://schemas.openxmlformats.org/drawingml/2006/main"/>
           <a:p xmlns:a="http://schemas.openxmlformats.org/drawingml/2006/main">
             <a:pPr>
+              <a:buNone/>
               <a:defRPr sz="1350" b="1">
                 <a:solidFill>
                   <a:srgbClr val="F37021"/>
@@ -4227,6 +4309,7 @@
           <a:lstStyle xmlns:a="http://schemas.openxmlformats.org/drawingml/2006/main"/>
           <a:p xmlns:a="http://schemas.openxmlformats.org/drawingml/2006/main">
             <a:pPr>
+              <a:buNone/>
               <a:defRPr sz="3150" b="1">
                 <a:solidFill>
                   <a:srgbClr val="002677"/>
@@ -4284,6 +4367,7 @@
           <a:lstStyle xmlns:a="http://schemas.openxmlformats.org/drawingml/2006/main"/>
           <a:p xmlns:a="http://schemas.openxmlformats.org/drawingml/2006/main">
             <a:pPr>
+              <a:buNone/>
               <a:defRPr sz="1725" b="0">
                 <a:solidFill>
                   <a:srgbClr val="475569"/>
@@ -4341,6 +4425,7 @@
           <a:lstStyle xmlns:a="http://schemas.openxmlformats.org/drawingml/2006/main"/>
           <a:p xmlns:a="http://schemas.openxmlformats.org/drawingml/2006/main">
             <a:pPr algn="r">
+              <a:buNone/>
               <a:defRPr sz="1125" b="0">
                 <a:solidFill>
                   <a:srgbClr val="475569"/>
@@ -4366,14 +4451,14 @@
       </p:sp>
       <p:pic>
         <p:nvPicPr>
-          <p:cNvPr id="11" name=""/>
+          <p:cNvPr id="13" name=""/>
           <p:cNvPicPr>
             <a:picLocks xmlns:a="http://schemas.openxmlformats.org/drawingml/2006/main" noChangeAspect="1"/>
           </p:cNvPicPr>
           <p:nvPr/>
         </p:nvPicPr>
         <p:blipFill>
-          <a:blip xmlns:r="http://schemas.openxmlformats.org/officeDocument/2006/relationships" xmlns:a="http://schemas.openxmlformats.org/drawingml/2006/main" r:embed="R755d06cf188b4a72"/>
+          <a:blip xmlns:r="http://schemas.openxmlformats.org/officeDocument/2006/relationships" xmlns:a="http://schemas.openxmlformats.org/drawingml/2006/main" r:embed="Rbe1eaa664d214410"/>
           <a:srcRect xmlns:a="http://schemas.openxmlformats.org/drawingml/2006/main" l="0" t="18218" r="0" b="18218"/>
           <a:stretch xmlns:a="http://schemas.openxmlformats.org/drawingml/2006/main">
             <a:fillRect l="0" t="0" r="0" b="0"/>
@@ -4423,6 +4508,7 @@
           <a:lstStyle xmlns:a="http://schemas.openxmlformats.org/drawingml/2006/main"/>
           <a:p xmlns:a="http://schemas.openxmlformats.org/drawingml/2006/main">
             <a:pPr>
+              <a:buNone/>
               <a:defRPr sz="1500" b="0">
                 <a:solidFill>
                   <a:srgbClr val="475569"/>
@@ -4441,7 +4527,7 @@
                 <a:ea typeface="Calibri"/>
                 <a:cs typeface="Calibri"/>
               </a:rPr>
-              <a:t>Tampilan Containers: cloudlab-nginx Up dan 8088:80. Konfirmasi HTTP dengan curl.exe -I.</a:t>
+              <a:t>docker run -p 127.0.0.1:8088:80 meneruskan host 8088 ke Nginx 80; curl.exe -I membuktikan HTTP 200.</a:t>
             </a:r>
           </a:p>
         </p:txBody>
@@ -4509,6 +4595,7 @@
           <a:lstStyle xmlns:a="http://schemas.openxmlformats.org/drawingml/2006/main"/>
           <a:p xmlns:a="http://schemas.openxmlformats.org/drawingml/2006/main">
             <a:pPr>
+              <a:buNone/>
               <a:defRPr sz="1350" b="1">
                 <a:solidFill>
                   <a:srgbClr val="F37021"/>
@@ -4566,6 +4653,7 @@
           <a:lstStyle xmlns:a="http://schemas.openxmlformats.org/drawingml/2006/main"/>
           <a:p xmlns:a="http://schemas.openxmlformats.org/drawingml/2006/main">
             <a:pPr>
+              <a:buNone/>
               <a:defRPr sz="3150" b="1">
                 <a:solidFill>
                   <a:srgbClr val="002677"/>
@@ -4623,6 +4711,7 @@
           <a:lstStyle xmlns:a="http://schemas.openxmlformats.org/drawingml/2006/main"/>
           <a:p xmlns:a="http://schemas.openxmlformats.org/drawingml/2006/main">
             <a:pPr>
+              <a:buNone/>
               <a:defRPr sz="1725" b="0">
                 <a:solidFill>
                   <a:srgbClr val="475569"/>
@@ -4680,6 +4769,7 @@
           <a:lstStyle xmlns:a="http://schemas.openxmlformats.org/drawingml/2006/main"/>
           <a:p xmlns:a="http://schemas.openxmlformats.org/drawingml/2006/main">
             <a:pPr algn="r">
+              <a:buNone/>
               <a:defRPr sz="1125" b="0">
                 <a:solidFill>
                   <a:srgbClr val="475569"/>
@@ -4767,6 +4857,7 @@
           <a:lstStyle xmlns:a="http://schemas.openxmlformats.org/drawingml/2006/main"/>
           <a:p xmlns:a="http://schemas.openxmlformats.org/drawingml/2006/main">
             <a:pPr>
+              <a:buNone/>
               <a:defRPr sz="1575" b="0">
                 <a:solidFill>
                   <a:srgbClr val="E6F3FF"/>
@@ -4790,6 +4881,7 @@
           </a:p>
           <a:p xmlns:a="http://schemas.openxmlformats.org/drawingml/2006/main">
             <a:pPr>
+              <a:buNone/>
               <a:defRPr sz="1575" b="0">
                 <a:solidFill>
                   <a:srgbClr val="E6F3FF"/>
@@ -4813,6 +4905,7 @@
           </a:p>
           <a:p xmlns:a="http://schemas.openxmlformats.org/drawingml/2006/main">
             <a:pPr>
+              <a:buNone/>
               <a:defRPr sz="1575" b="0">
                 <a:solidFill>
                   <a:srgbClr val="E6F3FF"/>
@@ -4836,6 +4929,7 @@
           </a:p>
           <a:p xmlns:a="http://schemas.openxmlformats.org/drawingml/2006/main">
             <a:pPr>
+              <a:buNone/>
               <a:defRPr sz="1575" b="0">
                 <a:solidFill>
                   <a:srgbClr val="E6F3FF"/>
@@ -4859,6 +4953,7 @@
           </a:p>
           <a:p xmlns:a="http://schemas.openxmlformats.org/drawingml/2006/main">
             <a:pPr>
+              <a:buNone/>
               <a:defRPr sz="1575" b="0">
                 <a:solidFill>
                   <a:srgbClr val="E6F3FF"/>
@@ -4882,6 +4977,7 @@
           </a:p>
           <a:p xmlns:a="http://schemas.openxmlformats.org/drawingml/2006/main">
             <a:pPr>
+              <a:buNone/>
               <a:defRPr sz="1575" b="0">
                 <a:solidFill>
                   <a:srgbClr val="E6F3FF"/>
@@ -4905,6 +5001,7 @@
           </a:p>
           <a:p xmlns:a="http://schemas.openxmlformats.org/drawingml/2006/main">
             <a:pPr>
+              <a:buNone/>
               <a:defRPr sz="1575" b="0">
                 <a:solidFill>
                   <a:srgbClr val="E6F3FF"/>
@@ -4962,6 +5059,7 @@
           <a:lstStyle xmlns:a="http://schemas.openxmlformats.org/drawingml/2006/main"/>
           <a:p xmlns:a="http://schemas.openxmlformats.org/drawingml/2006/main">
             <a:pPr>
+              <a:buNone/>
               <a:defRPr sz="1425" b="1">
                 <a:solidFill>
                   <a:srgbClr val="F37021"/>
@@ -5019,6 +5117,7 @@
           <a:lstStyle xmlns:a="http://schemas.openxmlformats.org/drawingml/2006/main"/>
           <a:p xmlns:a="http://schemas.openxmlformats.org/drawingml/2006/main">
             <a:pPr>
+              <a:buNone/>
               <a:defRPr sz="1725" b="0">
                 <a:solidFill>
                   <a:srgbClr val="0F172A"/>
@@ -5105,6 +5204,7 @@
           <a:lstStyle xmlns:a="http://schemas.openxmlformats.org/drawingml/2006/main"/>
           <a:p xmlns:a="http://schemas.openxmlformats.org/drawingml/2006/main">
             <a:pPr>
+              <a:buNone/>
               <a:defRPr sz="1350" b="1">
                 <a:solidFill>
                   <a:srgbClr val="F37021"/>
@@ -5162,6 +5262,7 @@
           <a:lstStyle xmlns:a="http://schemas.openxmlformats.org/drawingml/2006/main"/>
           <a:p xmlns:a="http://schemas.openxmlformats.org/drawingml/2006/main">
             <a:pPr>
+              <a:buNone/>
               <a:defRPr sz="3150" b="1">
                 <a:solidFill>
                   <a:srgbClr val="002677"/>
@@ -5219,6 +5320,7 @@
           <a:lstStyle xmlns:a="http://schemas.openxmlformats.org/drawingml/2006/main"/>
           <a:p xmlns:a="http://schemas.openxmlformats.org/drawingml/2006/main">
             <a:pPr>
+              <a:buNone/>
               <a:defRPr sz="1725" b="0">
                 <a:solidFill>
                   <a:srgbClr val="475569"/>
@@ -5276,6 +5378,7 @@
           <a:lstStyle xmlns:a="http://schemas.openxmlformats.org/drawingml/2006/main"/>
           <a:p xmlns:a="http://schemas.openxmlformats.org/drawingml/2006/main">
             <a:pPr algn="r">
+              <a:buNone/>
               <a:defRPr sz="1125" b="0">
                 <a:solidFill>
                   <a:srgbClr val="475569"/>
@@ -5301,14 +5404,14 @@
       </p:sp>
       <p:pic>
         <p:nvPicPr>
-          <p:cNvPr id="11" name=""/>
+          <p:cNvPr id="13" name=""/>
           <p:cNvPicPr>
             <a:picLocks xmlns:a="http://schemas.openxmlformats.org/drawingml/2006/main" noChangeAspect="1"/>
           </p:cNvPicPr>
           <p:nvPr/>
         </p:nvPicPr>
         <p:blipFill>
-          <a:blip xmlns:r="http://schemas.openxmlformats.org/officeDocument/2006/relationships" xmlns:a="http://schemas.openxmlformats.org/drawingml/2006/main" r:embed="Ref4f01b5d17a4a98"/>
+          <a:blip xmlns:r="http://schemas.openxmlformats.org/officeDocument/2006/relationships" xmlns:a="http://schemas.openxmlformats.org/drawingml/2006/main" r:embed="R205383b6628d4deb"/>
           <a:stretch xmlns:a="http://schemas.openxmlformats.org/drawingml/2006/main"/>
         </p:blipFill>
         <p:spPr>
@@ -5355,6 +5458,7 @@
           <a:lstStyle xmlns:a="http://schemas.openxmlformats.org/drawingml/2006/main"/>
           <a:p xmlns:a="http://schemas.openxmlformats.org/drawingml/2006/main">
             <a:pPr>
+              <a:buNone/>
               <a:defRPr sz="1500" b="0">
                 <a:solidFill>
                   <a:srgbClr val="475569"/>
@@ -5441,6 +5545,7 @@
           <a:lstStyle xmlns:a="http://schemas.openxmlformats.org/drawingml/2006/main"/>
           <a:p xmlns:a="http://schemas.openxmlformats.org/drawingml/2006/main">
             <a:pPr>
+              <a:buNone/>
               <a:defRPr sz="1350" b="1">
                 <a:solidFill>
                   <a:srgbClr val="F37021"/>
@@ -5498,6 +5603,7 @@
           <a:lstStyle xmlns:a="http://schemas.openxmlformats.org/drawingml/2006/main"/>
           <a:p xmlns:a="http://schemas.openxmlformats.org/drawingml/2006/main">
             <a:pPr>
+              <a:buNone/>
               <a:defRPr sz="3150" b="1">
                 <a:solidFill>
                   <a:srgbClr val="002677"/>
@@ -5555,6 +5661,7 @@
           <a:lstStyle xmlns:a="http://schemas.openxmlformats.org/drawingml/2006/main"/>
           <a:p xmlns:a="http://schemas.openxmlformats.org/drawingml/2006/main">
             <a:pPr>
+              <a:buNone/>
               <a:defRPr sz="1725" b="0">
                 <a:solidFill>
                   <a:srgbClr val="475569"/>
@@ -5612,6 +5719,7 @@
           <a:lstStyle xmlns:a="http://schemas.openxmlformats.org/drawingml/2006/main"/>
           <a:p xmlns:a="http://schemas.openxmlformats.org/drawingml/2006/main">
             <a:pPr algn="r">
+              <a:buNone/>
               <a:defRPr sz="1125" b="0">
                 <a:solidFill>
                   <a:srgbClr val="475569"/>
@@ -5699,6 +5807,7 @@
           <a:lstStyle xmlns:a="http://schemas.openxmlformats.org/drawingml/2006/main"/>
           <a:p xmlns:a="http://schemas.openxmlformats.org/drawingml/2006/main">
             <a:pPr>
+              <a:buNone/>
               <a:defRPr sz="1350" b="0">
                 <a:solidFill>
                   <a:srgbClr val="E6F3FF"/>
@@ -5722,6 +5831,7 @@
           </a:p>
           <a:p xmlns:a="http://schemas.openxmlformats.org/drawingml/2006/main">
             <a:pPr>
+              <a:buNone/>
               <a:defRPr sz="1350" b="0">
                 <a:solidFill>
                   <a:srgbClr val="E6F3FF"/>
@@ -5745,6 +5855,7 @@
           </a:p>
           <a:p xmlns:a="http://schemas.openxmlformats.org/drawingml/2006/main">
             <a:pPr>
+              <a:buNone/>
               <a:defRPr sz="1350" b="0">
                 <a:solidFill>
                   <a:srgbClr val="E6F3FF"/>
@@ -5768,6 +5879,7 @@
           </a:p>
           <a:p xmlns:a="http://schemas.openxmlformats.org/drawingml/2006/main">
             <a:pPr>
+              <a:buNone/>
               <a:defRPr sz="1350" b="0">
                 <a:solidFill>
                   <a:srgbClr val="E6F3FF"/>
@@ -5791,6 +5903,7 @@
           </a:p>
           <a:p xmlns:a="http://schemas.openxmlformats.org/drawingml/2006/main">
             <a:pPr>
+              <a:buNone/>
               <a:defRPr sz="1350" b="0">
                 <a:solidFill>
                   <a:srgbClr val="E6F3FF"/>
@@ -5814,6 +5927,7 @@
           </a:p>
           <a:p xmlns:a="http://schemas.openxmlformats.org/drawingml/2006/main">
             <a:pPr>
+              <a:buNone/>
               <a:defRPr sz="1350" b="0">
                 <a:solidFill>
                   <a:srgbClr val="E6F3FF"/>
@@ -5837,6 +5951,7 @@
           </a:p>
           <a:p xmlns:a="http://schemas.openxmlformats.org/drawingml/2006/main">
             <a:pPr>
+              <a:buNone/>
               <a:defRPr sz="1350" b="0">
                 <a:solidFill>
                   <a:srgbClr val="E6F3FF"/>
@@ -5894,6 +6009,7 @@
           <a:lstStyle xmlns:a="http://schemas.openxmlformats.org/drawingml/2006/main"/>
           <a:p xmlns:a="http://schemas.openxmlformats.org/drawingml/2006/main">
             <a:pPr>
+              <a:buNone/>
               <a:defRPr sz="1425" b="1">
                 <a:solidFill>
                   <a:srgbClr val="F37021"/>
@@ -5951,6 +6067,7 @@
           <a:lstStyle xmlns:a="http://schemas.openxmlformats.org/drawingml/2006/main"/>
           <a:p xmlns:a="http://schemas.openxmlformats.org/drawingml/2006/main">
             <a:pPr>
+              <a:buNone/>
               <a:defRPr sz="1725" b="0">
                 <a:solidFill>
                   <a:srgbClr val="0F172A"/>
@@ -6037,6 +6154,7 @@
           <a:lstStyle xmlns:a="http://schemas.openxmlformats.org/drawingml/2006/main"/>
           <a:p xmlns:a="http://schemas.openxmlformats.org/drawingml/2006/main">
             <a:pPr>
+              <a:buNone/>
               <a:defRPr sz="1350" b="1">
                 <a:solidFill>
                   <a:srgbClr val="F37021"/>
@@ -6094,6 +6212,7 @@
           <a:lstStyle xmlns:a="http://schemas.openxmlformats.org/drawingml/2006/main"/>
           <a:p xmlns:a="http://schemas.openxmlformats.org/drawingml/2006/main">
             <a:pPr>
+              <a:buNone/>
               <a:defRPr sz="3150" b="1">
                 <a:solidFill>
                   <a:srgbClr val="002677"/>
@@ -6151,6 +6270,7 @@
           <a:lstStyle xmlns:a="http://schemas.openxmlformats.org/drawingml/2006/main"/>
           <a:p xmlns:a="http://schemas.openxmlformats.org/drawingml/2006/main">
             <a:pPr>
+              <a:buNone/>
               <a:defRPr sz="1725" b="0">
                 <a:solidFill>
                   <a:srgbClr val="475569"/>
@@ -6208,6 +6328,7 @@
           <a:lstStyle xmlns:a="http://schemas.openxmlformats.org/drawingml/2006/main"/>
           <a:p xmlns:a="http://schemas.openxmlformats.org/drawingml/2006/main">
             <a:pPr algn="r">
+              <a:buNone/>
               <a:defRPr sz="1125" b="0">
                 <a:solidFill>
                   <a:srgbClr val="475569"/>
@@ -6233,14 +6354,14 @@
       </p:sp>
       <p:pic>
         <p:nvPicPr>
-          <p:cNvPr id="11" name=""/>
+          <p:cNvPr id="13" name=""/>
           <p:cNvPicPr>
             <a:picLocks xmlns:a="http://schemas.openxmlformats.org/drawingml/2006/main" noChangeAspect="1"/>
           </p:cNvPicPr>
           <p:nvPr/>
         </p:nvPicPr>
         <p:blipFill>
-          <a:blip xmlns:r="http://schemas.openxmlformats.org/officeDocument/2006/relationships" xmlns:a="http://schemas.openxmlformats.org/drawingml/2006/main" r:embed="R03fe2bcbf4f3422b"/>
+          <a:blip xmlns:r="http://schemas.openxmlformats.org/officeDocument/2006/relationships" xmlns:a="http://schemas.openxmlformats.org/drawingml/2006/main" r:embed="Rbbc63cc51edc4176"/>
           <a:srcRect xmlns:a="http://schemas.openxmlformats.org/drawingml/2006/main" l="0" t="19234" r="0" b="19234"/>
           <a:stretch xmlns:a="http://schemas.openxmlformats.org/drawingml/2006/main">
             <a:fillRect l="0" t="0" r="0" b="0"/>
@@ -6290,6 +6411,7 @@
           <a:lstStyle xmlns:a="http://schemas.openxmlformats.org/drawingml/2006/main"/>
           <a:p xmlns:a="http://schemas.openxmlformats.org/drawingml/2006/main">
             <a:pPr>
+              <a:buNone/>
               <a:defRPr sz="1500" b="0">
                 <a:solidFill>
                   <a:srgbClr val="475569"/>
@@ -6308,7 +6430,7 @@
                 <a:ea typeface="Calibri"/>
                 <a:cs typeface="Calibri"/>
               </a:rPr>
-              <a:t>Perintah: docker run cloudlab-site dengan --mount readonly. Browser menampilkan STATUS_OK: Layanan normal.</a:t>
+              <a:t>docker run --mount readonly membuat Nginx membaca site/ dari host; -p 8088:80 membuka STATUS_OK di browser.</a:t>
             </a:r>
           </a:p>
         </p:txBody>
@@ -6376,6 +6498,7 @@
           <a:lstStyle xmlns:a="http://schemas.openxmlformats.org/drawingml/2006/main"/>
           <a:p xmlns:a="http://schemas.openxmlformats.org/drawingml/2006/main">
             <a:pPr>
+              <a:buNone/>
               <a:defRPr sz="1350" b="1">
                 <a:solidFill>
                   <a:srgbClr val="F37021"/>
@@ -6433,6 +6556,7 @@
           <a:lstStyle xmlns:a="http://schemas.openxmlformats.org/drawingml/2006/main"/>
           <a:p xmlns:a="http://schemas.openxmlformats.org/drawingml/2006/main">
             <a:pPr>
+              <a:buNone/>
               <a:defRPr sz="3150" b="1">
                 <a:solidFill>
                   <a:srgbClr val="002677"/>
@@ -6490,6 +6614,7 @@
           <a:lstStyle xmlns:a="http://schemas.openxmlformats.org/drawingml/2006/main"/>
           <a:p xmlns:a="http://schemas.openxmlformats.org/drawingml/2006/main">
             <a:pPr>
+              <a:buNone/>
               <a:defRPr sz="1725" b="0">
                 <a:solidFill>
                   <a:srgbClr val="475569"/>
@@ -6547,6 +6672,7 @@
           <a:lstStyle xmlns:a="http://schemas.openxmlformats.org/drawingml/2006/main"/>
           <a:p xmlns:a="http://schemas.openxmlformats.org/drawingml/2006/main">
             <a:pPr algn="r">
+              <a:buNone/>
               <a:defRPr sz="1125" b="0">
                 <a:solidFill>
                   <a:srgbClr val="475569"/>
@@ -6572,14 +6698,14 @@
       </p:sp>
       <p:pic>
         <p:nvPicPr>
-          <p:cNvPr id="11" name=""/>
+          <p:cNvPr id="13" name=""/>
           <p:cNvPicPr>
             <a:picLocks xmlns:a="http://schemas.openxmlformats.org/drawingml/2006/main" noChangeAspect="1"/>
           </p:cNvPicPr>
           <p:nvPr/>
         </p:nvPicPr>
         <p:blipFill>
-          <a:blip xmlns:r="http://schemas.openxmlformats.org/officeDocument/2006/relationships" xmlns:a="http://schemas.openxmlformats.org/drawingml/2006/main" r:embed="Rf4cc3c82cd24462b"/>
+          <a:blip xmlns:r="http://schemas.openxmlformats.org/officeDocument/2006/relationships" xmlns:a="http://schemas.openxmlformats.org/drawingml/2006/main" r:embed="Rae9616e58ad0411e"/>
           <a:srcRect xmlns:a="http://schemas.openxmlformats.org/drawingml/2006/main" l="0" t="18218" r="0" b="18218"/>
           <a:stretch xmlns:a="http://schemas.openxmlformats.org/drawingml/2006/main">
             <a:fillRect l="0" t="0" r="0" b="0"/>
@@ -6629,6 +6755,7 @@
           <a:lstStyle xmlns:a="http://schemas.openxmlformats.org/drawingml/2006/main"/>
           <a:p xmlns:a="http://schemas.openxmlformats.org/drawingml/2006/main">
             <a:pPr>
+              <a:buNone/>
               <a:defRPr sz="1500" b="0">
                 <a:solidFill>
                   <a:srgbClr val="475569"/>
@@ -6647,7 +6774,7 @@
                 <a:ea typeface="Calibri"/>
                 <a:cs typeface="Calibri"/>
               </a:rPr>
-              <a:t>Tampilan Containers: cloudlab-site Up dan 8088:80. Jalankan docker inspect untuk memastikan RW=false.</a:t>
+              <a:t>docker inspect membaca mount: RW=false berarti container hanya membaca site/; Docker Desktop menunjukkan 8088:80.</a:t>
             </a:r>
           </a:p>
         </p:txBody>
@@ -6715,6 +6842,7 @@
           <a:lstStyle xmlns:a="http://schemas.openxmlformats.org/drawingml/2006/main"/>
           <a:p xmlns:a="http://schemas.openxmlformats.org/drawingml/2006/main">
             <a:pPr>
+              <a:buNone/>
               <a:defRPr sz="1350" b="1">
                 <a:solidFill>
                   <a:srgbClr val="F37021"/>
@@ -6772,6 +6900,7 @@
           <a:lstStyle xmlns:a="http://schemas.openxmlformats.org/drawingml/2006/main"/>
           <a:p xmlns:a="http://schemas.openxmlformats.org/drawingml/2006/main">
             <a:pPr>
+              <a:buNone/>
               <a:defRPr sz="3150" b="1">
                 <a:solidFill>
                   <a:srgbClr val="002677"/>
@@ -6829,6 +6958,7 @@
           <a:lstStyle xmlns:a="http://schemas.openxmlformats.org/drawingml/2006/main"/>
           <a:p xmlns:a="http://schemas.openxmlformats.org/drawingml/2006/main">
             <a:pPr>
+              <a:buNone/>
               <a:defRPr sz="1725" b="0">
                 <a:solidFill>
                   <a:srgbClr val="475569"/>
@@ -6886,6 +7016,7 @@
           <a:lstStyle xmlns:a="http://schemas.openxmlformats.org/drawingml/2006/main"/>
           <a:p xmlns:a="http://schemas.openxmlformats.org/drawingml/2006/main">
             <a:pPr algn="r">
+              <a:buNone/>
               <a:defRPr sz="1125" b="0">
                 <a:solidFill>
                   <a:srgbClr val="475569"/>
@@ -6973,6 +7104,7 @@
           <a:lstStyle xmlns:a="http://schemas.openxmlformats.org/drawingml/2006/main"/>
           <a:p xmlns:a="http://schemas.openxmlformats.org/drawingml/2006/main">
             <a:pPr>
+              <a:buNone/>
               <a:defRPr sz="1575" b="0">
                 <a:solidFill>
                   <a:srgbClr val="E6F3FF"/>
@@ -6996,6 +7128,7 @@
           </a:p>
           <a:p xmlns:a="http://schemas.openxmlformats.org/drawingml/2006/main">
             <a:pPr>
+              <a:buNone/>
               <a:defRPr sz="1575" b="0">
                 <a:solidFill>
                   <a:srgbClr val="E6F3FF"/>
@@ -7019,6 +7152,7 @@
           </a:p>
           <a:p xmlns:a="http://schemas.openxmlformats.org/drawingml/2006/main">
             <a:pPr>
+              <a:buNone/>
               <a:defRPr sz="1575" b="0">
                 <a:solidFill>
                   <a:srgbClr val="E6F3FF"/>
@@ -7042,6 +7176,7 @@
           </a:p>
           <a:p xmlns:a="http://schemas.openxmlformats.org/drawingml/2006/main">
             <a:pPr>
+              <a:buNone/>
               <a:defRPr sz="1575" b="0">
                 <a:solidFill>
                   <a:srgbClr val="E6F3FF"/>
@@ -7065,6 +7200,7 @@
           </a:p>
           <a:p xmlns:a="http://schemas.openxmlformats.org/drawingml/2006/main">
             <a:pPr>
+              <a:buNone/>
               <a:defRPr sz="1575" b="0">
                 <a:solidFill>
                   <a:srgbClr val="E6F3FF"/>
@@ -7088,6 +7224,7 @@
           </a:p>
           <a:p xmlns:a="http://schemas.openxmlformats.org/drawingml/2006/main">
             <a:pPr>
+              <a:buNone/>
               <a:defRPr sz="1575" b="0">
                 <a:solidFill>
                   <a:srgbClr val="E6F3FF"/>
@@ -7111,6 +7248,7 @@
           </a:p>
           <a:p xmlns:a="http://schemas.openxmlformats.org/drawingml/2006/main">
             <a:pPr>
+              <a:buNone/>
               <a:defRPr sz="1575" b="0">
                 <a:solidFill>
                   <a:srgbClr val="E6F3FF"/>
@@ -7168,6 +7306,7 @@
           <a:lstStyle xmlns:a="http://schemas.openxmlformats.org/drawingml/2006/main"/>
           <a:p xmlns:a="http://schemas.openxmlformats.org/drawingml/2006/main">
             <a:pPr>
+              <a:buNone/>
               <a:defRPr sz="1425" b="1">
                 <a:solidFill>
                   <a:srgbClr val="F37021"/>
@@ -7225,6 +7364,7 @@
           <a:lstStyle xmlns:a="http://schemas.openxmlformats.org/drawingml/2006/main"/>
           <a:p xmlns:a="http://schemas.openxmlformats.org/drawingml/2006/main">
             <a:pPr>
+              <a:buNone/>
               <a:defRPr sz="1725" b="0">
                 <a:solidFill>
                   <a:srgbClr val="0F172A"/>
@@ -7311,6 +7451,7 @@
           <a:lstStyle xmlns:a="http://schemas.openxmlformats.org/drawingml/2006/main"/>
           <a:p xmlns:a="http://schemas.openxmlformats.org/drawingml/2006/main">
             <a:pPr>
+              <a:buNone/>
               <a:defRPr sz="1350" b="1">
                 <a:solidFill>
                   <a:srgbClr val="F37021"/>
@@ -7368,6 +7509,7 @@
           <a:lstStyle xmlns:a="http://schemas.openxmlformats.org/drawingml/2006/main"/>
           <a:p xmlns:a="http://schemas.openxmlformats.org/drawingml/2006/main">
             <a:pPr>
+              <a:buNone/>
               <a:defRPr sz="3150" b="1">
                 <a:solidFill>
                   <a:srgbClr val="002677"/>
@@ -7425,6 +7567,7 @@
           <a:lstStyle xmlns:a="http://schemas.openxmlformats.org/drawingml/2006/main"/>
           <a:p xmlns:a="http://schemas.openxmlformats.org/drawingml/2006/main">
             <a:pPr>
+              <a:buNone/>
               <a:defRPr sz="1725" b="0">
                 <a:solidFill>
                   <a:srgbClr val="475569"/>
@@ -7482,6 +7625,7 @@
           <a:lstStyle xmlns:a="http://schemas.openxmlformats.org/drawingml/2006/main"/>
           <a:p xmlns:a="http://schemas.openxmlformats.org/drawingml/2006/main">
             <a:pPr algn="r">
+              <a:buNone/>
               <a:defRPr sz="1125" b="0">
                 <a:solidFill>
                   <a:srgbClr val="475569"/>
@@ -7507,14 +7651,14 @@
       </p:sp>
       <p:pic>
         <p:nvPicPr>
-          <p:cNvPr id="11" name=""/>
+          <p:cNvPr id="13" name=""/>
           <p:cNvPicPr>
             <a:picLocks xmlns:a="http://schemas.openxmlformats.org/drawingml/2006/main" noChangeAspect="1"/>
           </p:cNvPicPr>
           <p:nvPr/>
         </p:nvPicPr>
         <p:blipFill>
-          <a:blip xmlns:r="http://schemas.openxmlformats.org/officeDocument/2006/relationships" xmlns:a="http://schemas.openxmlformats.org/drawingml/2006/main" r:embed="R2f65fdda022b4ad3"/>
+          <a:blip xmlns:r="http://schemas.openxmlformats.org/officeDocument/2006/relationships" xmlns:a="http://schemas.openxmlformats.org/drawingml/2006/main" r:embed="R204fc7d49f764734"/>
           <a:srcRect xmlns:a="http://schemas.openxmlformats.org/drawingml/2006/main" l="0" t="19234" r="0" b="19234"/>
           <a:stretch xmlns:a="http://schemas.openxmlformats.org/drawingml/2006/main">
             <a:fillRect l="0" t="0" r="0" b="0"/>
@@ -7564,6 +7708,7 @@
           <a:lstStyle xmlns:a="http://schemas.openxmlformats.org/drawingml/2006/main"/>
           <a:p xmlns:a="http://schemas.openxmlformats.org/drawingml/2006/main">
             <a:pPr>
+              <a:buNone/>
               <a:defRPr sz="1500" b="0">
                 <a:solidFill>
                   <a:srgbClr val="475569"/>
@@ -7650,6 +7795,7 @@
           <a:lstStyle xmlns:a="http://schemas.openxmlformats.org/drawingml/2006/main"/>
           <a:p xmlns:a="http://schemas.openxmlformats.org/drawingml/2006/main">
             <a:pPr>
+              <a:buNone/>
               <a:defRPr sz="1350" b="1">
                 <a:solidFill>
                   <a:srgbClr val="F37021"/>
@@ -7707,6 +7853,7 @@
           <a:lstStyle xmlns:a="http://schemas.openxmlformats.org/drawingml/2006/main"/>
           <a:p xmlns:a="http://schemas.openxmlformats.org/drawingml/2006/main">
             <a:pPr>
+              <a:buNone/>
               <a:defRPr sz="3150" b="1">
                 <a:solidFill>
                   <a:srgbClr val="002677"/>
@@ -7764,6 +7911,7 @@
           <a:lstStyle xmlns:a="http://schemas.openxmlformats.org/drawingml/2006/main"/>
           <a:p xmlns:a="http://schemas.openxmlformats.org/drawingml/2006/main">
             <a:pPr>
+              <a:buNone/>
               <a:defRPr sz="1725" b="0">
                 <a:solidFill>
                   <a:srgbClr val="475569"/>
@@ -7821,6 +7969,7 @@
           <a:lstStyle xmlns:a="http://schemas.openxmlformats.org/drawingml/2006/main"/>
           <a:p xmlns:a="http://schemas.openxmlformats.org/drawingml/2006/main">
             <a:pPr algn="r">
+              <a:buNone/>
               <a:defRPr sz="1125" b="0">
                 <a:solidFill>
                   <a:srgbClr val="475569"/>
@@ -7846,14 +7995,14 @@
       </p:sp>
       <p:pic>
         <p:nvPicPr>
-          <p:cNvPr id="11" name=""/>
+          <p:cNvPr id="13" name=""/>
           <p:cNvPicPr>
             <a:picLocks xmlns:a="http://schemas.openxmlformats.org/drawingml/2006/main" noChangeAspect="1"/>
           </p:cNvPicPr>
           <p:nvPr/>
         </p:nvPicPr>
         <p:blipFill>
-          <a:blip xmlns:r="http://schemas.openxmlformats.org/officeDocument/2006/relationships" xmlns:a="http://schemas.openxmlformats.org/drawingml/2006/main" r:embed="R3678144cbf9c44b1"/>
+          <a:blip xmlns:r="http://schemas.openxmlformats.org/officeDocument/2006/relationships" xmlns:a="http://schemas.openxmlformats.org/drawingml/2006/main" r:embed="Rdbb0ba1dcb4f4f67"/>
           <a:srcRect xmlns:a="http://schemas.openxmlformats.org/drawingml/2006/main" l="0" t="18218" r="0" b="18218"/>
           <a:stretch xmlns:a="http://schemas.openxmlformats.org/drawingml/2006/main">
             <a:fillRect l="0" t="0" r="0" b="0"/>
@@ -7903,6 +8052,7 @@
           <a:lstStyle xmlns:a="http://schemas.openxmlformats.org/drawingml/2006/main"/>
           <a:p xmlns:a="http://schemas.openxmlformats.org/drawingml/2006/main">
             <a:pPr>
+              <a:buNone/>
               <a:defRPr sz="1500" b="0">
                 <a:solidFill>
                   <a:srgbClr val="475569"/>
@@ -7989,6 +8139,7 @@
           <a:lstStyle xmlns:a="http://schemas.openxmlformats.org/drawingml/2006/main"/>
           <a:p xmlns:a="http://schemas.openxmlformats.org/drawingml/2006/main">
             <a:pPr>
+              <a:buNone/>
               <a:defRPr sz="1350" b="1">
                 <a:solidFill>
                   <a:srgbClr val="F37021"/>
@@ -8046,6 +8197,7 @@
           <a:lstStyle xmlns:a="http://schemas.openxmlformats.org/drawingml/2006/main"/>
           <a:p xmlns:a="http://schemas.openxmlformats.org/drawingml/2006/main">
             <a:pPr>
+              <a:buNone/>
               <a:defRPr sz="3150" b="1">
                 <a:solidFill>
                   <a:srgbClr val="002677"/>
@@ -8103,6 +8255,7 @@
           <a:lstStyle xmlns:a="http://schemas.openxmlformats.org/drawingml/2006/main"/>
           <a:p xmlns:a="http://schemas.openxmlformats.org/drawingml/2006/main">
             <a:pPr>
+              <a:buNone/>
               <a:defRPr sz="1725" b="0">
                 <a:solidFill>
                   <a:srgbClr val="475569"/>
@@ -8160,6 +8313,7 @@
           <a:lstStyle xmlns:a="http://schemas.openxmlformats.org/drawingml/2006/main"/>
           <a:p xmlns:a="http://schemas.openxmlformats.org/drawingml/2006/main">
             <a:pPr algn="r">
+              <a:buNone/>
               <a:defRPr sz="1125" b="0">
                 <a:solidFill>
                   <a:srgbClr val="475569"/>
@@ -8217,6 +8371,7 @@
           <a:lstStyle xmlns:a="http://schemas.openxmlformats.org/drawingml/2006/main"/>
           <a:p xmlns:a="http://schemas.openxmlformats.org/drawingml/2006/main">
             <a:pPr>
+              <a:buNone/>
               <a:defRPr sz="2325" b="0">
                 <a:solidFill>
                   <a:srgbClr val="0F172A"/>
@@ -8274,6 +8429,7 @@
           <a:lstStyle xmlns:a="http://schemas.openxmlformats.org/drawingml/2006/main"/>
           <a:p xmlns:a="http://schemas.openxmlformats.org/drawingml/2006/main">
             <a:pPr>
+              <a:buNone/>
               <a:defRPr sz="1725" b="1">
                 <a:solidFill>
                   <a:srgbClr val="F37021"/>
@@ -8331,6 +8487,7 @@
           <a:lstStyle xmlns:a="http://schemas.openxmlformats.org/drawingml/2006/main"/>
           <a:p xmlns:a="http://schemas.openxmlformats.org/drawingml/2006/main">
             <a:pPr>
+              <a:buNone/>
               <a:defRPr sz="2025" b="1">
                 <a:solidFill>
                   <a:srgbClr val="002677"/>
@@ -8417,6 +8574,7 @@
           <a:lstStyle xmlns:a="http://schemas.openxmlformats.org/drawingml/2006/main"/>
           <a:p xmlns:a="http://schemas.openxmlformats.org/drawingml/2006/main">
             <a:pPr>
+              <a:buNone/>
               <a:defRPr sz="1350" b="1">
                 <a:solidFill>
                   <a:srgbClr val="F37021"/>
@@ -8474,6 +8632,7 @@
           <a:lstStyle xmlns:a="http://schemas.openxmlformats.org/drawingml/2006/main"/>
           <a:p xmlns:a="http://schemas.openxmlformats.org/drawingml/2006/main">
             <a:pPr>
+              <a:buNone/>
               <a:defRPr sz="3150" b="1">
                 <a:solidFill>
                   <a:srgbClr val="002677"/>
@@ -8531,6 +8690,7 @@
           <a:lstStyle xmlns:a="http://schemas.openxmlformats.org/drawingml/2006/main"/>
           <a:p xmlns:a="http://schemas.openxmlformats.org/drawingml/2006/main">
             <a:pPr>
+              <a:buNone/>
               <a:defRPr sz="1725" b="0">
                 <a:solidFill>
                   <a:srgbClr val="475569"/>
@@ -8588,6 +8748,7 @@
           <a:lstStyle xmlns:a="http://schemas.openxmlformats.org/drawingml/2006/main"/>
           <a:p xmlns:a="http://schemas.openxmlformats.org/drawingml/2006/main">
             <a:pPr algn="r">
+              <a:buNone/>
               <a:defRPr sz="1125" b="0">
                 <a:solidFill>
                   <a:srgbClr val="475569"/>
@@ -8613,14 +8774,14 @@
       </p:sp>
       <p:pic>
         <p:nvPicPr>
-          <p:cNvPr id="11" name=""/>
+          <p:cNvPr id="13" name=""/>
           <p:cNvPicPr>
             <a:picLocks xmlns:a="http://schemas.openxmlformats.org/drawingml/2006/main" noChangeAspect="1"/>
           </p:cNvPicPr>
           <p:nvPr/>
         </p:nvPicPr>
         <p:blipFill>
-          <a:blip xmlns:r="http://schemas.openxmlformats.org/officeDocument/2006/relationships" xmlns:a="http://schemas.openxmlformats.org/drawingml/2006/main" r:embed="R2f4a051aebf24477"/>
+          <a:blip xmlns:r="http://schemas.openxmlformats.org/officeDocument/2006/relationships" xmlns:a="http://schemas.openxmlformats.org/drawingml/2006/main" r:embed="Re099aeff32524606"/>
           <a:stretch xmlns:a="http://schemas.openxmlformats.org/drawingml/2006/main"/>
         </p:blipFill>
         <p:spPr>
@@ -8667,6 +8828,7 @@
           <a:lstStyle xmlns:a="http://schemas.openxmlformats.org/drawingml/2006/main"/>
           <a:p xmlns:a="http://schemas.openxmlformats.org/drawingml/2006/main">
             <a:pPr>
+              <a:buNone/>
               <a:defRPr sz="1500" b="0">
                 <a:solidFill>
                   <a:srgbClr val="475569"/>
@@ -8753,6 +8915,7 @@
           <a:lstStyle xmlns:a="http://schemas.openxmlformats.org/drawingml/2006/main"/>
           <a:p xmlns:a="http://schemas.openxmlformats.org/drawingml/2006/main">
             <a:pPr>
+              <a:buNone/>
               <a:defRPr sz="1350" b="1">
                 <a:solidFill>
                   <a:srgbClr val="F37021"/>
@@ -8810,6 +8973,7 @@
           <a:lstStyle xmlns:a="http://schemas.openxmlformats.org/drawingml/2006/main"/>
           <a:p xmlns:a="http://schemas.openxmlformats.org/drawingml/2006/main">
             <a:pPr>
+              <a:buNone/>
               <a:defRPr sz="3150" b="1">
                 <a:solidFill>
                   <a:srgbClr val="002677"/>
@@ -8867,6 +9031,7 @@
           <a:lstStyle xmlns:a="http://schemas.openxmlformats.org/drawingml/2006/main"/>
           <a:p xmlns:a="http://schemas.openxmlformats.org/drawingml/2006/main">
             <a:pPr>
+              <a:buNone/>
               <a:defRPr sz="1725" b="0">
                 <a:solidFill>
                   <a:srgbClr val="475569"/>
@@ -8924,6 +9089,7 @@
           <a:lstStyle xmlns:a="http://schemas.openxmlformats.org/drawingml/2006/main"/>
           <a:p xmlns:a="http://schemas.openxmlformats.org/drawingml/2006/main">
             <a:pPr algn="r">
+              <a:buNone/>
               <a:defRPr sz="1125" b="0">
                 <a:solidFill>
                   <a:srgbClr val="475569"/>
@@ -9011,6 +9177,7 @@
           <a:lstStyle xmlns:a="http://schemas.openxmlformats.org/drawingml/2006/main"/>
           <a:p xmlns:a="http://schemas.openxmlformats.org/drawingml/2006/main">
             <a:pPr>
+              <a:buNone/>
               <a:defRPr sz="1275" b="0">
                 <a:solidFill>
                   <a:srgbClr val="E6F3FF"/>
@@ -9034,6 +9201,7 @@
           </a:p>
           <a:p xmlns:a="http://schemas.openxmlformats.org/drawingml/2006/main">
             <a:pPr>
+              <a:buNone/>
               <a:defRPr sz="1275" b="0">
                 <a:solidFill>
                   <a:srgbClr val="E6F3FF"/>
@@ -9057,6 +9225,7 @@
           </a:p>
           <a:p xmlns:a="http://schemas.openxmlformats.org/drawingml/2006/main">
             <a:pPr>
+              <a:buNone/>
               <a:defRPr sz="1275" b="0">
                 <a:solidFill>
                   <a:srgbClr val="E6F3FF"/>
@@ -9080,6 +9249,7 @@
           </a:p>
           <a:p xmlns:a="http://schemas.openxmlformats.org/drawingml/2006/main">
             <a:pPr>
+              <a:buNone/>
               <a:defRPr sz="1275" b="0">
                 <a:solidFill>
                   <a:srgbClr val="E6F3FF"/>
@@ -9103,6 +9273,7 @@
           </a:p>
           <a:p xmlns:a="http://schemas.openxmlformats.org/drawingml/2006/main">
             <a:pPr>
+              <a:buNone/>
               <a:defRPr sz="1275" b="0">
                 <a:solidFill>
                   <a:srgbClr val="E6F3FF"/>
@@ -9126,6 +9297,7 @@
           </a:p>
           <a:p xmlns:a="http://schemas.openxmlformats.org/drawingml/2006/main">
             <a:pPr>
+              <a:buNone/>
               <a:defRPr sz="1275" b="0">
                 <a:solidFill>
                   <a:srgbClr val="E6F3FF"/>
@@ -9149,6 +9321,7 @@
           </a:p>
           <a:p xmlns:a="http://schemas.openxmlformats.org/drawingml/2006/main">
             <a:pPr>
+              <a:buNone/>
               <a:defRPr sz="1275" b="0">
                 <a:solidFill>
                   <a:srgbClr val="E6F3FF"/>
@@ -9172,6 +9345,7 @@
           </a:p>
           <a:p xmlns:a="http://schemas.openxmlformats.org/drawingml/2006/main">
             <a:pPr>
+              <a:buNone/>
               <a:defRPr sz="1275" b="0">
                 <a:solidFill>
                   <a:srgbClr val="E6F3FF"/>
@@ -9195,6 +9369,7 @@
           </a:p>
           <a:p xmlns:a="http://schemas.openxmlformats.org/drawingml/2006/main">
             <a:pPr>
+              <a:buNone/>
               <a:defRPr sz="1275" b="0">
                 <a:solidFill>
                   <a:srgbClr val="E6F3FF"/>
@@ -9252,6 +9427,7 @@
           <a:lstStyle xmlns:a="http://schemas.openxmlformats.org/drawingml/2006/main"/>
           <a:p xmlns:a="http://schemas.openxmlformats.org/drawingml/2006/main">
             <a:pPr>
+              <a:buNone/>
               <a:defRPr sz="1425" b="1">
                 <a:solidFill>
                   <a:srgbClr val="F37021"/>
@@ -9309,6 +9485,7 @@
           <a:lstStyle xmlns:a="http://schemas.openxmlformats.org/drawingml/2006/main"/>
           <a:p xmlns:a="http://schemas.openxmlformats.org/drawingml/2006/main">
             <a:pPr>
+              <a:buNone/>
               <a:defRPr sz="1725" b="0">
                 <a:solidFill>
                   <a:srgbClr val="0F172A"/>
@@ -9395,6 +9572,7 @@
           <a:lstStyle xmlns:a="http://schemas.openxmlformats.org/drawingml/2006/main"/>
           <a:p xmlns:a="http://schemas.openxmlformats.org/drawingml/2006/main">
             <a:pPr>
+              <a:buNone/>
               <a:defRPr sz="1350" b="1">
                 <a:solidFill>
                   <a:srgbClr val="F37021"/>
@@ -9452,6 +9630,7 @@
           <a:lstStyle xmlns:a="http://schemas.openxmlformats.org/drawingml/2006/main"/>
           <a:p xmlns:a="http://schemas.openxmlformats.org/drawingml/2006/main">
             <a:pPr>
+              <a:buNone/>
               <a:defRPr sz="3150" b="1">
                 <a:solidFill>
                   <a:srgbClr val="002677"/>
@@ -9509,6 +9688,7 @@
           <a:lstStyle xmlns:a="http://schemas.openxmlformats.org/drawingml/2006/main"/>
           <a:p xmlns:a="http://schemas.openxmlformats.org/drawingml/2006/main">
             <a:pPr>
+              <a:buNone/>
               <a:defRPr sz="1725" b="0">
                 <a:solidFill>
                   <a:srgbClr val="475569"/>
@@ -9566,6 +9746,7 @@
           <a:lstStyle xmlns:a="http://schemas.openxmlformats.org/drawingml/2006/main"/>
           <a:p xmlns:a="http://schemas.openxmlformats.org/drawingml/2006/main">
             <a:pPr algn="r">
+              <a:buNone/>
               <a:defRPr sz="1125" b="0">
                 <a:solidFill>
                   <a:srgbClr val="475569"/>
@@ -9591,14 +9772,14 @@
       </p:sp>
       <p:pic>
         <p:nvPicPr>
-          <p:cNvPr id="11" name=""/>
+          <p:cNvPr id="13" name=""/>
           <p:cNvPicPr>
             <a:picLocks xmlns:a="http://schemas.openxmlformats.org/drawingml/2006/main" noChangeAspect="1"/>
           </p:cNvPicPr>
           <p:nvPr/>
         </p:nvPicPr>
         <p:blipFill>
-          <a:blip xmlns:r="http://schemas.openxmlformats.org/officeDocument/2006/relationships" xmlns:a="http://schemas.openxmlformats.org/drawingml/2006/main" r:embed="R0641fc7193f44069"/>
+          <a:blip xmlns:r="http://schemas.openxmlformats.org/officeDocument/2006/relationships" xmlns:a="http://schemas.openxmlformats.org/drawingml/2006/main" r:embed="R4ef45ec04f5245af"/>
           <a:srcRect xmlns:a="http://schemas.openxmlformats.org/drawingml/2006/main" l="0" t="19234" r="0" b="19234"/>
           <a:stretch xmlns:a="http://schemas.openxmlformats.org/drawingml/2006/main">
             <a:fillRect l="0" t="0" r="0" b="0"/>
@@ -9648,6 +9829,7 @@
           <a:lstStyle xmlns:a="http://schemas.openxmlformats.org/drawingml/2006/main"/>
           <a:p xmlns:a="http://schemas.openxmlformats.org/drawingml/2006/main">
             <a:pPr>
+              <a:buNone/>
               <a:defRPr sz="1500" b="0">
                 <a:solidFill>
                   <a:srgbClr val="475569"/>
@@ -9666,7 +9848,7 @@
                 <a:ea typeface="Calibri"/>
                 <a:cs typeface="Calibri"/>
               </a:rPr>
-              <a:t>Perintah: edit site/index.html, lalu refresh 127.0.0.1:8088. Image ID tetap; RW=false.</a:t>
+              <a:t>Edit site/index.html lalu refresh: bind mount memasok file baru tanpa build image; inspect tetap RW=false.</a:t>
             </a:r>
           </a:p>
         </p:txBody>
@@ -9734,6 +9916,7 @@
           <a:lstStyle xmlns:a="http://schemas.openxmlformats.org/drawingml/2006/main"/>
           <a:p xmlns:a="http://schemas.openxmlformats.org/drawingml/2006/main">
             <a:pPr>
+              <a:buNone/>
               <a:defRPr sz="1350" b="1">
                 <a:solidFill>
                   <a:srgbClr val="F37021"/>
@@ -9791,6 +9974,7 @@
           <a:lstStyle xmlns:a="http://schemas.openxmlformats.org/drawingml/2006/main"/>
           <a:p xmlns:a="http://schemas.openxmlformats.org/drawingml/2006/main">
             <a:pPr>
+              <a:buNone/>
               <a:defRPr sz="3150" b="1">
                 <a:solidFill>
                   <a:srgbClr val="002677"/>
@@ -9848,6 +10032,7 @@
           <a:lstStyle xmlns:a="http://schemas.openxmlformats.org/drawingml/2006/main"/>
           <a:p xmlns:a="http://schemas.openxmlformats.org/drawingml/2006/main">
             <a:pPr>
+              <a:buNone/>
               <a:defRPr sz="1725" b="0">
                 <a:solidFill>
                   <a:srgbClr val="475569"/>
@@ -9905,6 +10090,7 @@
           <a:lstStyle xmlns:a="http://schemas.openxmlformats.org/drawingml/2006/main"/>
           <a:p xmlns:a="http://schemas.openxmlformats.org/drawingml/2006/main">
             <a:pPr algn="r">
+              <a:buNone/>
               <a:defRPr sz="1125" b="0">
                 <a:solidFill>
                   <a:srgbClr val="475569"/>
@@ -9992,6 +10178,7 @@
           <a:lstStyle xmlns:a="http://schemas.openxmlformats.org/drawingml/2006/main"/>
           <a:p xmlns:a="http://schemas.openxmlformats.org/drawingml/2006/main">
             <a:pPr>
+              <a:buNone/>
               <a:defRPr sz="1425" b="0">
                 <a:solidFill>
                   <a:srgbClr val="E6F3FF"/>
@@ -10015,6 +10202,7 @@
           </a:p>
           <a:p xmlns:a="http://schemas.openxmlformats.org/drawingml/2006/main">
             <a:pPr>
+              <a:buNone/>
               <a:defRPr sz="1425" b="0">
                 <a:solidFill>
                   <a:srgbClr val="E6F3FF"/>
@@ -10038,6 +10226,7 @@
           </a:p>
           <a:p xmlns:a="http://schemas.openxmlformats.org/drawingml/2006/main">
             <a:pPr>
+              <a:buNone/>
               <a:defRPr sz="1425" b="0">
                 <a:solidFill>
                   <a:srgbClr val="E6F3FF"/>
@@ -10061,6 +10250,7 @@
           </a:p>
           <a:p xmlns:a="http://schemas.openxmlformats.org/drawingml/2006/main">
             <a:pPr>
+              <a:buNone/>
               <a:defRPr sz="1425" b="0">
                 <a:solidFill>
                   <a:srgbClr val="E6F3FF"/>
@@ -10084,6 +10274,7 @@
           </a:p>
           <a:p xmlns:a="http://schemas.openxmlformats.org/drawingml/2006/main">
             <a:pPr>
+              <a:buNone/>
               <a:defRPr sz="1425" b="0">
                 <a:solidFill>
                   <a:srgbClr val="E6F3FF"/>
@@ -10107,6 +10298,7 @@
           </a:p>
           <a:p xmlns:a="http://schemas.openxmlformats.org/drawingml/2006/main">
             <a:pPr>
+              <a:buNone/>
               <a:defRPr sz="1425" b="0">
                 <a:solidFill>
                   <a:srgbClr val="E6F3FF"/>
@@ -10130,6 +10322,7 @@
           </a:p>
           <a:p xmlns:a="http://schemas.openxmlformats.org/drawingml/2006/main">
             <a:pPr>
+              <a:buNone/>
               <a:defRPr sz="1425" b="0">
                 <a:solidFill>
                   <a:srgbClr val="E6F3FF"/>
@@ -10187,6 +10380,7 @@
           <a:lstStyle xmlns:a="http://schemas.openxmlformats.org/drawingml/2006/main"/>
           <a:p xmlns:a="http://schemas.openxmlformats.org/drawingml/2006/main">
             <a:pPr>
+              <a:buNone/>
               <a:defRPr sz="1425" b="1">
                 <a:solidFill>
                   <a:srgbClr val="F37021"/>
@@ -10244,6 +10438,7 @@
           <a:lstStyle xmlns:a="http://schemas.openxmlformats.org/drawingml/2006/main"/>
           <a:p xmlns:a="http://schemas.openxmlformats.org/drawingml/2006/main">
             <a:pPr>
+              <a:buNone/>
               <a:defRPr sz="1725" b="0">
                 <a:solidFill>
                   <a:srgbClr val="0F172A"/>
@@ -10330,6 +10525,7 @@
           <a:lstStyle xmlns:a="http://schemas.openxmlformats.org/drawingml/2006/main"/>
           <a:p xmlns:a="http://schemas.openxmlformats.org/drawingml/2006/main">
             <a:pPr>
+              <a:buNone/>
               <a:defRPr sz="1350" b="1">
                 <a:solidFill>
                   <a:srgbClr val="F37021"/>
@@ -10387,6 +10583,7 @@
           <a:lstStyle xmlns:a="http://schemas.openxmlformats.org/drawingml/2006/main"/>
           <a:p xmlns:a="http://schemas.openxmlformats.org/drawingml/2006/main">
             <a:pPr>
+              <a:buNone/>
               <a:defRPr sz="3150" b="1">
                 <a:solidFill>
                   <a:srgbClr val="002677"/>
@@ -10444,6 +10641,7 @@
           <a:lstStyle xmlns:a="http://schemas.openxmlformats.org/drawingml/2006/main"/>
           <a:p xmlns:a="http://schemas.openxmlformats.org/drawingml/2006/main">
             <a:pPr>
+              <a:buNone/>
               <a:defRPr sz="1725" b="0">
                 <a:solidFill>
                   <a:srgbClr val="475569"/>
@@ -10501,6 +10699,7 @@
           <a:lstStyle xmlns:a="http://schemas.openxmlformats.org/drawingml/2006/main"/>
           <a:p xmlns:a="http://schemas.openxmlformats.org/drawingml/2006/main">
             <a:pPr algn="r">
+              <a:buNone/>
               <a:defRPr sz="1125" b="0">
                 <a:solidFill>
                   <a:srgbClr val="475569"/>
@@ -10526,14 +10725,14 @@
       </p:sp>
       <p:pic>
         <p:nvPicPr>
-          <p:cNvPr id="11" name=""/>
+          <p:cNvPr id="13" name=""/>
           <p:cNvPicPr>
             <a:picLocks xmlns:a="http://schemas.openxmlformats.org/drawingml/2006/main" noChangeAspect="1"/>
           </p:cNvPicPr>
           <p:nvPr/>
         </p:nvPicPr>
         <p:blipFill>
-          <a:blip xmlns:r="http://schemas.openxmlformats.org/officeDocument/2006/relationships" xmlns:a="http://schemas.openxmlformats.org/drawingml/2006/main" r:embed="R438919cd6fda4c46"/>
+          <a:blip xmlns:r="http://schemas.openxmlformats.org/officeDocument/2006/relationships" xmlns:a="http://schemas.openxmlformats.org/drawingml/2006/main" r:embed="Raa64c4a5086c4ef2"/>
           <a:stretch xmlns:a="http://schemas.openxmlformats.org/drawingml/2006/main"/>
         </p:blipFill>
         <p:spPr>
@@ -10580,6 +10779,7 @@
           <a:lstStyle xmlns:a="http://schemas.openxmlformats.org/drawingml/2006/main"/>
           <a:p xmlns:a="http://schemas.openxmlformats.org/drawingml/2006/main">
             <a:pPr>
+              <a:buNone/>
               <a:defRPr sz="1500" b="0">
                 <a:solidFill>
                   <a:srgbClr val="475569"/>
@@ -10666,6 +10866,7 @@
           <a:lstStyle xmlns:a="http://schemas.openxmlformats.org/drawingml/2006/main"/>
           <a:p xmlns:a="http://schemas.openxmlformats.org/drawingml/2006/main">
             <a:pPr>
+              <a:buNone/>
               <a:defRPr sz="1350" b="1">
                 <a:solidFill>
                   <a:srgbClr val="F37021"/>
@@ -10723,6 +10924,7 @@
           <a:lstStyle xmlns:a="http://schemas.openxmlformats.org/drawingml/2006/main"/>
           <a:p xmlns:a="http://schemas.openxmlformats.org/drawingml/2006/main">
             <a:pPr>
+              <a:buNone/>
               <a:defRPr sz="3150" b="1">
                 <a:solidFill>
                   <a:srgbClr val="002677"/>
@@ -10780,6 +10982,7 @@
           <a:lstStyle xmlns:a="http://schemas.openxmlformats.org/drawingml/2006/main"/>
           <a:p xmlns:a="http://schemas.openxmlformats.org/drawingml/2006/main">
             <a:pPr>
+              <a:buNone/>
               <a:defRPr sz="1725" b="0">
                 <a:solidFill>
                   <a:srgbClr val="475569"/>
@@ -10837,6 +11040,7 @@
           <a:lstStyle xmlns:a="http://schemas.openxmlformats.org/drawingml/2006/main"/>
           <a:p xmlns:a="http://schemas.openxmlformats.org/drawingml/2006/main">
             <a:pPr algn="r">
+              <a:buNone/>
               <a:defRPr sz="1125" b="0">
                 <a:solidFill>
                   <a:srgbClr val="475569"/>
@@ -10862,14 +11066,14 @@
       </p:sp>
       <p:pic>
         <p:nvPicPr>
-          <p:cNvPr id="11" name=""/>
+          <p:cNvPr id="13" name=""/>
           <p:cNvPicPr>
             <a:picLocks xmlns:a="http://schemas.openxmlformats.org/drawingml/2006/main" noChangeAspect="1"/>
           </p:cNvPicPr>
           <p:nvPr/>
         </p:nvPicPr>
         <p:blipFill>
-          <a:blip xmlns:r="http://schemas.openxmlformats.org/officeDocument/2006/relationships" xmlns:a="http://schemas.openxmlformats.org/drawingml/2006/main" r:embed="R05da0a6921d84457"/>
+          <a:blip xmlns:r="http://schemas.openxmlformats.org/officeDocument/2006/relationships" xmlns:a="http://schemas.openxmlformats.org/drawingml/2006/main" r:embed="R8fa711a1b7bf4f6a"/>
           <a:stretch xmlns:a="http://schemas.openxmlformats.org/drawingml/2006/main"/>
         </p:blipFill>
         <p:spPr>
@@ -10916,6 +11120,7 @@
           <a:lstStyle xmlns:a="http://schemas.openxmlformats.org/drawingml/2006/main"/>
           <a:p xmlns:a="http://schemas.openxmlformats.org/drawingml/2006/main">
             <a:pPr>
+              <a:buNone/>
               <a:defRPr sz="1500" b="0">
                 <a:solidFill>
                   <a:srgbClr val="475569"/>
@@ -10934,7 +11139,7 @@
                 <a:ea typeface="Calibri"/>
                 <a:cs typeface="Calibri"/>
               </a:rPr>
-              <a:t>Perintah: docker rm -f cloudlab-canary, lalu run pada 8089. Uji curl 8088 dan 8089.</a:t>
+              <a:t>docker rm -f membersihkan canary gagal; -p 8089:80 membuka port host baru. curl -I menguji kedua URL.</a:t>
             </a:r>
           </a:p>
         </p:txBody>
@@ -11002,6 +11207,7 @@
           <a:lstStyle xmlns:a="http://schemas.openxmlformats.org/drawingml/2006/main"/>
           <a:p xmlns:a="http://schemas.openxmlformats.org/drawingml/2006/main">
             <a:pPr>
+              <a:buNone/>
               <a:defRPr sz="1350" b="1">
                 <a:solidFill>
                   <a:srgbClr val="F37021"/>
@@ -11059,6 +11265,7 @@
           <a:lstStyle xmlns:a="http://schemas.openxmlformats.org/drawingml/2006/main"/>
           <a:p xmlns:a="http://schemas.openxmlformats.org/drawingml/2006/main">
             <a:pPr>
+              <a:buNone/>
               <a:defRPr sz="3150" b="1">
                 <a:solidFill>
                   <a:srgbClr val="002677"/>
@@ -11116,6 +11323,7 @@
           <a:lstStyle xmlns:a="http://schemas.openxmlformats.org/drawingml/2006/main"/>
           <a:p xmlns:a="http://schemas.openxmlformats.org/drawingml/2006/main">
             <a:pPr>
+              <a:buNone/>
               <a:defRPr sz="1725" b="0">
                 <a:solidFill>
                   <a:srgbClr val="475569"/>
@@ -11173,6 +11381,7 @@
           <a:lstStyle xmlns:a="http://schemas.openxmlformats.org/drawingml/2006/main"/>
           <a:p xmlns:a="http://schemas.openxmlformats.org/drawingml/2006/main">
             <a:pPr algn="r">
+              <a:buNone/>
               <a:defRPr sz="1125" b="0">
                 <a:solidFill>
                   <a:srgbClr val="475569"/>
@@ -11198,14 +11407,14 @@
       </p:sp>
       <p:pic>
         <p:nvPicPr>
-          <p:cNvPr id="11" name=""/>
+          <p:cNvPr id="13" name=""/>
           <p:cNvPicPr>
             <a:picLocks xmlns:a="http://schemas.openxmlformats.org/drawingml/2006/main" noChangeAspect="1"/>
           </p:cNvPicPr>
           <p:nvPr/>
         </p:nvPicPr>
         <p:blipFill>
-          <a:blip xmlns:r="http://schemas.openxmlformats.org/officeDocument/2006/relationships" xmlns:a="http://schemas.openxmlformats.org/drawingml/2006/main" r:embed="R1deca296a71548f4"/>
+          <a:blip xmlns:r="http://schemas.openxmlformats.org/officeDocument/2006/relationships" xmlns:a="http://schemas.openxmlformats.org/drawingml/2006/main" r:embed="R9a58a3f3cbe34fd9"/>
           <a:srcRect xmlns:a="http://schemas.openxmlformats.org/drawingml/2006/main" l="0" t="18218" r="0" b="18218"/>
           <a:stretch xmlns:a="http://schemas.openxmlformats.org/drawingml/2006/main">
             <a:fillRect l="0" t="0" r="0" b="0"/>
@@ -11255,6 +11464,7 @@
           <a:lstStyle xmlns:a="http://schemas.openxmlformats.org/drawingml/2006/main"/>
           <a:p xmlns:a="http://schemas.openxmlformats.org/drawingml/2006/main">
             <a:pPr>
+              <a:buNone/>
               <a:defRPr sz="1500" b="0">
                 <a:solidFill>
                   <a:srgbClr val="475569"/>
@@ -11341,6 +11551,7 @@
           <a:lstStyle xmlns:a="http://schemas.openxmlformats.org/drawingml/2006/main"/>
           <a:p xmlns:a="http://schemas.openxmlformats.org/drawingml/2006/main">
             <a:pPr>
+              <a:buNone/>
               <a:defRPr sz="1350" b="1">
                 <a:solidFill>
                   <a:srgbClr val="F37021"/>
@@ -11398,6 +11609,7 @@
           <a:lstStyle xmlns:a="http://schemas.openxmlformats.org/drawingml/2006/main"/>
           <a:p xmlns:a="http://schemas.openxmlformats.org/drawingml/2006/main">
             <a:pPr>
+              <a:buNone/>
               <a:defRPr sz="3150" b="1">
                 <a:solidFill>
                   <a:srgbClr val="002677"/>
@@ -11455,6 +11667,7 @@
           <a:lstStyle xmlns:a="http://schemas.openxmlformats.org/drawingml/2006/main"/>
           <a:p xmlns:a="http://schemas.openxmlformats.org/drawingml/2006/main">
             <a:pPr>
+              <a:buNone/>
               <a:defRPr sz="1725" b="0">
                 <a:solidFill>
                   <a:srgbClr val="475569"/>
@@ -11512,6 +11725,7 @@
           <a:lstStyle xmlns:a="http://schemas.openxmlformats.org/drawingml/2006/main"/>
           <a:p xmlns:a="http://schemas.openxmlformats.org/drawingml/2006/main">
             <a:pPr algn="r">
+              <a:buNone/>
               <a:defRPr sz="1125" b="0">
                 <a:solidFill>
                   <a:srgbClr val="475569"/>
@@ -11569,6 +11783,7 @@
           <a:lstStyle xmlns:a="http://schemas.openxmlformats.org/drawingml/2006/main"/>
           <a:p xmlns:a="http://schemas.openxmlformats.org/drawingml/2006/main">
             <a:pPr>
+              <a:buNone/>
               <a:defRPr sz="2400" b="1">
                 <a:solidFill>
                   <a:srgbClr val="F37021"/>
@@ -11626,6 +11841,7 @@
           <a:lstStyle xmlns:a="http://schemas.openxmlformats.org/drawingml/2006/main"/>
           <a:p xmlns:a="http://schemas.openxmlformats.org/drawingml/2006/main">
             <a:pPr>
+              <a:buNone/>
               <a:defRPr sz="2025" b="0">
                 <a:solidFill>
                   <a:srgbClr val="0F172A"/>
@@ -11683,6 +11899,7 @@
           <a:lstStyle xmlns:a="http://schemas.openxmlformats.org/drawingml/2006/main"/>
           <a:p xmlns:a="http://schemas.openxmlformats.org/drawingml/2006/main">
             <a:pPr>
+              <a:buNone/>
               <a:defRPr sz="2400" b="1">
                 <a:solidFill>
                   <a:srgbClr val="F37021"/>
@@ -11740,6 +11957,7 @@
           <a:lstStyle xmlns:a="http://schemas.openxmlformats.org/drawingml/2006/main"/>
           <a:p xmlns:a="http://schemas.openxmlformats.org/drawingml/2006/main">
             <a:pPr>
+              <a:buNone/>
               <a:defRPr sz="2025" b="0">
                 <a:solidFill>
                   <a:srgbClr val="0F172A"/>
@@ -11797,6 +12015,7 @@
           <a:lstStyle xmlns:a="http://schemas.openxmlformats.org/drawingml/2006/main"/>
           <a:p xmlns:a="http://schemas.openxmlformats.org/drawingml/2006/main">
             <a:pPr>
+              <a:buNone/>
               <a:defRPr sz="2400" b="1">
                 <a:solidFill>
                   <a:srgbClr val="F37021"/>
@@ -11854,6 +12073,7 @@
           <a:lstStyle xmlns:a="http://schemas.openxmlformats.org/drawingml/2006/main"/>
           <a:p xmlns:a="http://schemas.openxmlformats.org/drawingml/2006/main">
             <a:pPr>
+              <a:buNone/>
               <a:defRPr sz="2025" b="0">
                 <a:solidFill>
                   <a:srgbClr val="0F172A"/>
@@ -11911,6 +12131,7 @@
           <a:lstStyle xmlns:a="http://schemas.openxmlformats.org/drawingml/2006/main"/>
           <a:p xmlns:a="http://schemas.openxmlformats.org/drawingml/2006/main">
             <a:pPr>
+              <a:buNone/>
               <a:defRPr sz="2400" b="1">
                 <a:solidFill>
                   <a:srgbClr val="F37021"/>
@@ -11968,6 +12189,7 @@
           <a:lstStyle xmlns:a="http://schemas.openxmlformats.org/drawingml/2006/main"/>
           <a:p xmlns:a="http://schemas.openxmlformats.org/drawingml/2006/main">
             <a:pPr>
+              <a:buNone/>
               <a:defRPr sz="2025" b="0">
                 <a:solidFill>
                   <a:srgbClr val="0F172A"/>
@@ -12025,6 +12247,7 @@
           <a:lstStyle xmlns:a="http://schemas.openxmlformats.org/drawingml/2006/main"/>
           <a:p xmlns:a="http://schemas.openxmlformats.org/drawingml/2006/main">
             <a:pPr>
+              <a:buNone/>
               <a:defRPr sz="2400" b="1">
                 <a:solidFill>
                   <a:srgbClr val="F37021"/>
@@ -12082,6 +12305,7 @@
           <a:lstStyle xmlns:a="http://schemas.openxmlformats.org/drawingml/2006/main"/>
           <a:p xmlns:a="http://schemas.openxmlformats.org/drawingml/2006/main">
             <a:pPr>
+              <a:buNone/>
               <a:defRPr sz="2025" b="0">
                 <a:solidFill>
                   <a:srgbClr val="0F172A"/>
@@ -12168,6 +12392,7 @@
           <a:lstStyle xmlns:a="http://schemas.openxmlformats.org/drawingml/2006/main"/>
           <a:p xmlns:a="http://schemas.openxmlformats.org/drawingml/2006/main">
             <a:pPr>
+              <a:buNone/>
               <a:defRPr sz="1350" b="1">
                 <a:solidFill>
                   <a:srgbClr val="F37021"/>
@@ -12225,6 +12450,7 @@
           <a:lstStyle xmlns:a="http://schemas.openxmlformats.org/drawingml/2006/main"/>
           <a:p xmlns:a="http://schemas.openxmlformats.org/drawingml/2006/main">
             <a:pPr>
+              <a:buNone/>
               <a:defRPr sz="3150" b="1">
                 <a:solidFill>
                   <a:srgbClr val="002677"/>
@@ -12282,6 +12508,7 @@
           <a:lstStyle xmlns:a="http://schemas.openxmlformats.org/drawingml/2006/main"/>
           <a:p xmlns:a="http://schemas.openxmlformats.org/drawingml/2006/main">
             <a:pPr>
+              <a:buNone/>
               <a:defRPr sz="1725" b="0">
                 <a:solidFill>
                   <a:srgbClr val="475569"/>
@@ -12339,6 +12566,7 @@
           <a:lstStyle xmlns:a="http://schemas.openxmlformats.org/drawingml/2006/main"/>
           <a:p xmlns:a="http://schemas.openxmlformats.org/drawingml/2006/main">
             <a:pPr algn="r">
+              <a:buNone/>
               <a:defRPr sz="1125" b="0">
                 <a:solidFill>
                   <a:srgbClr val="475569"/>
@@ -12426,6 +12654,7 @@
           <a:lstStyle xmlns:a="http://schemas.openxmlformats.org/drawingml/2006/main"/>
           <a:p xmlns:a="http://schemas.openxmlformats.org/drawingml/2006/main">
             <a:pPr>
+              <a:buNone/>
               <a:defRPr sz="1875" b="0">
                 <a:solidFill>
                   <a:srgbClr val="E6F3FF"/>
@@ -12449,6 +12678,7 @@
           </a:p>
           <a:p xmlns:a="http://schemas.openxmlformats.org/drawingml/2006/main">
             <a:pPr>
+              <a:buNone/>
               <a:defRPr sz="1875" b="0">
                 <a:solidFill>
                   <a:srgbClr val="E6F3FF"/>
@@ -12477,6 +12707,7 @@
           </a:p>
           <a:p xmlns:a="http://schemas.openxmlformats.org/drawingml/2006/main">
             <a:pPr>
+              <a:buNone/>
               <a:defRPr sz="1875" b="0">
                 <a:solidFill>
                   <a:srgbClr val="E6F3FF"/>
@@ -12500,6 +12731,7 @@
           </a:p>
           <a:p xmlns:a="http://schemas.openxmlformats.org/drawingml/2006/main">
             <a:pPr>
+              <a:buNone/>
               <a:defRPr sz="1875" b="0">
                 <a:solidFill>
                   <a:srgbClr val="E6F3FF"/>
@@ -12557,6 +12789,7 @@
           <a:lstStyle xmlns:a="http://schemas.openxmlformats.org/drawingml/2006/main"/>
           <a:p xmlns:a="http://schemas.openxmlformats.org/drawingml/2006/main">
             <a:pPr>
+              <a:buNone/>
               <a:defRPr sz="1425" b="1">
                 <a:solidFill>
                   <a:srgbClr val="F37021"/>
@@ -12614,6 +12847,7 @@
           <a:lstStyle xmlns:a="http://schemas.openxmlformats.org/drawingml/2006/main"/>
           <a:p xmlns:a="http://schemas.openxmlformats.org/drawingml/2006/main">
             <a:pPr>
+              <a:buNone/>
               <a:defRPr sz="1725" b="0">
                 <a:solidFill>
                   <a:srgbClr val="0F172A"/>
@@ -12700,6 +12934,7 @@
           <a:lstStyle xmlns:a="http://schemas.openxmlformats.org/drawingml/2006/main"/>
           <a:p xmlns:a="http://schemas.openxmlformats.org/drawingml/2006/main">
             <a:pPr>
+              <a:buNone/>
               <a:defRPr sz="1350" b="1">
                 <a:solidFill>
                   <a:srgbClr val="F37021"/>
@@ -12757,6 +12992,7 @@
           <a:lstStyle xmlns:a="http://schemas.openxmlformats.org/drawingml/2006/main"/>
           <a:p xmlns:a="http://schemas.openxmlformats.org/drawingml/2006/main">
             <a:pPr>
+              <a:buNone/>
               <a:defRPr sz="3150" b="1">
                 <a:solidFill>
                   <a:srgbClr val="002677"/>
@@ -12814,6 +13050,7 @@
           <a:lstStyle xmlns:a="http://schemas.openxmlformats.org/drawingml/2006/main"/>
           <a:p xmlns:a="http://schemas.openxmlformats.org/drawingml/2006/main">
             <a:pPr>
+              <a:buNone/>
               <a:defRPr sz="1725" b="0">
                 <a:solidFill>
                   <a:srgbClr val="475569"/>
@@ -12871,6 +13108,7 @@
           <a:lstStyle xmlns:a="http://schemas.openxmlformats.org/drawingml/2006/main"/>
           <a:p xmlns:a="http://schemas.openxmlformats.org/drawingml/2006/main">
             <a:pPr algn="r">
+              <a:buNone/>
               <a:defRPr sz="1125" b="0">
                 <a:solidFill>
                   <a:srgbClr val="475569"/>
@@ -12896,14 +13134,14 @@
       </p:sp>
       <p:pic>
         <p:nvPicPr>
-          <p:cNvPr id="11" name=""/>
+          <p:cNvPr id="13" name=""/>
           <p:cNvPicPr>
             <a:picLocks xmlns:a="http://schemas.openxmlformats.org/drawingml/2006/main" noChangeAspect="1"/>
           </p:cNvPicPr>
           <p:nvPr/>
         </p:nvPicPr>
         <p:blipFill>
-          <a:blip xmlns:r="http://schemas.openxmlformats.org/officeDocument/2006/relationships" xmlns:a="http://schemas.openxmlformats.org/drawingml/2006/main" r:embed="R3a87d9c36b3f4be4"/>
+          <a:blip xmlns:r="http://schemas.openxmlformats.org/officeDocument/2006/relationships" xmlns:a="http://schemas.openxmlformats.org/drawingml/2006/main" r:embed="Rbeee3fc78be34558"/>
           <a:stretch xmlns:a="http://schemas.openxmlformats.org/drawingml/2006/main"/>
         </p:blipFill>
         <p:spPr>
@@ -12950,6 +13188,7 @@
           <a:lstStyle xmlns:a="http://schemas.openxmlformats.org/drawingml/2006/main"/>
           <a:p xmlns:a="http://schemas.openxmlformats.org/drawingml/2006/main">
             <a:pPr>
+              <a:buNone/>
               <a:defRPr sz="1500" b="0">
                 <a:solidFill>
                   <a:srgbClr val="475569"/>
@@ -13036,6 +13275,7 @@
           <a:lstStyle xmlns:a="http://schemas.openxmlformats.org/drawingml/2006/main"/>
           <a:p xmlns:a="http://schemas.openxmlformats.org/drawingml/2006/main">
             <a:pPr>
+              <a:buNone/>
               <a:defRPr sz="1350" b="1">
                 <a:solidFill>
                   <a:srgbClr val="F37021"/>
@@ -13093,6 +13333,7 @@
           <a:lstStyle xmlns:a="http://schemas.openxmlformats.org/drawingml/2006/main"/>
           <a:p xmlns:a="http://schemas.openxmlformats.org/drawingml/2006/main">
             <a:pPr>
+              <a:buNone/>
               <a:defRPr sz="3150" b="1">
                 <a:solidFill>
                   <a:srgbClr val="002677"/>
@@ -13150,6 +13391,7 @@
           <a:lstStyle xmlns:a="http://schemas.openxmlformats.org/drawingml/2006/main"/>
           <a:p xmlns:a="http://schemas.openxmlformats.org/drawingml/2006/main">
             <a:pPr>
+              <a:buNone/>
               <a:defRPr sz="1725" b="0">
                 <a:solidFill>
                   <a:srgbClr val="475569"/>
@@ -13207,6 +13449,7 @@
           <a:lstStyle xmlns:a="http://schemas.openxmlformats.org/drawingml/2006/main"/>
           <a:p xmlns:a="http://schemas.openxmlformats.org/drawingml/2006/main">
             <a:pPr algn="r">
+              <a:buNone/>
               <a:defRPr sz="1125" b="0">
                 <a:solidFill>
                   <a:srgbClr val="475569"/>
@@ -13264,6 +13507,7 @@
           <a:lstStyle xmlns:a="http://schemas.openxmlformats.org/drawingml/2006/main"/>
           <a:p xmlns:a="http://schemas.openxmlformats.org/drawingml/2006/main">
             <a:pPr>
+              <a:buNone/>
               <a:defRPr sz="2025" b="1">
                 <a:solidFill>
                   <a:srgbClr val="F37021"/>
@@ -13321,6 +13565,7 @@
           <a:lstStyle xmlns:a="http://schemas.openxmlformats.org/drawingml/2006/main"/>
           <a:p xmlns:a="http://schemas.openxmlformats.org/drawingml/2006/main">
             <a:pPr>
+              <a:buNone/>
               <a:defRPr sz="2100" b="0">
                 <a:solidFill>
                   <a:srgbClr val="0F172A"/>
@@ -13378,6 +13623,7 @@
           <a:lstStyle xmlns:a="http://schemas.openxmlformats.org/drawingml/2006/main"/>
           <a:p xmlns:a="http://schemas.openxmlformats.org/drawingml/2006/main">
             <a:pPr>
+              <a:buNone/>
               <a:defRPr sz="2025" b="1">
                 <a:solidFill>
                   <a:srgbClr val="F37021"/>
@@ -13435,6 +13681,7 @@
           <a:lstStyle xmlns:a="http://schemas.openxmlformats.org/drawingml/2006/main"/>
           <a:p xmlns:a="http://schemas.openxmlformats.org/drawingml/2006/main">
             <a:pPr>
+              <a:buNone/>
               <a:defRPr sz="2100" b="0">
                 <a:solidFill>
                   <a:srgbClr val="0F172A"/>
@@ -13492,6 +13739,7 @@
           <a:lstStyle xmlns:a="http://schemas.openxmlformats.org/drawingml/2006/main"/>
           <a:p xmlns:a="http://schemas.openxmlformats.org/drawingml/2006/main">
             <a:pPr>
+              <a:buNone/>
               <a:defRPr sz="2025" b="1">
                 <a:solidFill>
                   <a:srgbClr val="002677"/>
@@ -13549,6 +13797,7 @@
           <a:lstStyle xmlns:a="http://schemas.openxmlformats.org/drawingml/2006/main"/>
           <a:p xmlns:a="http://schemas.openxmlformats.org/drawingml/2006/main">
             <a:pPr>
+              <a:buNone/>
               <a:defRPr sz="1950" b="0">
                 <a:solidFill>
                   <a:srgbClr val="0F172A"/>
@@ -13635,6 +13884,7 @@
           <a:lstStyle xmlns:a="http://schemas.openxmlformats.org/drawingml/2006/main"/>
           <a:p xmlns:a="http://schemas.openxmlformats.org/drawingml/2006/main">
             <a:pPr>
+              <a:buNone/>
               <a:defRPr sz="1350" b="1">
                 <a:solidFill>
                   <a:srgbClr val="F37021"/>
@@ -13692,6 +13942,7 @@
           <a:lstStyle xmlns:a="http://schemas.openxmlformats.org/drawingml/2006/main"/>
           <a:p xmlns:a="http://schemas.openxmlformats.org/drawingml/2006/main">
             <a:pPr>
+              <a:buNone/>
               <a:defRPr sz="3150" b="1">
                 <a:solidFill>
                   <a:srgbClr val="002677"/>
@@ -13749,6 +14000,7 @@
           <a:lstStyle xmlns:a="http://schemas.openxmlformats.org/drawingml/2006/main"/>
           <a:p xmlns:a="http://schemas.openxmlformats.org/drawingml/2006/main">
             <a:pPr>
+              <a:buNone/>
               <a:defRPr sz="1725" b="0">
                 <a:solidFill>
                   <a:srgbClr val="475569"/>
@@ -13806,6 +14058,7 @@
           <a:lstStyle xmlns:a="http://schemas.openxmlformats.org/drawingml/2006/main"/>
           <a:p xmlns:a="http://schemas.openxmlformats.org/drawingml/2006/main">
             <a:pPr algn="r">
+              <a:buNone/>
               <a:defRPr sz="1125" b="0">
                 <a:solidFill>
                   <a:srgbClr val="475569"/>
@@ -13831,14 +14084,14 @@
       </p:sp>
       <p:pic>
         <p:nvPicPr>
-          <p:cNvPr id="11" name=""/>
+          <p:cNvPr id="13" name=""/>
           <p:cNvPicPr>
             <a:picLocks xmlns:a="http://schemas.openxmlformats.org/drawingml/2006/main" noChangeAspect="1"/>
           </p:cNvPicPr>
           <p:nvPr/>
         </p:nvPicPr>
         <p:blipFill>
-          <a:blip xmlns:r="http://schemas.openxmlformats.org/officeDocument/2006/relationships" xmlns:a="http://schemas.openxmlformats.org/drawingml/2006/main" r:embed="Red9330ec9abf426b"/>
+          <a:blip xmlns:r="http://schemas.openxmlformats.org/officeDocument/2006/relationships" xmlns:a="http://schemas.openxmlformats.org/drawingml/2006/main" r:embed="Re9d730fdad4147bb"/>
           <a:stretch xmlns:a="http://schemas.openxmlformats.org/drawingml/2006/main"/>
         </p:blipFill>
         <p:spPr>
@@ -13885,6 +14138,7 @@
           <a:lstStyle xmlns:a="http://schemas.openxmlformats.org/drawingml/2006/main"/>
           <a:p xmlns:a="http://schemas.openxmlformats.org/drawingml/2006/main">
             <a:pPr>
+              <a:buNone/>
               <a:defRPr sz="1500" b="0">
                 <a:solidFill>
                   <a:srgbClr val="475569"/>
@@ -13903,7 +14157,7 @@
                 <a:ea typeface="Calibri"/>
                 <a:cs typeface="Calibri"/>
               </a:rPr>
-              <a:t>Lihat PASS D/E dan ringkasan Challenge: 14 PASS, 0 FAIL.</a:t>
+              <a:t>&amp; .\tests\challenge.ps1 membaca web dan port; PASS D/E membuktikan hotfix dan canary, total 14 PASS.</a:t>
             </a:r>
           </a:p>
         </p:txBody>
@@ -13971,6 +14225,7 @@
           <a:lstStyle xmlns:a="http://schemas.openxmlformats.org/drawingml/2006/main"/>
           <a:p xmlns:a="http://schemas.openxmlformats.org/drawingml/2006/main">
             <a:pPr>
+              <a:buNone/>
               <a:defRPr sz="1350" b="1">
                 <a:solidFill>
                   <a:srgbClr val="F37021"/>
@@ -14028,6 +14283,7 @@
           <a:lstStyle xmlns:a="http://schemas.openxmlformats.org/drawingml/2006/main"/>
           <a:p xmlns:a="http://schemas.openxmlformats.org/drawingml/2006/main">
             <a:pPr>
+              <a:buNone/>
               <a:defRPr sz="3150" b="1">
                 <a:solidFill>
                   <a:srgbClr val="002677"/>
@@ -14085,6 +14341,7 @@
           <a:lstStyle xmlns:a="http://schemas.openxmlformats.org/drawingml/2006/main"/>
           <a:p xmlns:a="http://schemas.openxmlformats.org/drawingml/2006/main">
             <a:pPr>
+              <a:buNone/>
               <a:defRPr sz="1725" b="0">
                 <a:solidFill>
                   <a:srgbClr val="475569"/>
@@ -14142,6 +14399,7 @@
           <a:lstStyle xmlns:a="http://schemas.openxmlformats.org/drawingml/2006/main"/>
           <a:p xmlns:a="http://schemas.openxmlformats.org/drawingml/2006/main">
             <a:pPr algn="r">
+              <a:buNone/>
               <a:defRPr sz="1125" b="0">
                 <a:solidFill>
                   <a:srgbClr val="475569"/>
@@ -14229,6 +14487,7 @@
           <a:lstStyle xmlns:a="http://schemas.openxmlformats.org/drawingml/2006/main"/>
           <a:p xmlns:a="http://schemas.openxmlformats.org/drawingml/2006/main">
             <a:pPr>
+              <a:buNone/>
               <a:defRPr sz="1425" b="0">
                 <a:solidFill>
                   <a:srgbClr val="E6F3FF"/>
@@ -14252,6 +14511,7 @@
           </a:p>
           <a:p xmlns:a="http://schemas.openxmlformats.org/drawingml/2006/main">
             <a:pPr>
+              <a:buNone/>
               <a:defRPr sz="1425" b="0">
                 <a:solidFill>
                   <a:srgbClr val="E6F3FF"/>
@@ -14275,6 +14535,7 @@
           </a:p>
           <a:p xmlns:a="http://schemas.openxmlformats.org/drawingml/2006/main">
             <a:pPr>
+              <a:buNone/>
               <a:defRPr sz="1425" b="0">
                 <a:solidFill>
                   <a:srgbClr val="E6F3FF"/>
@@ -14298,6 +14559,7 @@
           </a:p>
           <a:p xmlns:a="http://schemas.openxmlformats.org/drawingml/2006/main">
             <a:pPr>
+              <a:buNone/>
               <a:defRPr sz="1425" b="0">
                 <a:solidFill>
                   <a:srgbClr val="E6F3FF"/>
@@ -14321,6 +14583,7 @@
           </a:p>
           <a:p xmlns:a="http://schemas.openxmlformats.org/drawingml/2006/main">
             <a:pPr>
+              <a:buNone/>
               <a:defRPr sz="1425" b="0">
                 <a:solidFill>
                   <a:srgbClr val="E6F3FF"/>
@@ -14378,6 +14641,7 @@
           <a:lstStyle xmlns:a="http://schemas.openxmlformats.org/drawingml/2006/main"/>
           <a:p xmlns:a="http://schemas.openxmlformats.org/drawingml/2006/main">
             <a:pPr>
+              <a:buNone/>
               <a:defRPr sz="1425" b="1">
                 <a:solidFill>
                   <a:srgbClr val="F37021"/>
@@ -14435,6 +14699,7 @@
           <a:lstStyle xmlns:a="http://schemas.openxmlformats.org/drawingml/2006/main"/>
           <a:p xmlns:a="http://schemas.openxmlformats.org/drawingml/2006/main">
             <a:pPr>
+              <a:buNone/>
               <a:defRPr sz="1725" b="0">
                 <a:solidFill>
                   <a:srgbClr val="0F172A"/>
@@ -14521,6 +14786,7 @@
           <a:lstStyle xmlns:a="http://schemas.openxmlformats.org/drawingml/2006/main"/>
           <a:p xmlns:a="http://schemas.openxmlformats.org/drawingml/2006/main">
             <a:pPr>
+              <a:buNone/>
               <a:defRPr sz="1350" b="1">
                 <a:solidFill>
                   <a:srgbClr val="F37021"/>
@@ -14578,6 +14844,7 @@
           <a:lstStyle xmlns:a="http://schemas.openxmlformats.org/drawingml/2006/main"/>
           <a:p xmlns:a="http://schemas.openxmlformats.org/drawingml/2006/main">
             <a:pPr>
+              <a:buNone/>
               <a:defRPr sz="3150" b="1">
                 <a:solidFill>
                   <a:srgbClr val="002677"/>
@@ -14635,6 +14902,7 @@
           <a:lstStyle xmlns:a="http://schemas.openxmlformats.org/drawingml/2006/main"/>
           <a:p xmlns:a="http://schemas.openxmlformats.org/drawingml/2006/main">
             <a:pPr>
+              <a:buNone/>
               <a:defRPr sz="1725" b="0">
                 <a:solidFill>
                   <a:srgbClr val="475569"/>
@@ -14692,6 +14960,7 @@
           <a:lstStyle xmlns:a="http://schemas.openxmlformats.org/drawingml/2006/main"/>
           <a:p xmlns:a="http://schemas.openxmlformats.org/drawingml/2006/main">
             <a:pPr algn="r">
+              <a:buNone/>
               <a:defRPr sz="1125" b="0">
                 <a:solidFill>
                   <a:srgbClr val="475569"/>
@@ -14749,6 +15018,7 @@
           <a:lstStyle xmlns:a="http://schemas.openxmlformats.org/drawingml/2006/main"/>
           <a:p xmlns:a="http://schemas.openxmlformats.org/drawingml/2006/main">
             <a:pPr>
+              <a:buNone/>
               <a:defRPr sz="2025" b="1">
                 <a:solidFill>
                   <a:srgbClr val="F37021"/>
@@ -14806,6 +15076,7 @@
           <a:lstStyle xmlns:a="http://schemas.openxmlformats.org/drawingml/2006/main"/>
           <a:p xmlns:a="http://schemas.openxmlformats.org/drawingml/2006/main">
             <a:pPr>
+              <a:buNone/>
               <a:defRPr sz="1875" b="0">
                 <a:solidFill>
                   <a:srgbClr val="0F172A"/>
@@ -14863,6 +15134,7 @@
           <a:lstStyle xmlns:a="http://schemas.openxmlformats.org/drawingml/2006/main"/>
           <a:p xmlns:a="http://schemas.openxmlformats.org/drawingml/2006/main">
             <a:pPr>
+              <a:buNone/>
               <a:defRPr sz="2025" b="1">
                 <a:solidFill>
                   <a:srgbClr val="F37021"/>
@@ -14920,6 +15192,7 @@
           <a:lstStyle xmlns:a="http://schemas.openxmlformats.org/drawingml/2006/main"/>
           <a:p xmlns:a="http://schemas.openxmlformats.org/drawingml/2006/main">
             <a:pPr>
+              <a:buNone/>
               <a:defRPr sz="1875" b="0">
                 <a:solidFill>
                   <a:srgbClr val="0F172A"/>
@@ -14977,6 +15250,7 @@
           <a:lstStyle xmlns:a="http://schemas.openxmlformats.org/drawingml/2006/main"/>
           <a:p xmlns:a="http://schemas.openxmlformats.org/drawingml/2006/main">
             <a:pPr>
+              <a:buNone/>
               <a:defRPr sz="2025" b="1">
                 <a:solidFill>
                   <a:srgbClr val="F37021"/>
@@ -15034,6 +15308,7 @@
           <a:lstStyle xmlns:a="http://schemas.openxmlformats.org/drawingml/2006/main"/>
           <a:p xmlns:a="http://schemas.openxmlformats.org/drawingml/2006/main">
             <a:pPr>
+              <a:buNone/>
               <a:defRPr sz="1875" b="0">
                 <a:solidFill>
                   <a:srgbClr val="0F172A"/>
@@ -15120,6 +15395,7 @@
           <a:lstStyle xmlns:a="http://schemas.openxmlformats.org/drawingml/2006/main"/>
           <a:p xmlns:a="http://schemas.openxmlformats.org/drawingml/2006/main">
             <a:pPr>
+              <a:buNone/>
               <a:defRPr sz="1350" b="1">
                 <a:solidFill>
                   <a:srgbClr val="F37021"/>
@@ -15177,6 +15453,7 @@
           <a:lstStyle xmlns:a="http://schemas.openxmlformats.org/drawingml/2006/main"/>
           <a:p xmlns:a="http://schemas.openxmlformats.org/drawingml/2006/main">
             <a:pPr>
+              <a:buNone/>
               <a:defRPr sz="3150" b="1">
                 <a:solidFill>
                   <a:srgbClr val="002677"/>
@@ -15234,6 +15511,7 @@
           <a:lstStyle xmlns:a="http://schemas.openxmlformats.org/drawingml/2006/main"/>
           <a:p xmlns:a="http://schemas.openxmlformats.org/drawingml/2006/main">
             <a:pPr>
+              <a:buNone/>
               <a:defRPr sz="1725" b="0">
                 <a:solidFill>
                   <a:srgbClr val="475569"/>
@@ -15291,6 +15569,7 @@
           <a:lstStyle xmlns:a="http://schemas.openxmlformats.org/drawingml/2006/main"/>
           <a:p xmlns:a="http://schemas.openxmlformats.org/drawingml/2006/main">
             <a:pPr algn="r">
+              <a:buNone/>
               <a:defRPr sz="1125" b="0">
                 <a:solidFill>
                   <a:srgbClr val="475569"/>
@@ -15378,6 +15657,7 @@
           <a:lstStyle xmlns:a="http://schemas.openxmlformats.org/drawingml/2006/main"/>
           <a:p xmlns:a="http://schemas.openxmlformats.org/drawingml/2006/main">
             <a:pPr>
+              <a:buNone/>
               <a:defRPr sz="1425" b="0">
                 <a:solidFill>
                   <a:srgbClr val="E6F3FF"/>
@@ -15401,6 +15681,7 @@
           </a:p>
           <a:p xmlns:a="http://schemas.openxmlformats.org/drawingml/2006/main">
             <a:pPr>
+              <a:buNone/>
               <a:defRPr sz="1425" b="0">
                 <a:solidFill>
                   <a:srgbClr val="E6F3FF"/>
@@ -15424,6 +15705,7 @@
           </a:p>
           <a:p xmlns:a="http://schemas.openxmlformats.org/drawingml/2006/main">
             <a:pPr>
+              <a:buNone/>
               <a:defRPr sz="1425" b="0">
                 <a:solidFill>
                   <a:srgbClr val="E6F3FF"/>
@@ -15447,6 +15729,7 @@
           </a:p>
           <a:p xmlns:a="http://schemas.openxmlformats.org/drawingml/2006/main">
             <a:pPr>
+              <a:buNone/>
               <a:defRPr sz="1425" b="0">
                 <a:solidFill>
                   <a:srgbClr val="E6F3FF"/>
@@ -15470,6 +15753,7 @@
           </a:p>
           <a:p xmlns:a="http://schemas.openxmlformats.org/drawingml/2006/main">
             <a:pPr>
+              <a:buNone/>
               <a:defRPr sz="1425" b="0">
                 <a:solidFill>
                   <a:srgbClr val="E6F3FF"/>
@@ -15493,6 +15777,7 @@
           </a:p>
           <a:p xmlns:a="http://schemas.openxmlformats.org/drawingml/2006/main">
             <a:pPr>
+              <a:buNone/>
               <a:defRPr sz="1425" b="0">
                 <a:solidFill>
                   <a:srgbClr val="E6F3FF"/>
@@ -15516,6 +15801,7 @@
           </a:p>
           <a:p xmlns:a="http://schemas.openxmlformats.org/drawingml/2006/main">
             <a:pPr>
+              <a:buNone/>
               <a:defRPr sz="1425" b="0">
                 <a:solidFill>
                   <a:srgbClr val="E6F3FF"/>
@@ -15573,6 +15859,7 @@
           <a:lstStyle xmlns:a="http://schemas.openxmlformats.org/drawingml/2006/main"/>
           <a:p xmlns:a="http://schemas.openxmlformats.org/drawingml/2006/main">
             <a:pPr>
+              <a:buNone/>
               <a:defRPr sz="1425" b="1">
                 <a:solidFill>
                   <a:srgbClr val="F37021"/>
@@ -15630,6 +15917,7 @@
           <a:lstStyle xmlns:a="http://schemas.openxmlformats.org/drawingml/2006/main"/>
           <a:p xmlns:a="http://schemas.openxmlformats.org/drawingml/2006/main">
             <a:pPr>
+              <a:buNone/>
               <a:defRPr sz="1725" b="0">
                 <a:solidFill>
                   <a:srgbClr val="0F172A"/>
@@ -15664,7 +15952,7 @@
 </file>
 
 <file path=ppt/slides/slide34.xml><?xml version="1.0" encoding="utf-8"?>
-<p:sld xmlns:a="http://schemas.openxmlformats.org/drawingml/2006/main" xmlns:p="http://schemas.openxmlformats.org/presentationml/2006/main" xmlns:r="http://schemas.openxmlformats.org/officeDocument/2006/relationships">
+<p:sld xmlns:p="http://schemas.openxmlformats.org/presentationml/2006/main">
   <p:cSld>
     <p:spTree>
       <p:nvGrpSpPr>
@@ -15672,41 +15960,44 @@
         <p:cNvGrpSpPr/>
         <p:nvPr/>
       </p:nvGrpSpPr>
-      <p:grpSpPr/>
+      <p:grpSpPr>
+        <a:xfrm xmlns:a="http://schemas.openxmlformats.org/drawingml/2006/main"/>
+      </p:grpSpPr>
       <p:sp>
         <p:nvSpPr>
           <p:cNvPr id="7" name="section">
-            <a:extLst>
+            <a:extLst xmlns:a="http://schemas.openxmlformats.org/drawingml/2006/main">
               <a:ext uri="{FF2B5EF4-FFF2-40B4-BE49-F238E27FC236}">
                 <a16:creationId xmlns:a16="http://schemas.microsoft.com/office/drawing/2014/main" id="{8AB038A4-485E-4E1A-8EA7-A13497461296}"/>
               </a:ext>
             </a:extLst>
           </p:cNvPr>
           <p:cNvSpPr>
-            <a:spLocks noGrp="1"/>
-          </p:cNvSpPr>
-          <p:nvPr/>
-        </p:nvSpPr>
-        <p:spPr>
-          <a:xfrm>
+            <a:spLocks xmlns:a="http://schemas.openxmlformats.org/drawingml/2006/main" noGrp="1"/>
+          </p:cNvSpPr>
+          <p:nvPr/>
+        </p:nvSpPr>
+        <p:spPr>
+          <a:xfrm xmlns:a="http://schemas.openxmlformats.org/drawingml/2006/main">
             <a:off x="685800" y="295275"/>
             <a:ext cx="7620000" cy="228600"/>
           </a:xfrm>
-          <a:prstGeom prst="rect">
-            <a:avLst/>
-          </a:prstGeom>
-          <a:noFill/>
-          <a:ln w="0">
-            <a:noFill/>
-          </a:ln>
-        </p:spPr>
-        <p:txBody>
-          <a:bodyPr wrap="square" lIns="0" tIns="0" rIns="0" bIns="0" anchor="t">
-            <a:normAutofit fontScale="100000"/>
-          </a:bodyPr>
-          <a:lstStyle/>
-          <a:p>
-            <a:pPr>
+          <a:prstGeom xmlns:a="http://schemas.openxmlformats.org/drawingml/2006/main" prst="rect">
+            <a:avLst/>
+          </a:prstGeom>
+          <a:noFill xmlns:a="http://schemas.openxmlformats.org/drawingml/2006/main"/>
+          <a:ln xmlns:a="http://schemas.openxmlformats.org/drawingml/2006/main" w="0">
+            <a:noFill/>
+          </a:ln>
+        </p:spPr>
+        <p:txBody>
+          <a:bodyPr xmlns:a="http://schemas.openxmlformats.org/drawingml/2006/main" wrap="square" lIns="0" tIns="0" rIns="0" bIns="0" anchor="t">
+            <a:normAutofit fontScale="100000"/>
+          </a:bodyPr>
+          <a:lstStyle xmlns:a="http://schemas.openxmlformats.org/drawingml/2006/main"/>
+          <a:p xmlns:a="http://schemas.openxmlformats.org/drawingml/2006/main">
+            <a:pPr>
+              <a:buNone/>
               <a:defRPr sz="1350" b="1">
                 <a:solidFill>
                   <a:srgbClr val="F37021"/>
@@ -15733,37 +16024,38 @@
       <p:sp>
         <p:nvSpPr>
           <p:cNvPr id="2" name="title">
-            <a:extLst>
+            <a:extLst xmlns:a="http://schemas.openxmlformats.org/drawingml/2006/main">
               <a:ext uri="{FF2B5EF4-FFF2-40B4-BE49-F238E27FC236}">
                 <a16:creationId xmlns:a16="http://schemas.microsoft.com/office/drawing/2014/main" id="{91FF576F-51DB-4D3D-BA37-0B58A7B6CC93}"/>
               </a:ext>
             </a:extLst>
           </p:cNvPr>
           <p:cNvSpPr>
-            <a:spLocks noGrp="1"/>
-          </p:cNvSpPr>
-          <p:nvPr/>
-        </p:nvSpPr>
-        <p:spPr>
-          <a:xfrm>
+            <a:spLocks xmlns:a="http://schemas.openxmlformats.org/drawingml/2006/main" noGrp="1"/>
+          </p:cNvSpPr>
+          <p:nvPr/>
+        </p:nvSpPr>
+        <p:spPr>
+          <a:xfrm xmlns:a="http://schemas.openxmlformats.org/drawingml/2006/main">
             <a:off x="685800" y="619125"/>
             <a:ext cx="10820400" cy="742950"/>
           </a:xfrm>
-          <a:prstGeom prst="rect">
-            <a:avLst/>
-          </a:prstGeom>
-          <a:noFill/>
-          <a:ln w="0">
-            <a:noFill/>
-          </a:ln>
-        </p:spPr>
-        <p:txBody>
-          <a:bodyPr wrap="square" lIns="0" tIns="0" rIns="0" bIns="0" anchor="t">
-            <a:normAutofit fontScale="100000"/>
-          </a:bodyPr>
-          <a:lstStyle/>
-          <a:p>
-            <a:pPr>
+          <a:prstGeom xmlns:a="http://schemas.openxmlformats.org/drawingml/2006/main" prst="rect">
+            <a:avLst/>
+          </a:prstGeom>
+          <a:noFill xmlns:a="http://schemas.openxmlformats.org/drawingml/2006/main"/>
+          <a:ln xmlns:a="http://schemas.openxmlformats.org/drawingml/2006/main" w="0">
+            <a:noFill/>
+          </a:ln>
+        </p:spPr>
+        <p:txBody>
+          <a:bodyPr xmlns:a="http://schemas.openxmlformats.org/drawingml/2006/main" wrap="square" lIns="0" tIns="0" rIns="0" bIns="0" anchor="t">
+            <a:normAutofit fontScale="100000"/>
+          </a:bodyPr>
+          <a:lstStyle xmlns:a="http://schemas.openxmlformats.org/drawingml/2006/main"/>
+          <a:p xmlns:a="http://schemas.openxmlformats.org/drawingml/2006/main">
+            <a:pPr>
+              <a:buNone/>
               <a:defRPr sz="3150" b="1">
                 <a:solidFill>
                   <a:srgbClr val="002677"/>
@@ -15790,37 +16082,38 @@
       <p:sp>
         <p:nvSpPr>
           <p:cNvPr id="3" name="subtitle">
-            <a:extLst>
+            <a:extLst xmlns:a="http://schemas.openxmlformats.org/drawingml/2006/main">
               <a:ext uri="{FF2B5EF4-FFF2-40B4-BE49-F238E27FC236}">
                 <a16:creationId xmlns:a16="http://schemas.microsoft.com/office/drawing/2014/main" id="{EFA20D18-3AFC-49C5-BDA1-9BC7214D00B4}"/>
               </a:ext>
             </a:extLst>
           </p:cNvPr>
           <p:cNvSpPr>
-            <a:spLocks noGrp="1"/>
-          </p:cNvSpPr>
-          <p:nvPr/>
-        </p:nvSpPr>
-        <p:spPr>
-          <a:xfrm>
+            <a:spLocks xmlns:a="http://schemas.openxmlformats.org/drawingml/2006/main" noGrp="1"/>
+          </p:cNvSpPr>
+          <p:nvPr/>
+        </p:nvSpPr>
+        <p:spPr>
+          <a:xfrm xmlns:a="http://schemas.openxmlformats.org/drawingml/2006/main">
             <a:off x="685800" y="1362075"/>
             <a:ext cx="10820400" cy="438150"/>
           </a:xfrm>
-          <a:prstGeom prst="rect">
-            <a:avLst/>
-          </a:prstGeom>
-          <a:noFill/>
-          <a:ln w="0">
-            <a:noFill/>
-          </a:ln>
-        </p:spPr>
-        <p:txBody>
-          <a:bodyPr wrap="square" lIns="0" tIns="0" rIns="0" bIns="0" anchor="t">
-            <a:normAutofit fontScale="100000"/>
-          </a:bodyPr>
-          <a:lstStyle/>
-          <a:p>
-            <a:pPr>
+          <a:prstGeom xmlns:a="http://schemas.openxmlformats.org/drawingml/2006/main" prst="rect">
+            <a:avLst/>
+          </a:prstGeom>
+          <a:noFill xmlns:a="http://schemas.openxmlformats.org/drawingml/2006/main"/>
+          <a:ln xmlns:a="http://schemas.openxmlformats.org/drawingml/2006/main" w="0">
+            <a:noFill/>
+          </a:ln>
+        </p:spPr>
+        <p:txBody>
+          <a:bodyPr xmlns:a="http://schemas.openxmlformats.org/drawingml/2006/main" wrap="square" lIns="0" tIns="0" rIns="0" bIns="0" anchor="t">
+            <a:normAutofit fontScale="100000"/>
+          </a:bodyPr>
+          <a:lstStyle xmlns:a="http://schemas.openxmlformats.org/drawingml/2006/main"/>
+          <a:p xmlns:a="http://schemas.openxmlformats.org/drawingml/2006/main">
+            <a:pPr>
+              <a:buNone/>
               <a:defRPr sz="1725" b="0">
                 <a:solidFill>
                   <a:srgbClr val="475569"/>
@@ -15847,37 +16140,38 @@
       <p:sp>
         <p:nvSpPr>
           <p:cNvPr id="4" name="page">
-            <a:extLst>
+            <a:extLst xmlns:a="http://schemas.openxmlformats.org/drawingml/2006/main">
               <a:ext uri="{FF2B5EF4-FFF2-40B4-BE49-F238E27FC236}">
                 <a16:creationId xmlns:a16="http://schemas.microsoft.com/office/drawing/2014/main" id="{46C0AC1E-CE3B-48DA-BD1F-EB4120B24A2C}"/>
               </a:ext>
             </a:extLst>
           </p:cNvPr>
           <p:cNvSpPr>
-            <a:spLocks noGrp="1"/>
-          </p:cNvSpPr>
-          <p:nvPr/>
-        </p:nvSpPr>
-        <p:spPr>
-          <a:xfrm>
+            <a:spLocks xmlns:a="http://schemas.openxmlformats.org/drawingml/2006/main" noGrp="1"/>
+          </p:cNvSpPr>
+          <p:nvPr/>
+        </p:nvSpPr>
+        <p:spPr>
+          <a:xfrm xmlns:a="http://schemas.openxmlformats.org/drawingml/2006/main">
             <a:off x="11153775" y="6353175"/>
             <a:ext cx="361950" cy="209550"/>
           </a:xfrm>
-          <a:prstGeom prst="rect">
-            <a:avLst/>
-          </a:prstGeom>
-          <a:noFill/>
-          <a:ln w="0">
-            <a:noFill/>
-          </a:ln>
-        </p:spPr>
-        <p:txBody>
-          <a:bodyPr wrap="square" lIns="0" tIns="0" rIns="0" bIns="0" anchor="t">
-            <a:normAutofit fontScale="100000"/>
-          </a:bodyPr>
-          <a:lstStyle/>
-          <a:p>
+          <a:prstGeom xmlns:a="http://schemas.openxmlformats.org/drawingml/2006/main" prst="rect">
+            <a:avLst/>
+          </a:prstGeom>
+          <a:noFill xmlns:a="http://schemas.openxmlformats.org/drawingml/2006/main"/>
+          <a:ln xmlns:a="http://schemas.openxmlformats.org/drawingml/2006/main" w="0">
+            <a:noFill/>
+          </a:ln>
+        </p:spPr>
+        <p:txBody>
+          <a:bodyPr xmlns:a="http://schemas.openxmlformats.org/drawingml/2006/main" wrap="square" lIns="0" tIns="0" rIns="0" bIns="0" anchor="t">
+            <a:normAutofit fontScale="100000"/>
+          </a:bodyPr>
+          <a:lstStyle xmlns:a="http://schemas.openxmlformats.org/drawingml/2006/main"/>
+          <a:p xmlns:a="http://schemas.openxmlformats.org/drawingml/2006/main">
             <a:pPr algn="r">
+              <a:buNone/>
               <a:defRPr sz="1125" b="0">
                 <a:solidFill>
                   <a:srgbClr val="475569"/>
@@ -15904,37 +16198,38 @@
       <p:sp>
         <p:nvSpPr>
           <p:cNvPr id="6" name="evidence-final-test-bottom-caption">
-            <a:extLst>
+            <a:extLst xmlns:a="http://schemas.openxmlformats.org/drawingml/2006/main">
               <a:ext uri="{FF2B5EF4-FFF2-40B4-BE49-F238E27FC236}">
                 <a16:creationId xmlns:a16="http://schemas.microsoft.com/office/drawing/2014/main" id="{D4371BEE-53D1-466B-AF5C-123D697F8CAB}"/>
               </a:ext>
             </a:extLst>
           </p:cNvPr>
           <p:cNvSpPr>
-            <a:spLocks noGrp="1"/>
-          </p:cNvSpPr>
-          <p:nvPr/>
-        </p:nvSpPr>
-        <p:spPr>
-          <a:xfrm>
+            <a:spLocks xmlns:a="http://schemas.openxmlformats.org/drawingml/2006/main" noGrp="1"/>
+          </p:cNvSpPr>
+          <p:nvPr/>
+        </p:nvSpPr>
+        <p:spPr>
+          <a:xfrm xmlns:a="http://schemas.openxmlformats.org/drawingml/2006/main">
             <a:off x="685800" y="5705475"/>
             <a:ext cx="10572750" cy="447675"/>
           </a:xfrm>
-          <a:prstGeom prst="rect">
-            <a:avLst/>
-          </a:prstGeom>
-          <a:noFill/>
-          <a:ln w="0">
-            <a:noFill/>
-          </a:ln>
-        </p:spPr>
-        <p:txBody>
-          <a:bodyPr wrap="square" lIns="0" tIns="0" rIns="0" bIns="0" anchor="t">
-            <a:normAutofit fontScale="100000"/>
-          </a:bodyPr>
-          <a:lstStyle/>
-          <a:p>
-            <a:pPr>
+          <a:prstGeom xmlns:a="http://schemas.openxmlformats.org/drawingml/2006/main" prst="rect">
+            <a:avLst/>
+          </a:prstGeom>
+          <a:noFill xmlns:a="http://schemas.openxmlformats.org/drawingml/2006/main"/>
+          <a:ln xmlns:a="http://schemas.openxmlformats.org/drawingml/2006/main" w="0">
+            <a:noFill/>
+          </a:ln>
+        </p:spPr>
+        <p:txBody>
+          <a:bodyPr xmlns:a="http://schemas.openxmlformats.org/drawingml/2006/main" wrap="square" lIns="0" tIns="0" rIns="0" bIns="0" anchor="t">
+            <a:normAutofit fontScale="100000"/>
+          </a:bodyPr>
+          <a:lstStyle xmlns:a="http://schemas.openxmlformats.org/drawingml/2006/main"/>
+          <a:p xmlns:a="http://schemas.openxmlformats.org/drawingml/2006/main">
+            <a:pPr>
+              <a:buNone/>
               <a:defRPr sz="1500" b="0">
                 <a:solidFill>
                   <a:srgbClr val="475569"/>
@@ -15960,107 +16255,127 @@
       </p:sp>
       <p:pic>
         <p:nvPicPr>
-          <p:cNvPr id="8" name="Picture 7" descr="11_github_published.jpg"/>
+          <p:cNvPr id="16" name="Picture 7"/>
           <p:cNvPicPr>
-            <a:picLocks noChangeAspect="1"/>
+            <a:picLocks xmlns:a="http://schemas.openxmlformats.org/drawingml/2006/main" noChangeAspect="1"/>
           </p:cNvPicPr>
           <p:nvPr/>
         </p:nvPicPr>
         <p:blipFill>
-          <a:blip r:embed="rId2"/>
-          <a:stretch>
-            <a:fillRect/>
+          <a:blip xmlns:r="http://schemas.openxmlformats.org/officeDocument/2006/relationships" xmlns:a="http://schemas.openxmlformats.org/drawingml/2006/main" r:embed="Raed366157c784b54"/>
+          <a:stretch xmlns:a="http://schemas.openxmlformats.org/drawingml/2006/main">
+            <a:fillRect l="0" t="0" r="0" b="0"/>
           </a:stretch>
         </p:blipFill>
         <p:spPr>
-          <a:xfrm>
+          <a:xfrm xmlns:a="http://schemas.openxmlformats.org/drawingml/2006/main">
             <a:off x="731520" y="2011680"/>
             <a:ext cx="7498079" cy="3624958"/>
           </a:xfrm>
-          <a:prstGeom prst="rect">
+          <a:prstGeom xmlns:a="http://schemas.openxmlformats.org/drawingml/2006/main" prst="rect">
             <a:avLst/>
           </a:prstGeom>
         </p:spPr>
       </p:pic>
       <p:sp>
         <p:nvSpPr>
-          <p:cNvPr id="9" name="TextBox 8"/>
-          <p:cNvSpPr txBox="1"/>
-          <p:nvPr/>
-        </p:nvSpPr>
-        <p:spPr>
-          <a:xfrm>
+          <p:cNvPr id="9" name="TextBox 8">
+            <a:extLst xmlns:a="http://schemas.openxmlformats.org/drawingml/2006/main">
+              <a:ext uri="{FF2B5EF4-FFF2-40B4-BE49-F238E27FC236}">
+                <a16:creationId xmlns:a16="http://schemas.microsoft.com/office/drawing/2014/main" id="{CB20D216-EEA0-477F-9B79-2422F55C513D}"/>
+              </a:ext>
+            </a:extLst>
+          </p:cNvPr>
+          <p:cNvSpPr>
+            <a:spLocks xmlns:a="http://schemas.openxmlformats.org/drawingml/2006/main" noGrp="1"/>
+          </p:cNvSpPr>
+          <p:nvPr/>
+        </p:nvSpPr>
+        <p:spPr>
+          <a:xfrm xmlns:a="http://schemas.openxmlformats.org/drawingml/2006/main">
             <a:off x="8412480" y="2057400"/>
             <a:ext cx="3063240" cy="3383280"/>
           </a:xfrm>
-          <a:prstGeom prst="rect">
-            <a:avLst/>
-          </a:prstGeom>
-          <a:noFill/>
-        </p:spPr>
-        <p:txBody>
-          <a:bodyPr wrap="square">
+          <a:prstGeom xmlns:a="http://schemas.openxmlformats.org/drawingml/2006/main" prst="rect">
+            <a:avLst/>
+          </a:prstGeom>
+          <a:noFill xmlns:a="http://schemas.openxmlformats.org/drawingml/2006/main"/>
+        </p:spPr>
+        <p:txBody>
+          <a:bodyPr xmlns:a="http://schemas.openxmlformats.org/drawingml/2006/main" wrap="square">
             <a:spAutoFit/>
           </a:bodyPr>
-          <a:lstStyle/>
-          <a:p>
+          <a:lstStyle xmlns:a="http://schemas.openxmlformats.org/drawingml/2006/main"/>
+          <a:p xmlns:a="http://schemas.openxmlformats.org/drawingml/2006/main">
             <a:pPr>
               <a:spcAft>
                 <a:spcPts val="1000"/>
               </a:spcAft>
+              <a:buNone/>
               <a:defRPr sz="1700" b="1">
                 <a:solidFill>
                   <a:srgbClr val="002677"/>
                 </a:solidFill>
                 <a:latin typeface="Calibri"/>
+                <a:ea typeface="Calibri"/>
+                <a:cs typeface="Calibri"/>
               </a:defRPr>
             </a:pPr>
             <a:r>
               <a:t>Perintah: git push</a:t>
             </a:r>
           </a:p>
-          <a:p>
+          <a:p xmlns:a="http://schemas.openxmlformats.org/drawingml/2006/main">
             <a:pPr>
               <a:spcAft>
                 <a:spcPts val="1000"/>
               </a:spcAft>
+              <a:buNone/>
               <a:defRPr sz="1500" b="0">
                 <a:solidFill>
                   <a:srgbClr val="475569"/>
                 </a:solidFill>
                 <a:latin typeface="Calibri"/>
+                <a:ea typeface="Calibri"/>
+                <a:cs typeface="Calibri"/>
               </a:defRPr>
             </a:pPr>
             <a:r>
               <a:t>Fungsi: mengirim commit dan laporan ke origin.</a:t>
             </a:r>
           </a:p>
-          <a:p>
+          <a:p xmlns:a="http://schemas.openxmlformats.org/drawingml/2006/main">
             <a:pPr>
               <a:spcAft>
                 <a:spcPts val="1000"/>
               </a:spcAft>
+              <a:buNone/>
               <a:defRPr sz="1500" b="0">
                 <a:solidFill>
                   <a:srgbClr val="475569"/>
                 </a:solidFill>
                 <a:latin typeface="Calibri"/>
+                <a:ea typeface="Calibri"/>
+                <a:cs typeface="Calibri"/>
               </a:defRPr>
             </a:pPr>
             <a:r>
               <a:t>Cara kerja: Git memperbarui branch main di GitHub.</a:t>
             </a:r>
           </a:p>
-          <a:p>
+          <a:p xmlns:a="http://schemas.openxmlformats.org/drawingml/2006/main">
             <a:pPr>
               <a:spcAft>
                 <a:spcPts val="1000"/>
               </a:spcAft>
+              <a:buNone/>
               <a:defRPr sz="1500" b="0">
                 <a:solidFill>
                   <a:srgbClr val="475569"/>
                 </a:solidFill>
                 <a:latin typeface="Calibri"/>
+                <a:ea typeface="Calibri"/>
+                <a:cs typeface="Calibri"/>
               </a:defRPr>
             </a:pPr>
             <a:r>
@@ -16070,10 +16385,12 @@
         </p:txBody>
       </p:sp>
     </p:spTree>
+    <p:extLst>
+      <p:ext uri="{BB962C8B-B14F-4D97-AF65-F5344CB8AC3E}">
+        <p14:creationId xmlns:p14="http://schemas.microsoft.com/office/powerpoint/2010/main" val="1262402183"/>
+      </p:ext>
+    </p:extLst>
   </p:cSld>
-  <p:clrMapOvr>
-    <a:masterClrMapping/>
-  </p:clrMapOvr>
 </p:sld>
 </file>
 
@@ -16130,6 +16447,7 @@
           <a:lstStyle xmlns:a="http://schemas.openxmlformats.org/drawingml/2006/main"/>
           <a:p xmlns:a="http://schemas.openxmlformats.org/drawingml/2006/main">
             <a:pPr>
+              <a:buNone/>
               <a:defRPr sz="1350" b="1">
                 <a:solidFill>
                   <a:srgbClr val="F37021"/>
@@ -16187,6 +16505,7 @@
           <a:lstStyle xmlns:a="http://schemas.openxmlformats.org/drawingml/2006/main"/>
           <a:p xmlns:a="http://schemas.openxmlformats.org/drawingml/2006/main">
             <a:pPr>
+              <a:buNone/>
               <a:defRPr sz="3150" b="1">
                 <a:solidFill>
                   <a:srgbClr val="002677"/>
@@ -16244,6 +16563,7 @@
           <a:lstStyle xmlns:a="http://schemas.openxmlformats.org/drawingml/2006/main"/>
           <a:p xmlns:a="http://schemas.openxmlformats.org/drawingml/2006/main">
             <a:pPr>
+              <a:buNone/>
               <a:defRPr sz="1725" b="0">
                 <a:solidFill>
                   <a:srgbClr val="475569"/>
@@ -16301,6 +16621,7 @@
           <a:lstStyle xmlns:a="http://schemas.openxmlformats.org/drawingml/2006/main"/>
           <a:p xmlns:a="http://schemas.openxmlformats.org/drawingml/2006/main">
             <a:pPr algn="r">
+              <a:buNone/>
               <a:defRPr sz="1125" b="0">
                 <a:solidFill>
                   <a:srgbClr val="475569"/>
@@ -16358,6 +16679,7 @@
           <a:lstStyle xmlns:a="http://schemas.openxmlformats.org/drawingml/2006/main"/>
           <a:p xmlns:a="http://schemas.openxmlformats.org/drawingml/2006/main">
             <a:pPr>
+              <a:buNone/>
               <a:defRPr sz="2250" b="1">
                 <a:solidFill>
                   <a:srgbClr val="F37021"/>
@@ -16415,6 +16737,7 @@
           <a:lstStyle xmlns:a="http://schemas.openxmlformats.org/drawingml/2006/main"/>
           <a:p xmlns:a="http://schemas.openxmlformats.org/drawingml/2006/main">
             <a:pPr>
+              <a:buNone/>
               <a:defRPr sz="2025" b="0">
                 <a:solidFill>
                   <a:srgbClr val="0F172A"/>
@@ -16472,6 +16795,7 @@
           <a:lstStyle xmlns:a="http://schemas.openxmlformats.org/drawingml/2006/main"/>
           <a:p xmlns:a="http://schemas.openxmlformats.org/drawingml/2006/main">
             <a:pPr>
+              <a:buNone/>
               <a:defRPr sz="2250" b="1">
                 <a:solidFill>
                   <a:srgbClr val="F37021"/>
@@ -16529,6 +16853,7 @@
           <a:lstStyle xmlns:a="http://schemas.openxmlformats.org/drawingml/2006/main"/>
           <a:p xmlns:a="http://schemas.openxmlformats.org/drawingml/2006/main">
             <a:pPr>
+              <a:buNone/>
               <a:defRPr sz="2025" b="0">
                 <a:solidFill>
                   <a:srgbClr val="0F172A"/>
@@ -16586,6 +16911,7 @@
           <a:lstStyle xmlns:a="http://schemas.openxmlformats.org/drawingml/2006/main"/>
           <a:p xmlns:a="http://schemas.openxmlformats.org/drawingml/2006/main">
             <a:pPr>
+              <a:buNone/>
               <a:defRPr sz="2250" b="1">
                 <a:solidFill>
                   <a:srgbClr val="F37021"/>
@@ -16643,6 +16969,7 @@
           <a:lstStyle xmlns:a="http://schemas.openxmlformats.org/drawingml/2006/main"/>
           <a:p xmlns:a="http://schemas.openxmlformats.org/drawingml/2006/main">
             <a:pPr>
+              <a:buNone/>
               <a:defRPr sz="2025" b="0">
                 <a:solidFill>
                   <a:srgbClr val="0F172A"/>
@@ -16729,6 +17056,7 @@
           <a:lstStyle xmlns:a="http://schemas.openxmlformats.org/drawingml/2006/main"/>
           <a:p xmlns:a="http://schemas.openxmlformats.org/drawingml/2006/main">
             <a:pPr>
+              <a:buNone/>
               <a:defRPr sz="1350" b="1">
                 <a:solidFill>
                   <a:srgbClr val="F37021"/>
@@ -16786,6 +17114,7 @@
           <a:lstStyle xmlns:a="http://schemas.openxmlformats.org/drawingml/2006/main"/>
           <a:p xmlns:a="http://schemas.openxmlformats.org/drawingml/2006/main">
             <a:pPr>
+              <a:buNone/>
               <a:defRPr sz="3150" b="1">
                 <a:solidFill>
                   <a:srgbClr val="002677"/>
@@ -16843,6 +17172,7 @@
           <a:lstStyle xmlns:a="http://schemas.openxmlformats.org/drawingml/2006/main"/>
           <a:p xmlns:a="http://schemas.openxmlformats.org/drawingml/2006/main">
             <a:pPr>
+              <a:buNone/>
               <a:defRPr sz="1725" b="0">
                 <a:solidFill>
                   <a:srgbClr val="475569"/>
@@ -16900,6 +17230,7 @@
           <a:lstStyle xmlns:a="http://schemas.openxmlformats.org/drawingml/2006/main"/>
           <a:p xmlns:a="http://schemas.openxmlformats.org/drawingml/2006/main">
             <a:pPr algn="r">
+              <a:buNone/>
               <a:defRPr sz="1125" b="0">
                 <a:solidFill>
                   <a:srgbClr val="475569"/>
@@ -16987,6 +17318,7 @@
           <a:lstStyle xmlns:a="http://schemas.openxmlformats.org/drawingml/2006/main"/>
           <a:p xmlns:a="http://schemas.openxmlformats.org/drawingml/2006/main">
             <a:pPr>
+              <a:buNone/>
               <a:defRPr sz="2025" b="0">
                 <a:solidFill>
                   <a:srgbClr val="E6F3FF"/>
@@ -17010,6 +17342,7 @@
           </a:p>
           <a:p xmlns:a="http://schemas.openxmlformats.org/drawingml/2006/main">
             <a:pPr>
+              <a:buNone/>
               <a:defRPr sz="2025" b="0">
                 <a:solidFill>
                   <a:srgbClr val="E6F3FF"/>
@@ -17033,6 +17366,7 @@
           </a:p>
           <a:p xmlns:a="http://schemas.openxmlformats.org/drawingml/2006/main">
             <a:pPr>
+              <a:buNone/>
               <a:defRPr sz="2025" b="0">
                 <a:solidFill>
                   <a:srgbClr val="E6F3FF"/>
@@ -17056,6 +17390,7 @@
           </a:p>
           <a:p xmlns:a="http://schemas.openxmlformats.org/drawingml/2006/main">
             <a:pPr>
+              <a:buNone/>
               <a:defRPr sz="2025" b="0">
                 <a:solidFill>
                   <a:srgbClr val="E6F3FF"/>
@@ -17113,6 +17448,7 @@
           <a:lstStyle xmlns:a="http://schemas.openxmlformats.org/drawingml/2006/main"/>
           <a:p xmlns:a="http://schemas.openxmlformats.org/drawingml/2006/main">
             <a:pPr>
+              <a:buNone/>
               <a:defRPr sz="1425" b="1">
                 <a:solidFill>
                   <a:srgbClr val="F37021"/>
@@ -17170,6 +17506,7 @@
           <a:lstStyle xmlns:a="http://schemas.openxmlformats.org/drawingml/2006/main"/>
           <a:p xmlns:a="http://schemas.openxmlformats.org/drawingml/2006/main">
             <a:pPr>
+              <a:buNone/>
               <a:defRPr sz="1725" b="0">
                 <a:solidFill>
                   <a:srgbClr val="0F172A"/>
@@ -17256,6 +17593,7 @@
           <a:lstStyle xmlns:a="http://schemas.openxmlformats.org/drawingml/2006/main"/>
           <a:p xmlns:a="http://schemas.openxmlformats.org/drawingml/2006/main">
             <a:pPr>
+              <a:buNone/>
               <a:defRPr sz="1350" b="1">
                 <a:solidFill>
                   <a:srgbClr val="F37021"/>
@@ -17313,6 +17651,7 @@
           <a:lstStyle xmlns:a="http://schemas.openxmlformats.org/drawingml/2006/main"/>
           <a:p xmlns:a="http://schemas.openxmlformats.org/drawingml/2006/main">
             <a:pPr>
+              <a:buNone/>
               <a:defRPr sz="3150" b="1">
                 <a:solidFill>
                   <a:srgbClr val="002677"/>
@@ -17370,6 +17709,7 @@
           <a:lstStyle xmlns:a="http://schemas.openxmlformats.org/drawingml/2006/main"/>
           <a:p xmlns:a="http://schemas.openxmlformats.org/drawingml/2006/main">
             <a:pPr>
+              <a:buNone/>
               <a:defRPr sz="1725" b="0">
                 <a:solidFill>
                   <a:srgbClr val="475569"/>
@@ -17427,6 +17767,7 @@
           <a:lstStyle xmlns:a="http://schemas.openxmlformats.org/drawingml/2006/main"/>
           <a:p xmlns:a="http://schemas.openxmlformats.org/drawingml/2006/main">
             <a:pPr algn="r">
+              <a:buNone/>
               <a:defRPr sz="1125" b="0">
                 <a:solidFill>
                   <a:srgbClr val="475569"/>
@@ -17452,14 +17793,14 @@
       </p:sp>
       <p:pic>
         <p:nvPicPr>
-          <p:cNvPr id="11" name=""/>
+          <p:cNvPr id="13" name=""/>
           <p:cNvPicPr>
             <a:picLocks xmlns:a="http://schemas.openxmlformats.org/drawingml/2006/main" noChangeAspect="1"/>
           </p:cNvPicPr>
           <p:nvPr/>
         </p:nvPicPr>
         <p:blipFill>
-          <a:blip xmlns:r="http://schemas.openxmlformats.org/officeDocument/2006/relationships" xmlns:a="http://schemas.openxmlformats.org/drawingml/2006/main" r:embed="R17f6a815c8e8428e"/>
+          <a:blip xmlns:r="http://schemas.openxmlformats.org/officeDocument/2006/relationships" xmlns:a="http://schemas.openxmlformats.org/drawingml/2006/main" r:embed="Rea390dae4e264aa6"/>
           <a:stretch xmlns:a="http://schemas.openxmlformats.org/drawingml/2006/main"/>
         </p:blipFill>
         <p:spPr>
@@ -17506,6 +17847,7 @@
           <a:lstStyle xmlns:a="http://schemas.openxmlformats.org/drawingml/2006/main"/>
           <a:p xmlns:a="http://schemas.openxmlformats.org/drawingml/2006/main">
             <a:pPr>
+              <a:buNone/>
               <a:defRPr sz="1500" b="0">
                 <a:solidFill>
                   <a:srgbClr val="475569"/>
@@ -17524,7 +17866,7 @@
                 <a:ea typeface="Calibri"/>
                 <a:cs typeface="Calibri"/>
               </a:rPr>
-              <a:t>Tampilan Docker Desktop: indikator Engine running. Cek versi client/server melalui docker version di terminal.</a:t>
+              <a:t>docker version meminta versi Server ke daemon; Client dan Server tampil berarti CLI terhubung ke Engine aktif.</a:t>
             </a:r>
           </a:p>
         </p:txBody>
@@ -17592,6 +17934,7 @@
           <a:lstStyle xmlns:a="http://schemas.openxmlformats.org/drawingml/2006/main"/>
           <a:p xmlns:a="http://schemas.openxmlformats.org/drawingml/2006/main">
             <a:pPr>
+              <a:buNone/>
               <a:defRPr sz="1350" b="1">
                 <a:solidFill>
                   <a:srgbClr val="F37021"/>
@@ -17649,6 +17992,7 @@
           <a:lstStyle xmlns:a="http://schemas.openxmlformats.org/drawingml/2006/main"/>
           <a:p xmlns:a="http://schemas.openxmlformats.org/drawingml/2006/main">
             <a:pPr>
+              <a:buNone/>
               <a:defRPr sz="3150" b="1">
                 <a:solidFill>
                   <a:srgbClr val="002677"/>
@@ -17706,6 +18050,7 @@
           <a:lstStyle xmlns:a="http://schemas.openxmlformats.org/drawingml/2006/main"/>
           <a:p xmlns:a="http://schemas.openxmlformats.org/drawingml/2006/main">
             <a:pPr>
+              <a:buNone/>
               <a:defRPr sz="1725" b="0">
                 <a:solidFill>
                   <a:srgbClr val="475569"/>
@@ -17763,6 +18108,7 @@
           <a:lstStyle xmlns:a="http://schemas.openxmlformats.org/drawingml/2006/main"/>
           <a:p xmlns:a="http://schemas.openxmlformats.org/drawingml/2006/main">
             <a:pPr algn="r">
+              <a:buNone/>
               <a:defRPr sz="1125" b="0">
                 <a:solidFill>
                   <a:srgbClr val="475569"/>
@@ -17850,6 +18196,7 @@
           <a:lstStyle xmlns:a="http://schemas.openxmlformats.org/drawingml/2006/main"/>
           <a:p xmlns:a="http://schemas.openxmlformats.org/drawingml/2006/main">
             <a:pPr>
+              <a:buNone/>
               <a:defRPr sz="1350" b="0">
                 <a:solidFill>
                   <a:srgbClr val="E6F3FF"/>
@@ -17873,6 +18220,7 @@
           </a:p>
           <a:p xmlns:a="http://schemas.openxmlformats.org/drawingml/2006/main">
             <a:pPr>
+              <a:buNone/>
               <a:defRPr sz="1350" b="0">
                 <a:solidFill>
                   <a:srgbClr val="E6F3FF"/>
@@ -17896,6 +18244,7 @@
           </a:p>
           <a:p xmlns:a="http://schemas.openxmlformats.org/drawingml/2006/main">
             <a:pPr>
+              <a:buNone/>
               <a:defRPr sz="1350" b="0">
                 <a:solidFill>
                   <a:srgbClr val="E6F3FF"/>
@@ -17919,6 +18268,7 @@
           </a:p>
           <a:p xmlns:a="http://schemas.openxmlformats.org/drawingml/2006/main">
             <a:pPr>
+              <a:buNone/>
               <a:defRPr sz="1350" b="0">
                 <a:solidFill>
                   <a:srgbClr val="E6F3FF"/>
@@ -17942,6 +18292,7 @@
           </a:p>
           <a:p xmlns:a="http://schemas.openxmlformats.org/drawingml/2006/main">
             <a:pPr>
+              <a:buNone/>
               <a:defRPr sz="1350" b="0">
                 <a:solidFill>
                   <a:srgbClr val="E6F3FF"/>
@@ -17965,6 +18316,7 @@
           </a:p>
           <a:p xmlns:a="http://schemas.openxmlformats.org/drawingml/2006/main">
             <a:pPr>
+              <a:buNone/>
               <a:defRPr sz="1350" b="0">
                 <a:solidFill>
                   <a:srgbClr val="E6F3FF"/>
@@ -17988,6 +18340,7 @@
           </a:p>
           <a:p xmlns:a="http://schemas.openxmlformats.org/drawingml/2006/main">
             <a:pPr>
+              <a:buNone/>
               <a:defRPr sz="1350" b="0">
                 <a:solidFill>
                   <a:srgbClr val="E6F3FF"/>
@@ -18011,6 +18364,7 @@
           </a:p>
           <a:p xmlns:a="http://schemas.openxmlformats.org/drawingml/2006/main">
             <a:pPr>
+              <a:buNone/>
               <a:defRPr sz="1350" b="0">
                 <a:solidFill>
                   <a:srgbClr val="E6F3FF"/>
@@ -18068,6 +18422,7 @@
           <a:lstStyle xmlns:a="http://schemas.openxmlformats.org/drawingml/2006/main"/>
           <a:p xmlns:a="http://schemas.openxmlformats.org/drawingml/2006/main">
             <a:pPr>
+              <a:buNone/>
               <a:defRPr sz="1425" b="1">
                 <a:solidFill>
                   <a:srgbClr val="F37021"/>
@@ -18125,6 +18480,7 @@
           <a:lstStyle xmlns:a="http://schemas.openxmlformats.org/drawingml/2006/main"/>
           <a:p xmlns:a="http://schemas.openxmlformats.org/drawingml/2006/main">
             <a:pPr>
+              <a:buNone/>
               <a:defRPr sz="1725" b="0">
                 <a:solidFill>
                   <a:srgbClr val="0F172A"/>
@@ -18211,6 +18567,7 @@
           <a:lstStyle xmlns:a="http://schemas.openxmlformats.org/drawingml/2006/main"/>
           <a:p xmlns:a="http://schemas.openxmlformats.org/drawingml/2006/main">
             <a:pPr>
+              <a:buNone/>
               <a:defRPr sz="1350" b="1">
                 <a:solidFill>
                   <a:srgbClr val="F37021"/>
@@ -18268,6 +18625,7 @@
           <a:lstStyle xmlns:a="http://schemas.openxmlformats.org/drawingml/2006/main"/>
           <a:p xmlns:a="http://schemas.openxmlformats.org/drawingml/2006/main">
             <a:pPr>
+              <a:buNone/>
               <a:defRPr sz="3150" b="1">
                 <a:solidFill>
                   <a:srgbClr val="002677"/>
@@ -18325,6 +18683,7 @@
           <a:lstStyle xmlns:a="http://schemas.openxmlformats.org/drawingml/2006/main"/>
           <a:p xmlns:a="http://schemas.openxmlformats.org/drawingml/2006/main">
             <a:pPr>
+              <a:buNone/>
               <a:defRPr sz="1725" b="0">
                 <a:solidFill>
                   <a:srgbClr val="475569"/>
@@ -18382,6 +18741,7 @@
           <a:lstStyle xmlns:a="http://schemas.openxmlformats.org/drawingml/2006/main"/>
           <a:p xmlns:a="http://schemas.openxmlformats.org/drawingml/2006/main">
             <a:pPr algn="r">
+              <a:buNone/>
               <a:defRPr sz="1125" b="0">
                 <a:solidFill>
                   <a:srgbClr val="475569"/>
@@ -18407,14 +18767,14 @@
       </p:sp>
       <p:pic>
         <p:nvPicPr>
-          <p:cNvPr id="11" name=""/>
+          <p:cNvPr id="13" name=""/>
           <p:cNvPicPr>
             <a:picLocks xmlns:a="http://schemas.openxmlformats.org/drawingml/2006/main" noChangeAspect="1"/>
           </p:cNvPicPr>
           <p:nvPr/>
         </p:nvPicPr>
         <p:blipFill>
-          <a:blip xmlns:r="http://schemas.openxmlformats.org/officeDocument/2006/relationships" xmlns:a="http://schemas.openxmlformats.org/drawingml/2006/main" r:embed="R9e0ce1e8f52c4d7f"/>
+          <a:blip xmlns:r="http://schemas.openxmlformats.org/officeDocument/2006/relationships" xmlns:a="http://schemas.openxmlformats.org/drawingml/2006/main" r:embed="R22f9e8d1dfb54e9d"/>
           <a:stretch xmlns:a="http://schemas.openxmlformats.org/drawingml/2006/main"/>
         </p:blipFill>
         <p:spPr>
@@ -18461,6 +18821,7 @@
           <a:lstStyle xmlns:a="http://schemas.openxmlformats.org/drawingml/2006/main"/>
           <a:p xmlns:a="http://schemas.openxmlformats.org/drawingml/2006/main">
             <a:pPr>
+              <a:buNone/>
               <a:defRPr sz="1500" b="0">
                 <a:solidFill>
                   <a:srgbClr val="475569"/>
@@ -18479,7 +18840,7 @@
                 <a:ea typeface="Calibri"/>
                 <a:cs typeface="Calibri"/>
               </a:rPr>
-              <a:t>Perintah: docker image ls nginx/python/node. Perhatikan tag dan ukuran pada mesin saat uji.</a:t>
+              <a:t>docker image ls membaca image lokal; tag nginx/python/node menunjukkan hasil docker pull sudah tersedia.</a:t>
             </a:r>
           </a:p>
         </p:txBody>
@@ -18547,6 +18908,7 @@
           <a:lstStyle xmlns:a="http://schemas.openxmlformats.org/drawingml/2006/main"/>
           <a:p xmlns:a="http://schemas.openxmlformats.org/drawingml/2006/main">
             <a:pPr>
+              <a:buNone/>
               <a:defRPr sz="1350" b="1">
                 <a:solidFill>
                   <a:srgbClr val="F37021"/>
@@ -18604,6 +18966,7 @@
           <a:lstStyle xmlns:a="http://schemas.openxmlformats.org/drawingml/2006/main"/>
           <a:p xmlns:a="http://schemas.openxmlformats.org/drawingml/2006/main">
             <a:pPr>
+              <a:buNone/>
               <a:defRPr sz="3150" b="1">
                 <a:solidFill>
                   <a:srgbClr val="002677"/>
@@ -18661,6 +19024,7 @@
           <a:lstStyle xmlns:a="http://schemas.openxmlformats.org/drawingml/2006/main"/>
           <a:p xmlns:a="http://schemas.openxmlformats.org/drawingml/2006/main">
             <a:pPr>
+              <a:buNone/>
               <a:defRPr sz="1725" b="0">
                 <a:solidFill>
                   <a:srgbClr val="475569"/>
@@ -18718,6 +19082,7 @@
           <a:lstStyle xmlns:a="http://schemas.openxmlformats.org/drawingml/2006/main"/>
           <a:p xmlns:a="http://schemas.openxmlformats.org/drawingml/2006/main">
             <a:pPr algn="r">
+              <a:buNone/>
               <a:defRPr sz="1125" b="0">
                 <a:solidFill>
                   <a:srgbClr val="475569"/>
@@ -18743,14 +19108,14 @@
       </p:sp>
       <p:pic>
         <p:nvPicPr>
-          <p:cNvPr id="11" name=""/>
+          <p:cNvPr id="13" name=""/>
           <p:cNvPicPr>
             <a:picLocks xmlns:a="http://schemas.openxmlformats.org/drawingml/2006/main" noChangeAspect="1"/>
           </p:cNvPicPr>
           <p:nvPr/>
         </p:nvPicPr>
         <p:blipFill>
-          <a:blip xmlns:r="http://schemas.openxmlformats.org/officeDocument/2006/relationships" xmlns:a="http://schemas.openxmlformats.org/drawingml/2006/main" r:embed="R880d86c2c4a14d49"/>
+          <a:blip xmlns:r="http://schemas.openxmlformats.org/officeDocument/2006/relationships" xmlns:a="http://schemas.openxmlformats.org/drawingml/2006/main" r:embed="Rcf2f5bd3716648ae"/>
           <a:stretch xmlns:a="http://schemas.openxmlformats.org/drawingml/2006/main"/>
         </p:blipFill>
         <p:spPr>
@@ -18797,6 +19162,7 @@
           <a:lstStyle xmlns:a="http://schemas.openxmlformats.org/drawingml/2006/main"/>
           <a:p xmlns:a="http://schemas.openxmlformats.org/drawingml/2006/main">
             <a:pPr>
+              <a:buNone/>
               <a:defRPr sz="1500" b="0">
                 <a:solidFill>
                   <a:srgbClr val="475569"/>

</xml_diff>

<commit_message>
Align Lab 04 with group project and publish revised theory/practical slides
</commit_message>
<xml_diff>
--- a/slides/LAB04_Docker_Lifecycle_Praktikum.pptx
+++ b/slides/LAB04_Docker_Lifecycle_Praktikum.pptx
@@ -2,46 +2,46 @@
 <file path=ppt/presentation.xml><?xml version="1.0" encoding="utf-8"?>
 <p:presentation xmlns:p="http://schemas.openxmlformats.org/presentationml/2006/main">
   <p:sldMasterIdLst>
-    <p:sldMasterId xmlns:r="http://schemas.openxmlformats.org/officeDocument/2006/relationships" id="2147483648" r:id="Rf314c5979c064308"/>
+    <p:sldMasterId xmlns:r="http://schemas.openxmlformats.org/officeDocument/2006/relationships" id="2147483648" r:id="R417381603f694050"/>
   </p:sldMasterIdLst>
   <p:notesMasterIdLst>
-    <p:notesMasterId xmlns:r="http://schemas.openxmlformats.org/officeDocument/2006/relationships" r:id="Rbbc75658ca1d419e"/>
+    <p:notesMasterId xmlns:r="http://schemas.openxmlformats.org/officeDocument/2006/relationships" r:id="R6ce7dcfa722c404e"/>
   </p:notesMasterIdLst>
   <p:sldIdLst>
-    <p:sldId xmlns:r="http://schemas.openxmlformats.org/officeDocument/2006/relationships" id="256" r:id="R3fb846f785a148e1"/>
-    <p:sldId xmlns:r="http://schemas.openxmlformats.org/officeDocument/2006/relationships" id="257" r:id="R1a2b4ebcbc734cc7"/>
-    <p:sldId xmlns:r="http://schemas.openxmlformats.org/officeDocument/2006/relationships" id="258" r:id="R1ad9c074f4a24647"/>
-    <p:sldId xmlns:r="http://schemas.openxmlformats.org/officeDocument/2006/relationships" id="259" r:id="Rc985e02931c740fb"/>
-    <p:sldId xmlns:r="http://schemas.openxmlformats.org/officeDocument/2006/relationships" id="260" r:id="R5df025e6d6454125"/>
-    <p:sldId xmlns:r="http://schemas.openxmlformats.org/officeDocument/2006/relationships" id="261" r:id="R909754d3f35b4617"/>
-    <p:sldId xmlns:r="http://schemas.openxmlformats.org/officeDocument/2006/relationships" id="262" r:id="R559ef0478bb34492"/>
-    <p:sldId xmlns:r="http://schemas.openxmlformats.org/officeDocument/2006/relationships" id="263" r:id="R00624a3160ac4e1d"/>
-    <p:sldId xmlns:r="http://schemas.openxmlformats.org/officeDocument/2006/relationships" id="264" r:id="R57462168942048cb"/>
-    <p:sldId xmlns:r="http://schemas.openxmlformats.org/officeDocument/2006/relationships" id="265" r:id="Rca9c461151894729"/>
-    <p:sldId xmlns:r="http://schemas.openxmlformats.org/officeDocument/2006/relationships" id="266" r:id="R8d328a364e28476f"/>
-    <p:sldId xmlns:r="http://schemas.openxmlformats.org/officeDocument/2006/relationships" id="267" r:id="R4c25f59e0c6e4587"/>
-    <p:sldId xmlns:r="http://schemas.openxmlformats.org/officeDocument/2006/relationships" id="268" r:id="Rd68fb666b8f8439d"/>
-    <p:sldId xmlns:r="http://schemas.openxmlformats.org/officeDocument/2006/relationships" id="269" r:id="Rf68d9bbcc3cf472e"/>
-    <p:sldId xmlns:r="http://schemas.openxmlformats.org/officeDocument/2006/relationships" id="270" r:id="R623787710025415a"/>
-    <p:sldId xmlns:r="http://schemas.openxmlformats.org/officeDocument/2006/relationships" id="271" r:id="R876f2431d34440fc"/>
-    <p:sldId xmlns:r="http://schemas.openxmlformats.org/officeDocument/2006/relationships" id="272" r:id="Re1802c7a32f4404d"/>
-    <p:sldId xmlns:r="http://schemas.openxmlformats.org/officeDocument/2006/relationships" id="273" r:id="R2ea8e52fbc2e4138"/>
-    <p:sldId xmlns:r="http://schemas.openxmlformats.org/officeDocument/2006/relationships" id="274" r:id="R4f94c47063b04440"/>
-    <p:sldId xmlns:r="http://schemas.openxmlformats.org/officeDocument/2006/relationships" id="275" r:id="Rd5e3614a2e244fee"/>
-    <p:sldId xmlns:r="http://schemas.openxmlformats.org/officeDocument/2006/relationships" id="276" r:id="R359cf016ff2442e3"/>
-    <p:sldId xmlns:r="http://schemas.openxmlformats.org/officeDocument/2006/relationships" id="277" r:id="R0f50644261004833"/>
-    <p:sldId xmlns:r="http://schemas.openxmlformats.org/officeDocument/2006/relationships" id="278" r:id="Rcf51cddfb8c24e73"/>
-    <p:sldId xmlns:r="http://schemas.openxmlformats.org/officeDocument/2006/relationships" id="279" r:id="Rd8b584e59b62456f"/>
-    <p:sldId xmlns:r="http://schemas.openxmlformats.org/officeDocument/2006/relationships" id="280" r:id="R2cd6fe28d52a4f67"/>
-    <p:sldId xmlns:r="http://schemas.openxmlformats.org/officeDocument/2006/relationships" id="281" r:id="R47acbfcf326842c0"/>
-    <p:sldId xmlns:r="http://schemas.openxmlformats.org/officeDocument/2006/relationships" id="282" r:id="R4003b5934bce4cd0"/>
-    <p:sldId xmlns:r="http://schemas.openxmlformats.org/officeDocument/2006/relationships" id="283" r:id="Re2ef04826fb14d79"/>
-    <p:sldId xmlns:r="http://schemas.openxmlformats.org/officeDocument/2006/relationships" id="284" r:id="R28c37ebf75104058"/>
-    <p:sldId xmlns:r="http://schemas.openxmlformats.org/officeDocument/2006/relationships" id="285" r:id="R6c4a3fadd50146f1"/>
-    <p:sldId xmlns:r="http://schemas.openxmlformats.org/officeDocument/2006/relationships" id="286" r:id="Rbf4b33aa13034791"/>
-    <p:sldId xmlns:r="http://schemas.openxmlformats.org/officeDocument/2006/relationships" id="287" r:id="R6cd661a292344977"/>
-    <p:sldId xmlns:r="http://schemas.openxmlformats.org/officeDocument/2006/relationships" id="288" r:id="Rf816190ed03c4876"/>
-    <p:sldId xmlns:r="http://schemas.openxmlformats.org/officeDocument/2006/relationships" id="289" r:id="Rf8bc6818702b40e9"/>
+    <p:sldId xmlns:r="http://schemas.openxmlformats.org/officeDocument/2006/relationships" id="256" r:id="R5fe10666197246f3"/>
+    <p:sldId xmlns:r="http://schemas.openxmlformats.org/officeDocument/2006/relationships" id="257" r:id="R2024999d0c3a415a"/>
+    <p:sldId xmlns:r="http://schemas.openxmlformats.org/officeDocument/2006/relationships" id="258" r:id="R80718917642a4b91"/>
+    <p:sldId xmlns:r="http://schemas.openxmlformats.org/officeDocument/2006/relationships" id="259" r:id="Rffa55af134564acd"/>
+    <p:sldId xmlns:r="http://schemas.openxmlformats.org/officeDocument/2006/relationships" id="260" r:id="R1c0412674b7548e6"/>
+    <p:sldId xmlns:r="http://schemas.openxmlformats.org/officeDocument/2006/relationships" id="261" r:id="Re97257e5059b4916"/>
+    <p:sldId xmlns:r="http://schemas.openxmlformats.org/officeDocument/2006/relationships" id="262" r:id="Rc45a5a8228ec45e4"/>
+    <p:sldId xmlns:r="http://schemas.openxmlformats.org/officeDocument/2006/relationships" id="263" r:id="Rcc4942bfa8774aad"/>
+    <p:sldId xmlns:r="http://schemas.openxmlformats.org/officeDocument/2006/relationships" id="264" r:id="R239a3e3a28b647eb"/>
+    <p:sldId xmlns:r="http://schemas.openxmlformats.org/officeDocument/2006/relationships" id="265" r:id="Rb30084e2d866474f"/>
+    <p:sldId xmlns:r="http://schemas.openxmlformats.org/officeDocument/2006/relationships" id="266" r:id="R3fed3dcfd7064384"/>
+    <p:sldId xmlns:r="http://schemas.openxmlformats.org/officeDocument/2006/relationships" id="267" r:id="R7795c5d88e154d93"/>
+    <p:sldId xmlns:r="http://schemas.openxmlformats.org/officeDocument/2006/relationships" id="268" r:id="R03a7a959c68f41cb"/>
+    <p:sldId xmlns:r="http://schemas.openxmlformats.org/officeDocument/2006/relationships" id="269" r:id="Ra97847d1f89c4249"/>
+    <p:sldId xmlns:r="http://schemas.openxmlformats.org/officeDocument/2006/relationships" id="270" r:id="R5420e5a74d494293"/>
+    <p:sldId xmlns:r="http://schemas.openxmlformats.org/officeDocument/2006/relationships" id="271" r:id="R94d0b4ac529a4f11"/>
+    <p:sldId xmlns:r="http://schemas.openxmlformats.org/officeDocument/2006/relationships" id="272" r:id="Rab42fde6816b4b58"/>
+    <p:sldId xmlns:r="http://schemas.openxmlformats.org/officeDocument/2006/relationships" id="273" r:id="R979e657ede7d4f18"/>
+    <p:sldId xmlns:r="http://schemas.openxmlformats.org/officeDocument/2006/relationships" id="274" r:id="R69eee632916741d2"/>
+    <p:sldId xmlns:r="http://schemas.openxmlformats.org/officeDocument/2006/relationships" id="275" r:id="R04e091da8d5946ec"/>
+    <p:sldId xmlns:r="http://schemas.openxmlformats.org/officeDocument/2006/relationships" id="276" r:id="Rad5ce613994049cd"/>
+    <p:sldId xmlns:r="http://schemas.openxmlformats.org/officeDocument/2006/relationships" id="277" r:id="R8dec5c1dffa84458"/>
+    <p:sldId xmlns:r="http://schemas.openxmlformats.org/officeDocument/2006/relationships" id="278" r:id="R1ce7a997d6b84b37"/>
+    <p:sldId xmlns:r="http://schemas.openxmlformats.org/officeDocument/2006/relationships" id="279" r:id="R21d33b6a7bf143c9"/>
+    <p:sldId xmlns:r="http://schemas.openxmlformats.org/officeDocument/2006/relationships" id="280" r:id="R7e8312eae3194101"/>
+    <p:sldId xmlns:r="http://schemas.openxmlformats.org/officeDocument/2006/relationships" id="281" r:id="R0e3988059b6e4c36"/>
+    <p:sldId xmlns:r="http://schemas.openxmlformats.org/officeDocument/2006/relationships" id="282" r:id="R02542edb455b41b2"/>
+    <p:sldId xmlns:r="http://schemas.openxmlformats.org/officeDocument/2006/relationships" id="283" r:id="R3c3a7a50f5a7437a"/>
+    <p:sldId xmlns:r="http://schemas.openxmlformats.org/officeDocument/2006/relationships" id="284" r:id="R856e5767e13d4d86"/>
+    <p:sldId xmlns:r="http://schemas.openxmlformats.org/officeDocument/2006/relationships" id="285" r:id="Rd5e12ef1341c4106"/>
+    <p:sldId xmlns:r="http://schemas.openxmlformats.org/officeDocument/2006/relationships" id="286" r:id="R432f30c47e2d4d52"/>
+    <p:sldId xmlns:r="http://schemas.openxmlformats.org/officeDocument/2006/relationships" id="287" r:id="R40516aecb896416e"/>
+    <p:sldId xmlns:r="http://schemas.openxmlformats.org/officeDocument/2006/relationships" id="288" r:id="R91067db54b3545a7"/>
+    <p:sldId xmlns:r="http://schemas.openxmlformats.org/officeDocument/2006/relationships" id="289" r:id="R39dabe6ea6b64704"/>
   </p:sldIdLst>
   <p:sldSz cx="12192000" cy="6858000"/>
   <p:notesSz cx="6858000" cy="9144000"/>
@@ -2849,7 +2849,7 @@
   </p:cSld>
   <p:clrMap bg1="lt1" tx1="dk1" bg2="lt2" tx2="dk2" accent1="accent1" accent2="accent2" accent3="accent3" accent4="accent4" accent5="accent5" accent6="accent6" hlink="hlink" folHlink="folHlink"/>
   <p:sldLayoutIdLst>
-    <p:sldLayoutId xmlns:r="http://schemas.openxmlformats.org/officeDocument/2006/relationships" id="2147483649" r:id="R9127e58684434d47"/>
+    <p:sldLayoutId xmlns:r="http://schemas.openxmlformats.org/officeDocument/2006/relationships" id="2147483649" r:id="Rf592ec03e10f4872"/>
   </p:sldLayoutIdLst>
   <p:txStyles>
     <p:titleStyle>
@@ -4458,7 +4458,7 @@
           <p:nvPr/>
         </p:nvPicPr>
         <p:blipFill>
-          <a:blip xmlns:r="http://schemas.openxmlformats.org/officeDocument/2006/relationships" xmlns:a="http://schemas.openxmlformats.org/drawingml/2006/main" r:embed="Rbe1eaa664d214410"/>
+          <a:blip xmlns:r="http://schemas.openxmlformats.org/officeDocument/2006/relationships" xmlns:a="http://schemas.openxmlformats.org/drawingml/2006/main" r:embed="R2e423f0c9fc04d8b"/>
           <a:srcRect xmlns:a="http://schemas.openxmlformats.org/drawingml/2006/main" l="0" t="18218" r="0" b="18218"/>
           <a:stretch xmlns:a="http://schemas.openxmlformats.org/drawingml/2006/main">
             <a:fillRect l="0" t="0" r="0" b="0"/>
@@ -5411,7 +5411,7 @@
           <p:nvPr/>
         </p:nvPicPr>
         <p:blipFill>
-          <a:blip xmlns:r="http://schemas.openxmlformats.org/officeDocument/2006/relationships" xmlns:a="http://schemas.openxmlformats.org/drawingml/2006/main" r:embed="R205383b6628d4deb"/>
+          <a:blip xmlns:r="http://schemas.openxmlformats.org/officeDocument/2006/relationships" xmlns:a="http://schemas.openxmlformats.org/drawingml/2006/main" r:embed="R9e07f8e1bcce4c98"/>
           <a:stretch xmlns:a="http://schemas.openxmlformats.org/drawingml/2006/main"/>
         </p:blipFill>
         <p:spPr>
@@ -6361,7 +6361,7 @@
           <p:nvPr/>
         </p:nvPicPr>
         <p:blipFill>
-          <a:blip xmlns:r="http://schemas.openxmlformats.org/officeDocument/2006/relationships" xmlns:a="http://schemas.openxmlformats.org/drawingml/2006/main" r:embed="Rbbc63cc51edc4176"/>
+          <a:blip xmlns:r="http://schemas.openxmlformats.org/officeDocument/2006/relationships" xmlns:a="http://schemas.openxmlformats.org/drawingml/2006/main" r:embed="Re9bfa5650d004932"/>
           <a:srcRect xmlns:a="http://schemas.openxmlformats.org/drawingml/2006/main" l="0" t="19234" r="0" b="19234"/>
           <a:stretch xmlns:a="http://schemas.openxmlformats.org/drawingml/2006/main">
             <a:fillRect l="0" t="0" r="0" b="0"/>
@@ -6705,7 +6705,7 @@
           <p:nvPr/>
         </p:nvPicPr>
         <p:blipFill>
-          <a:blip xmlns:r="http://schemas.openxmlformats.org/officeDocument/2006/relationships" xmlns:a="http://schemas.openxmlformats.org/drawingml/2006/main" r:embed="Rae9616e58ad0411e"/>
+          <a:blip xmlns:r="http://schemas.openxmlformats.org/officeDocument/2006/relationships" xmlns:a="http://schemas.openxmlformats.org/drawingml/2006/main" r:embed="R93e113835f934be1"/>
           <a:srcRect xmlns:a="http://schemas.openxmlformats.org/drawingml/2006/main" l="0" t="18218" r="0" b="18218"/>
           <a:stretch xmlns:a="http://schemas.openxmlformats.org/drawingml/2006/main">
             <a:fillRect l="0" t="0" r="0" b="0"/>
@@ -7658,7 +7658,7 @@
           <p:nvPr/>
         </p:nvPicPr>
         <p:blipFill>
-          <a:blip xmlns:r="http://schemas.openxmlformats.org/officeDocument/2006/relationships" xmlns:a="http://schemas.openxmlformats.org/drawingml/2006/main" r:embed="R204fc7d49f764734"/>
+          <a:blip xmlns:r="http://schemas.openxmlformats.org/officeDocument/2006/relationships" xmlns:a="http://schemas.openxmlformats.org/drawingml/2006/main" r:embed="R7def2e5ff73d4ffb"/>
           <a:srcRect xmlns:a="http://schemas.openxmlformats.org/drawingml/2006/main" l="0" t="19234" r="0" b="19234"/>
           <a:stretch xmlns:a="http://schemas.openxmlformats.org/drawingml/2006/main">
             <a:fillRect l="0" t="0" r="0" b="0"/>
@@ -8002,7 +8002,7 @@
           <p:nvPr/>
         </p:nvPicPr>
         <p:blipFill>
-          <a:blip xmlns:r="http://schemas.openxmlformats.org/officeDocument/2006/relationships" xmlns:a="http://schemas.openxmlformats.org/drawingml/2006/main" r:embed="Rdbb0ba1dcb4f4f67"/>
+          <a:blip xmlns:r="http://schemas.openxmlformats.org/officeDocument/2006/relationships" xmlns:a="http://schemas.openxmlformats.org/drawingml/2006/main" r:embed="R9fb36dacfb6b4fae"/>
           <a:srcRect xmlns:a="http://schemas.openxmlformats.org/drawingml/2006/main" l="0" t="18218" r="0" b="18218"/>
           <a:stretch xmlns:a="http://schemas.openxmlformats.org/drawingml/2006/main">
             <a:fillRect l="0" t="0" r="0" b="0"/>
@@ -8781,7 +8781,7 @@
           <p:nvPr/>
         </p:nvPicPr>
         <p:blipFill>
-          <a:blip xmlns:r="http://schemas.openxmlformats.org/officeDocument/2006/relationships" xmlns:a="http://schemas.openxmlformats.org/drawingml/2006/main" r:embed="Re099aeff32524606"/>
+          <a:blip xmlns:r="http://schemas.openxmlformats.org/officeDocument/2006/relationships" xmlns:a="http://schemas.openxmlformats.org/drawingml/2006/main" r:embed="R4da76e71447a4552"/>
           <a:stretch xmlns:a="http://schemas.openxmlformats.org/drawingml/2006/main"/>
         </p:blipFill>
         <p:spPr>
@@ -9779,7 +9779,7 @@
           <p:nvPr/>
         </p:nvPicPr>
         <p:blipFill>
-          <a:blip xmlns:r="http://schemas.openxmlformats.org/officeDocument/2006/relationships" xmlns:a="http://schemas.openxmlformats.org/drawingml/2006/main" r:embed="R4ef45ec04f5245af"/>
+          <a:blip xmlns:r="http://schemas.openxmlformats.org/officeDocument/2006/relationships" xmlns:a="http://schemas.openxmlformats.org/drawingml/2006/main" r:embed="R52659143bd9f427e"/>
           <a:srcRect xmlns:a="http://schemas.openxmlformats.org/drawingml/2006/main" l="0" t="19234" r="0" b="19234"/>
           <a:stretch xmlns:a="http://schemas.openxmlformats.org/drawingml/2006/main">
             <a:fillRect l="0" t="0" r="0" b="0"/>
@@ -10732,7 +10732,7 @@
           <p:nvPr/>
         </p:nvPicPr>
         <p:blipFill>
-          <a:blip xmlns:r="http://schemas.openxmlformats.org/officeDocument/2006/relationships" xmlns:a="http://schemas.openxmlformats.org/drawingml/2006/main" r:embed="Raa64c4a5086c4ef2"/>
+          <a:blip xmlns:r="http://schemas.openxmlformats.org/officeDocument/2006/relationships" xmlns:a="http://schemas.openxmlformats.org/drawingml/2006/main" r:embed="Rddaa865fa5904736"/>
           <a:stretch xmlns:a="http://schemas.openxmlformats.org/drawingml/2006/main"/>
         </p:blipFill>
         <p:spPr>
@@ -11073,7 +11073,7 @@
           <p:nvPr/>
         </p:nvPicPr>
         <p:blipFill>
-          <a:blip xmlns:r="http://schemas.openxmlformats.org/officeDocument/2006/relationships" xmlns:a="http://schemas.openxmlformats.org/drawingml/2006/main" r:embed="R8fa711a1b7bf4f6a"/>
+          <a:blip xmlns:r="http://schemas.openxmlformats.org/officeDocument/2006/relationships" xmlns:a="http://schemas.openxmlformats.org/drawingml/2006/main" r:embed="Rcce5138bf9dd4174"/>
           <a:stretch xmlns:a="http://schemas.openxmlformats.org/drawingml/2006/main"/>
         </p:blipFill>
         <p:spPr>
@@ -11414,7 +11414,7 @@
           <p:nvPr/>
         </p:nvPicPr>
         <p:blipFill>
-          <a:blip xmlns:r="http://schemas.openxmlformats.org/officeDocument/2006/relationships" xmlns:a="http://schemas.openxmlformats.org/drawingml/2006/main" r:embed="R9a58a3f3cbe34fd9"/>
+          <a:blip xmlns:r="http://schemas.openxmlformats.org/officeDocument/2006/relationships" xmlns:a="http://schemas.openxmlformats.org/drawingml/2006/main" r:embed="Ra4177aa4e8dc4619"/>
           <a:srcRect xmlns:a="http://schemas.openxmlformats.org/drawingml/2006/main" l="0" t="18218" r="0" b="18218"/>
           <a:stretch xmlns:a="http://schemas.openxmlformats.org/drawingml/2006/main">
             <a:fillRect l="0" t="0" r="0" b="0"/>
@@ -13141,7 +13141,7 @@
           <p:nvPr/>
         </p:nvPicPr>
         <p:blipFill>
-          <a:blip xmlns:r="http://schemas.openxmlformats.org/officeDocument/2006/relationships" xmlns:a="http://schemas.openxmlformats.org/drawingml/2006/main" r:embed="Rbeee3fc78be34558"/>
+          <a:blip xmlns:r="http://schemas.openxmlformats.org/officeDocument/2006/relationships" xmlns:a="http://schemas.openxmlformats.org/drawingml/2006/main" r:embed="R4f5c4edf52cc4bc7"/>
           <a:stretch xmlns:a="http://schemas.openxmlformats.org/drawingml/2006/main"/>
         </p:blipFill>
         <p:spPr>
@@ -14091,7 +14091,7 @@
           <p:nvPr/>
         </p:nvPicPr>
         <p:blipFill>
-          <a:blip xmlns:r="http://schemas.openxmlformats.org/officeDocument/2006/relationships" xmlns:a="http://schemas.openxmlformats.org/drawingml/2006/main" r:embed="Re9d730fdad4147bb"/>
+          <a:blip xmlns:r="http://schemas.openxmlformats.org/officeDocument/2006/relationships" xmlns:a="http://schemas.openxmlformats.org/drawingml/2006/main" r:embed="R04aadc398f7e4307"/>
           <a:stretch xmlns:a="http://schemas.openxmlformats.org/drawingml/2006/main"/>
         </p:blipFill>
         <p:spPr>
@@ -15530,7 +15530,7 @@
                 <a:ea typeface="Calibri"/>
                 <a:cs typeface="Calibri"/>
               </a:rPr>
-              <a:t>Simpan hasil sendiri di repo mahasiswa; hapus hanya dua container latihan.</a:t>
+              <a:t>Simpan hasil sendiri bila membantu proyek; hapus hanya dua container latihan.</a:t>
             </a:r>
           </a:p>
         </p:txBody>
@@ -15878,7 +15878,7 @@
                 <a:ea typeface="Calibri"/>
                 <a:cs typeface="Calibri"/>
               </a:rPr>
-              <a:t>Kumpulkan</a:t>
+              <a:t>Catatan opsional</a:t>
             </a:r>
           </a:p>
         </p:txBody>
@@ -15912,7 +15912,7 @@
         </p:spPr>
         <p:txBody>
           <a:bodyPr xmlns:a="http://schemas.openxmlformats.org/drawingml/2006/main" wrap="square" lIns="0" tIns="0" rIns="0" bIns="0" anchor="t">
-            <a:normAutofit fontScale="69376"/>
+            <a:normAutofit fontScale="99050"/>
           </a:bodyPr>
           <a:lstStyle xmlns:a="http://schemas.openxmlformats.org/drawingml/2006/main"/>
           <a:p xmlns:a="http://schemas.openxmlformats.org/drawingml/2006/main">
@@ -15936,7 +15936,7 @@
                 <a:ea typeface="Calibri"/>
                 <a:cs typeface="Calibri"/>
               </a:rPr>
-              <a:t>Catat gejala, diagnosis, perintah pemulihan, HTTP 200, pesan INCIDENT-042, serta hasil A–E. Screenshot modul adalah contoh; bukti mahasiswa berasal dari run mereka sendiri.</a:t>
+              <a:t>Catat gejala, diagnosis, pemulihan, HTTP 200, dan hasil A-E bila berguna untuk proyek. Lab 04 tidak dikumpulkan tersendiri.</a:t>
             </a:r>
           </a:p>
         </p:txBody>
@@ -16262,7 +16262,7 @@
           <p:nvPr/>
         </p:nvPicPr>
         <p:blipFill>
-          <a:blip xmlns:r="http://schemas.openxmlformats.org/officeDocument/2006/relationships" xmlns:a="http://schemas.openxmlformats.org/drawingml/2006/main" r:embed="Raed366157c784b54"/>
+          <a:blip xmlns:r="http://schemas.openxmlformats.org/officeDocument/2006/relationships" xmlns:a="http://schemas.openxmlformats.org/drawingml/2006/main" r:embed="Rcaea19ab27034fa0"/>
           <a:stretch xmlns:a="http://schemas.openxmlformats.org/drawingml/2006/main">
             <a:fillRect l="0" t="0" r="0" b="0"/>
           </a:stretch>
@@ -17800,7 +17800,7 @@
           <p:nvPr/>
         </p:nvPicPr>
         <p:blipFill>
-          <a:blip xmlns:r="http://schemas.openxmlformats.org/officeDocument/2006/relationships" xmlns:a="http://schemas.openxmlformats.org/drawingml/2006/main" r:embed="Rea390dae4e264aa6"/>
+          <a:blip xmlns:r="http://schemas.openxmlformats.org/officeDocument/2006/relationships" xmlns:a="http://schemas.openxmlformats.org/drawingml/2006/main" r:embed="R5ff1f81bb06e4b8c"/>
           <a:stretch xmlns:a="http://schemas.openxmlformats.org/drawingml/2006/main"/>
         </p:blipFill>
         <p:spPr>
@@ -18774,7 +18774,7 @@
           <p:nvPr/>
         </p:nvPicPr>
         <p:blipFill>
-          <a:blip xmlns:r="http://schemas.openxmlformats.org/officeDocument/2006/relationships" xmlns:a="http://schemas.openxmlformats.org/drawingml/2006/main" r:embed="R22f9e8d1dfb54e9d"/>
+          <a:blip xmlns:r="http://schemas.openxmlformats.org/officeDocument/2006/relationships" xmlns:a="http://schemas.openxmlformats.org/drawingml/2006/main" r:embed="R935658217b544152"/>
           <a:stretch xmlns:a="http://schemas.openxmlformats.org/drawingml/2006/main"/>
         </p:blipFill>
         <p:spPr>
@@ -19115,7 +19115,7 @@
           <p:nvPr/>
         </p:nvPicPr>
         <p:blipFill>
-          <a:blip xmlns:r="http://schemas.openxmlformats.org/officeDocument/2006/relationships" xmlns:a="http://schemas.openxmlformats.org/drawingml/2006/main" r:embed="Rcf2f5bd3716648ae"/>
+          <a:blip xmlns:r="http://schemas.openxmlformats.org/officeDocument/2006/relationships" xmlns:a="http://schemas.openxmlformats.org/drawingml/2006/main" r:embed="Rc9f406b313374f11"/>
           <a:stretch xmlns:a="http://schemas.openxmlformats.org/drawingml/2006/main"/>
         </p:blipFill>
         <p:spPr>

</xml_diff>